<commit_message>
Slides 27: custo-hora alinhado à planilha 05
Co-Authored-By: Claude Fable 5.1 <noreply@anthropic.com>
Claude-Session: https://claude.ai/code/session_0146uBo6FVJ2cyEehyP8rK61
</commit_message>
<xml_diff>
--- a/projetos/gestao-ia-planilhas/produto/kit-advogados/27-modelo-resultado-do-mes-8-slides.pptx
+++ b/projetos/gestao-ia-planilhas/produto/kit-advogados/27-modelo-resultado-do-mes-8-slides.pptx
@@ -203,7 +203,7 @@
                   <c:v>117</c:v>
                 </c:pt>
                 <c:pt idx="2">
-                  <c:v>84</c:v>
+                  <c:v>73</c:v>
                 </c:pt>
               </c:numCache>
             </c:numRef>
@@ -7150,7 +7150,7 @@
                 <a:ea typeface="Arial" pitchFamily="34" charset="-122"/>
                 <a:cs typeface="Arial" pitchFamily="34" charset="-120"/>
               </a:rPr>
-              <a:t>Custo-hora de R$ 84 = (custo fixo + pró-labore) ÷ 220 horas faturáveis dos sócios.</a:t>
+              <a:t>Custo-hora dos sócios de R$ 73, calculado na planilha 05 (custo direto + rateio dos fixos ÷ horas faturáveis).</a:t>
             </a:r>
             <a:endParaRPr lang="en-US" sz="1050" dirty="0"/>
           </a:p>

</xml_diff>

<commit_message>
Kit Advogados: documentos 21–26, slides 27–29 e LEIA-ME alinhados a NUMEROS.md (agosto fechado, régua da 14, NF obrigatória, marca só no mestre, manual com 20 planilhas em 4 semanas e aulas certas, txt limpos)
Co-Authored-By: Claude Fable 5.1 <noreply@anthropic.com>
Claude-Session: https://claude.ai/code/session_0146uBo6FVJ2cyEehyP8rK61
</commit_message>
<xml_diff>
--- a/projetos/gestao-ia-planilhas/produto/kit-advogados/27-modelo-resultado-do-mes-8-slides.pptx
+++ b/projetos/gestao-ia-planilhas/produto/kit-advogados/27-modelo-resultado-do-mes-8-slides.pptx
@@ -135,7 +135,7 @@
               <c:strCache>
                 <c:ptCount val="1"/>
                 <c:pt idx="0">
-                  <c:v>R$ por hora faturável</c:v>
+                  <c:v>Horas faturáveis em agosto</c:v>
                 </c:pt>
               </c:strCache>
             </c:strRef>
@@ -148,13 +148,13 @@
           </c:spPr>
           <c:invertIfNegative val="0"/>
           <c:dLbls>
-            <c:numFmt formatCode="&quot;R$ &quot;0" sourceLinked="0"/>
+            <c:numFmt formatCode="0" sourceLinked="0"/>
             <c:txPr>
               <a:bodyPr/>
               <a:lstStyle/>
               <a:p>
                 <a:pPr>
-                  <a:defRPr b="0" i="0" strike="noStrike" sz="1000" u="none">
+                  <a:defRPr b="0" i="0" strike="noStrike" sz="900" u="none">
                     <a:solidFill>
                       <a:srgbClr val="1F1235"/>
                     </a:solidFill>
@@ -184,7 +184,7 @@
                     <c:v>Rafael Lima</c:v>
                   </c:pt>
                   <c:pt idx="2">
-                    <c:v>Custo-hora do escritório</c:v>
+                    <c:v>Júlia Prado</c:v>
                   </c:pt>
                 </c:lvl>
               </c:multiLvlStrCache>
@@ -197,26 +197,109 @@
                 <c:formatCode>General</c:formatCode>
                 <c:ptCount val="3"/>
                 <c:pt idx="0">
-                  <c:v>199</c:v>
+                  <c:v>101.5</c:v>
                 </c:pt>
                 <c:pt idx="1">
-                  <c:v>117</c:v>
+                  <c:v>88</c:v>
                 </c:pt>
                 <c:pt idx="2">
-                  <c:v>73</c:v>
+                  <c:v>58.5</c:v>
+                </c:pt>
+              </c:numCache>
+            </c:numRef>
+          </c:val>
+        </c:ser>
+        <c:ser>
+          <c:idx val="1"/>
+          <c:order val="1"/>
+          <c:tx>
+            <c:strRef>
+              <c:f>Sheet1!$C$1</c:f>
+              <c:strCache>
+                <c:ptCount val="1"/>
+                <c:pt idx="0">
+                  <c:v>Meta de faturáveis por mês</c:v>
+                </c:pt>
+              </c:strCache>
+            </c:strRef>
+          </c:tx>
+          <c:spPr>
+            <a:solidFill>
+              <a:srgbClr val="B89BE0"/>
+            </a:solidFill>
+            <a:effectLst/>
+          </c:spPr>
+          <c:invertIfNegative val="0"/>
+          <c:dLbls>
+            <c:numFmt formatCode="0" sourceLinked="0"/>
+            <c:txPr>
+              <a:bodyPr/>
+              <a:lstStyle/>
+              <a:p>
+                <a:pPr>
+                  <a:defRPr b="0" i="0" strike="noStrike" sz="900" u="none">
+                    <a:solidFill>
+                      <a:srgbClr val="1F1235"/>
+                    </a:solidFill>
+                    <a:latin typeface="Arial"/>
+                  </a:defRPr>
+                </a:pPr>
+              </a:p>
+            </c:txPr>
+            <c:showLegendKey val="0"/>
+            <c:showVal val="1"/>
+            <c:showCatName val="0"/>
+            <c:showSerName val="0"/>
+            <c:showPercent val="0"/>
+            <c:showBubbleSize val="0"/>
+            <c:showLeaderLines val="0"/>
+          </c:dLbls>
+          <c:cat>
+            <c:multiLvlStrRef>
+              <c:f>Sheet1!$A$2:$A$4</c:f>
+              <c:multiLvlStrCache>
+                <c:ptCount val="3"/>
+                <c:lvl>
+                  <c:pt idx="0">
+                    <c:v>Marina Ferraz</c:v>
+                  </c:pt>
+                  <c:pt idx="1">
+                    <c:v>Rafael Lima</c:v>
+                  </c:pt>
+                  <c:pt idx="2">
+                    <c:v>Júlia Prado</c:v>
+                  </c:pt>
+                </c:lvl>
+              </c:multiLvlStrCache>
+            </c:multiLvlStrRef>
+          </c:cat>
+          <c:val>
+            <c:numRef>
+              <c:f>Sheet1!$C$2:$C$4</c:f>
+              <c:numCache>
+                <c:formatCode>General</c:formatCode>
+                <c:ptCount val="3"/>
+                <c:pt idx="0">
+                  <c:v>110</c:v>
+                </c:pt>
+                <c:pt idx="1">
+                  <c:v>110</c:v>
+                </c:pt>
+                <c:pt idx="2">
+                  <c:v>60</c:v>
                 </c:pt>
               </c:numCache>
             </c:numRef>
           </c:val>
         </c:ser>
         <c:dLbls>
-          <c:numFmt formatCode="&quot;R$ &quot;0" sourceLinked="0"/>
+          <c:numFmt formatCode="0" sourceLinked="0"/>
           <c:txPr>
             <a:bodyPr/>
             <a:lstStyle/>
             <a:p>
               <a:pPr>
-                <a:defRPr b="0" i="0" strike="noStrike" sz="1000" u="none">
+                <a:defRPr b="0" i="0" strike="noStrike" sz="900" u="none">
                   <a:solidFill>
                     <a:srgbClr val="1F1235"/>
                   </a:solidFill>
@@ -284,7 +367,7 @@
         <c:axId val="2094734552"/>
         <c:scaling>
           <c:orientation val="minMax"/>
-          <c:max val="240"/>
+          <c:max val="130"/>
           <c:min val="0"/>
         </c:scaling>
         <c:delete val="0"/>
@@ -340,6 +423,20 @@
         <a:effectLst/>
       </c:spPr>
     </c:plotArea>
+    <c:legend>
+      <c:legendPos val="b"/>
+      <c:overlay val="0"/>
+      <c:txPr>
+        <a:bodyPr/>
+        <a:lstStyle/>
+        <a:p>
+          <a:pPr>
+            <a:defRPr sz="900">      </a:defRPr>
+          </a:pPr>
+          <a:endParaRPr lang="en-US"/>
+        </a:p>
+      </c:txPr>
+    </c:legend>
     <c:plotVisOnly val="1"/>
     <c:dispBlanksAs val="span"/>
   </c:chart>
@@ -420,13 +517,13 @@
                 <c:ptCount val="3"/>
                 <c:lvl>
                   <c:pt idx="0">
+                    <c:v>Junho</c:v>
+                  </c:pt>
+                  <c:pt idx="1">
                     <c:v>Julho</c:v>
                   </c:pt>
-                  <c:pt idx="1">
+                  <c:pt idx="2">
                     <c:v>Agosto</c:v>
-                  </c:pt>
-                  <c:pt idx="2">
-                    <c:v>Setembro</c:v>
                   </c:pt>
                 </c:lvl>
               </c:multiLvlStrCache>
@@ -439,13 +536,13 @@
                 <c:formatCode>General</c:formatCode>
                 <c:ptCount val="3"/>
                 <c:pt idx="0">
-                  <c:v>23800</c:v>
+                  <c:v>27420</c:v>
                 </c:pt>
                 <c:pt idx="1">
-                  <c:v>27900</c:v>
+                  <c:v>29460</c:v>
                 </c:pt>
                 <c:pt idx="2">
-                  <c:v>29400</c:v>
+                  <c:v>26900</c:v>
                 </c:pt>
               </c:numCache>
             </c:numRef>
@@ -503,13 +600,13 @@
                 <c:ptCount val="3"/>
                 <c:lvl>
                   <c:pt idx="0">
+                    <c:v>Junho</c:v>
+                  </c:pt>
+                  <c:pt idx="1">
                     <c:v>Julho</c:v>
                   </c:pt>
-                  <c:pt idx="1">
+                  <c:pt idx="2">
                     <c:v>Agosto</c:v>
-                  </c:pt>
-                  <c:pt idx="2">
-                    <c:v>Setembro</c:v>
                   </c:pt>
                 </c:lvl>
               </c:multiLvlStrCache>
@@ -522,13 +619,13 @@
                 <c:formatCode>General</c:formatCode>
                 <c:ptCount val="3"/>
                 <c:pt idx="0">
-                  <c:v>19888</c:v>
+                  <c:v>23085</c:v>
                 </c:pt>
                 <c:pt idx="1">
-                  <c:v>20064</c:v>
+                  <c:v>28898</c:v>
                 </c:pt>
                 <c:pt idx="2">
-                  <c:v>20179</c:v>
+                  <c:v>21897</c:v>
                 </c:pt>
               </c:numCache>
             </c:numRef>
@@ -1090,7 +1187,7 @@
           <a:p>
             <a:r>
               <a:rPr lang="en-US" dirty="0"/>
-              <a:t>Modelo do Kit de Gestão para Advogados: troque os textos e mantenha a estrutura. Capa. A frase em itálico é a conclusão do mês em uma linha: escreva por último, depois de montar os outros slides. Os números vêm do Painel do escritório (planilha 17, aba Histórico), do Caixa (09) e da Carteira (13). O prompt "Explicar o mês" ajuda a escrever a frase.</a:t>
+              <a:t>Kit de Gestão para Advogados · modelo v1.0 · set/2026 · Modelo do Kit de Gestão para Advogados (v1.0, set/2026): troque os textos e mantenha a estrutura. O símbolo do canto está no slide mestre (Exibir &gt; Slide mestre): apague lá uma vez e some de todos. Capa. A frase em itálico é a conclusão do mês em uma linha: escreva por último, depois de montar os outros slides. Os números vêm do Resultado mensal (18, Config = Agosto), do Caixa (09), das Horas (16) e da Carteira (13); a posição de prazos e parcelas é a de hoje (01 e 14). O prompt "Painel 01 · Explicar o mês ao sócio" ajuda a escrever a frase.</a:t>
             </a:r>
             <a:endParaRPr lang="en-US" dirty="0"/>
           </a:p>
@@ -1178,7 +1275,7 @@
           <a:p>
             <a:r>
               <a:rPr lang="en-US" dirty="0"/>
-              <a:t>Resumo. Três números: o que entrou, o que sobrou e o que ainda vai entrar. O card destacado é o resultado. Diga o número ruim junto com o bom.</a:t>
+              <a:t>Kit de Gestão para Advogados · modelo v1.0 · set/2026 · Resumo. Três números: o que entrou, o que sobrou e o que ainda vai entrar. O card destacado é o resultado. Diga o número ruim junto com o bom. O resultado da DRE (18) não é o que sobrou no caixa (09: R$ 5.003): a DRE provisiona 8 % de impostos em vez da guia paga e deixa fora as despesas pessoais dos sócios (11).</a:t>
             </a:r>
             <a:endParaRPr lang="en-US" dirty="0"/>
           </a:p>
@@ -1266,7 +1363,7 @@
           <a:p>
             <a:r>
               <a:rPr lang="en-US" dirty="0"/>
-              <a:t>Prazos. Sete atrasados é o pior número do ano (o histórico do painel mostra 3, 2, 4, 1, 5, 6, 4, 5, 7). Não discuta caso a caso aqui: a lista com número do processo está na Agenda de prazos. Aqui a pergunta é: o que muda na rotina de segunda?</a:t>
+              <a:t>Kit de Gestão para Advogados · modelo v1.0 · set/2026 · Prazos. Sete atrasados, quatro deles vencidos entre sexta e domingo: o que a rotina de sexta deixou passar. Não discuta caso a caso aqui: a lista com número do processo está na Agenda de prazos. A pergunta é: o que muda na rotina de segunda? A Júlia responde pelas juntadas de documentos; os casos continuam com o sócio.</a:t>
             </a:r>
             <a:endParaRPr lang="en-US" dirty="0"/>
           </a:p>
@@ -1354,7 +1451,7 @@
           <a:p>
             <a:r>
               <a:rPr lang="en-US" dirty="0"/>
-              <a:t>Horas por pessoa vêm da planilha 16 (Horas por caso e por pessoa); o "entrou" por sócio, do Caixa (09) filtrado por responsável do caso. Clique no gráfico &gt; Editar dados para trocar os valores. A estagiária não fatura direto, por isso os traços.</a:t>
+              <a:t>Kit de Gestão para Advogados · modelo v1.0 · set/2026 · Horas por pessoa vêm da planilha 16 (Painel, Config = Agosto); custo-hora e hora mínima, da 05. Clique no gráfico &gt; Editar dados para trocar os valores. Os sócios ficaram perto ou acima da meta de 110 h faturáveis: o gargalo é agenda, não demanda.</a:t>
             </a:r>
             <a:endParaRPr lang="en-US" dirty="0"/>
           </a:p>
@@ -1442,7 +1539,7 @@
           <a:p>
             <a:r>
               <a:rPr lang="en-US" dirty="0"/>
-              <a:t>Caixa. Gráfico de colunas nativo: Entrou e Saiu por mês; a diferença é o que sobrou. Os três meses vêm da aba Histórico do painel. Se o mês fechou negativo, diga primeiro e explique por quê.</a:t>
+              <a:t>Kit de Gestão para Advogados · modelo v1.0 · set/2026 · Caixa. Gráfico de colunas nativo: Entrou e Saiu por mês; a diferença é o que sobrou. Os três meses vêm do Painel mensal do Caixa (09) ou da aba Histórico do painel (17). Se o mês fechou negativo, diga primeiro e explique por quê.</a:t>
             </a:r>
             <a:endParaRPr lang="en-US" dirty="0"/>
           </a:p>
@@ -1530,7 +1627,7 @@
           <a:p>
             <a:r>
               <a:rPr lang="en-US" dirty="0"/>
-              <a:t>Recebíveis. Separe sempre o que está vencido do que é êxito: êxito sem data não é inadimplência. Se quiser, acrescente a lista dos cinco maiores vencidos da planilha 14.</a:t>
+              <a:t>Kit de Gestão para Advogados · modelo v1.0 · set/2026 · Recebíveis. Separe sempre o que está vencido do que é êxito: êxito sem data não é inadimplência. Inadimplência = vencido ÷ (pago + vencido), a mesma conta em todo o kit. A lista "Cobrar primeiro" da planilha 14 ordena por valor × dias de atraso.</a:t>
             </a:r>
             <a:endParaRPr lang="en-US" dirty="0"/>
           </a:p>
@@ -1618,7 +1715,7 @@
           <a:p>
             <a:r>
               <a:rPr lang="en-US" dirty="0"/>
-              <a:t>Decisões. Só o que precisa de sim ou não dos sócios, com valor e prazo. No máximo três: mais que isso vira discussão sem fim.</a:t>
+              <a:t>Kit de Gestão para Advogados · modelo v1.0 · set/2026 · Decisões. Só o que precisa de sim ou não dos sócios, com valor e prazo. No máximo três: mais que isso vira discussão sem fim.</a:t>
             </a:r>
             <a:endParaRPr lang="en-US" dirty="0"/>
           </a:p>
@@ -1706,7 +1803,7 @@
           <a:p>
             <a:r>
               <a:rPr lang="en-US" dirty="0"/>
-              <a:t>Próximos passos. Copie para a rotina da semana (planilha 03) e confira na próxima reunião o que foi feito. Não termine com "obrigado": termine com a data da próxima reunião.</a:t>
+              <a:t>Kit de Gestão para Advogados · modelo v1.0 · set/2026 · Próximos passos. Copie para a rotina da semana (planilha 03) e confira na próxima reunião o que foi feito. Não termine com "obrigado": termine com a data da próxima reunião.</a:t>
             </a:r>
             <a:endParaRPr lang="en-US" dirty="0"/>
           </a:p>
@@ -1778,6 +1875,286 @@
 </p:sldLayout>
 </file>
 
+<file path=ppt/slideLayouts/slideLayout2.xml><?xml version="1.0" encoding="utf-8"?>
+<p:sldLayout xmlns:a="http://schemas.openxmlformats.org/drawingml/2006/main" xmlns:r="http://schemas.openxmlformats.org/officeDocument/2006/relationships" xmlns:p="http://schemas.openxmlformats.org/presentationml/2006/main" preserve="1">
+  <p:cSld name="CLARO">
+    <p:bg>
+      <p:bgPr>
+        <a:solidFill>
+          <a:srgbClr val="FFFFFF"/>
+        </a:solidFill>
+      </p:bgPr>
+    </p:bg>
+    <p:spTree>
+      <p:nvGrpSpPr>
+        <p:cNvPr id="1" name=""/>
+        <p:cNvGrpSpPr/>
+        <p:nvPr/>
+      </p:nvGrpSpPr>
+      <p:grpSpPr>
+        <a:xfrm>
+          <a:off x="0" y="0"/>
+          <a:ext cx="0" cy="0"/>
+          <a:chOff x="0" y="0"/>
+          <a:chExt cx="0" cy="0"/>
+        </a:xfrm>
+      </p:grpSpPr>
+      <p:sp>
+        <p:nvSpPr>
+          <p:cNvPr id="2" name="Shape 0"/>
+          <p:cNvSpPr/>
+          <p:nvPr/>
+        </p:nvSpPr>
+        <p:spPr>
+          <a:xfrm>
+            <a:off x="8321040" y="4846320"/>
+            <a:ext cx="192024" cy="64008"/>
+          </a:xfrm>
+          <a:prstGeom prst="rect">
+            <a:avLst>
+              <a:gd name="adj" fmla="val 42857"/>
+            </a:avLst>
+          </a:prstGeom>
+          <a:solidFill>
+            <a:srgbClr val="7A5AA8"/>
+          </a:solidFill>
+          <a:ln w="12700">
+            <a:solidFill>
+              <a:srgbClr val="7A5AA8"/>
+            </a:solidFill>
+            <a:prstDash val="solid"/>
+          </a:ln>
+        </p:spPr>
+      </p:sp>
+      <p:sp>
+        <p:nvSpPr>
+          <p:cNvPr id="3" name="Shape 1"/>
+          <p:cNvSpPr/>
+          <p:nvPr/>
+        </p:nvSpPr>
+        <p:spPr>
+          <a:xfrm>
+            <a:off x="8366760" y="4764024"/>
+            <a:ext cx="192024" cy="64008"/>
+          </a:xfrm>
+          <a:prstGeom prst="rect">
+            <a:avLst>
+              <a:gd name="adj" fmla="val 42857"/>
+            </a:avLst>
+          </a:prstGeom>
+          <a:solidFill>
+            <a:srgbClr val="3B1F5E"/>
+          </a:solidFill>
+          <a:ln w="12700">
+            <a:solidFill>
+              <a:srgbClr val="3B1F5E"/>
+            </a:solidFill>
+            <a:prstDash val="solid"/>
+          </a:ln>
+        </p:spPr>
+      </p:sp>
+      <p:sp>
+        <p:nvSpPr>
+          <p:cNvPr id="4" name="Shape 2"/>
+          <p:cNvSpPr/>
+          <p:nvPr/>
+        </p:nvSpPr>
+        <p:spPr>
+          <a:xfrm>
+            <a:off x="8412480" y="4681728"/>
+            <a:ext cx="192024" cy="64008"/>
+          </a:xfrm>
+          <a:prstGeom prst="rect">
+            <a:avLst>
+              <a:gd name="adj" fmla="val 42857"/>
+            </a:avLst>
+          </a:prstGeom>
+          <a:solidFill>
+            <a:srgbClr val="3B1F5E"/>
+          </a:solidFill>
+          <a:ln w="12700">
+            <a:solidFill>
+              <a:srgbClr val="3B1F5E"/>
+            </a:solidFill>
+            <a:prstDash val="solid"/>
+          </a:ln>
+        </p:spPr>
+      </p:sp>
+      <p:sp>
+        <p:nvSpPr>
+          <p:cNvPr id="5" name="Shape 3"/>
+          <p:cNvSpPr/>
+          <p:nvPr/>
+        </p:nvSpPr>
+        <p:spPr>
+          <a:xfrm>
+            <a:off x="8604504" y="4864608"/>
+            <a:ext cx="59436" cy="59436"/>
+          </a:xfrm>
+          <a:prstGeom prst="rect">
+            <a:avLst>
+              <a:gd name="adj" fmla="val 50000"/>
+            </a:avLst>
+          </a:prstGeom>
+          <a:solidFill>
+            <a:srgbClr val="FFC83D"/>
+          </a:solidFill>
+          <a:ln w="12700">
+            <a:solidFill>
+              <a:srgbClr val="FFC83D"/>
+            </a:solidFill>
+            <a:prstDash val="solid"/>
+          </a:ln>
+        </p:spPr>
+      </p:sp>
+    </p:spTree>
+  </p:cSld>
+  <p:clrMapOvr>
+    <a:masterClrMapping/>
+  </p:clrMapOvr>
+</p:sldLayout>
+</file>
+
+<file path=ppt/slideLayouts/slideLayout3.xml><?xml version="1.0" encoding="utf-8"?>
+<p:sldLayout xmlns:a="http://schemas.openxmlformats.org/drawingml/2006/main" xmlns:r="http://schemas.openxmlformats.org/officeDocument/2006/relationships" xmlns:p="http://schemas.openxmlformats.org/presentationml/2006/main" preserve="1">
+  <p:cSld name="ESCURO">
+    <p:bg>
+      <p:bgPr>
+        <a:solidFill>
+          <a:srgbClr val="3B1F5E"/>
+        </a:solidFill>
+      </p:bgPr>
+    </p:bg>
+    <p:spTree>
+      <p:nvGrpSpPr>
+        <p:cNvPr id="1" name=""/>
+        <p:cNvGrpSpPr/>
+        <p:nvPr/>
+      </p:nvGrpSpPr>
+      <p:grpSpPr>
+        <a:xfrm>
+          <a:off x="0" y="0"/>
+          <a:ext cx="0" cy="0"/>
+          <a:chOff x="0" y="0"/>
+          <a:chExt cx="0" cy="0"/>
+        </a:xfrm>
+      </p:grpSpPr>
+      <p:sp>
+        <p:nvSpPr>
+          <p:cNvPr id="2" name="Shape 0"/>
+          <p:cNvSpPr/>
+          <p:nvPr/>
+        </p:nvSpPr>
+        <p:spPr>
+          <a:xfrm>
+            <a:off x="8321040" y="4846320"/>
+            <a:ext cx="192024" cy="64008"/>
+          </a:xfrm>
+          <a:prstGeom prst="rect">
+            <a:avLst>
+              <a:gd name="adj" fmla="val 42857"/>
+            </a:avLst>
+          </a:prstGeom>
+          <a:solidFill>
+            <a:srgbClr val="B89BE0"/>
+          </a:solidFill>
+          <a:ln w="12700">
+            <a:solidFill>
+              <a:srgbClr val="B89BE0"/>
+            </a:solidFill>
+            <a:prstDash val="solid"/>
+          </a:ln>
+        </p:spPr>
+      </p:sp>
+      <p:sp>
+        <p:nvSpPr>
+          <p:cNvPr id="3" name="Shape 1"/>
+          <p:cNvSpPr/>
+          <p:nvPr/>
+        </p:nvSpPr>
+        <p:spPr>
+          <a:xfrm>
+            <a:off x="8366760" y="4764024"/>
+            <a:ext cx="192024" cy="64008"/>
+          </a:xfrm>
+          <a:prstGeom prst="rect">
+            <a:avLst>
+              <a:gd name="adj" fmla="val 42857"/>
+            </a:avLst>
+          </a:prstGeom>
+          <a:solidFill>
+            <a:srgbClr val="FFFFFF"/>
+          </a:solidFill>
+          <a:ln w="12700">
+            <a:solidFill>
+              <a:srgbClr val="FFFFFF"/>
+            </a:solidFill>
+            <a:prstDash val="solid"/>
+          </a:ln>
+        </p:spPr>
+      </p:sp>
+      <p:sp>
+        <p:nvSpPr>
+          <p:cNvPr id="4" name="Shape 2"/>
+          <p:cNvSpPr/>
+          <p:nvPr/>
+        </p:nvSpPr>
+        <p:spPr>
+          <a:xfrm>
+            <a:off x="8412480" y="4681728"/>
+            <a:ext cx="192024" cy="64008"/>
+          </a:xfrm>
+          <a:prstGeom prst="rect">
+            <a:avLst>
+              <a:gd name="adj" fmla="val 42857"/>
+            </a:avLst>
+          </a:prstGeom>
+          <a:solidFill>
+            <a:srgbClr val="FFFFFF"/>
+          </a:solidFill>
+          <a:ln w="12700">
+            <a:solidFill>
+              <a:srgbClr val="FFFFFF"/>
+            </a:solidFill>
+            <a:prstDash val="solid"/>
+          </a:ln>
+        </p:spPr>
+      </p:sp>
+      <p:sp>
+        <p:nvSpPr>
+          <p:cNvPr id="5" name="Shape 3"/>
+          <p:cNvSpPr/>
+          <p:nvPr/>
+        </p:nvSpPr>
+        <p:spPr>
+          <a:xfrm>
+            <a:off x="8604504" y="4864608"/>
+            <a:ext cx="59436" cy="59436"/>
+          </a:xfrm>
+          <a:prstGeom prst="rect">
+            <a:avLst>
+              <a:gd name="adj" fmla="val 50000"/>
+            </a:avLst>
+          </a:prstGeom>
+          <a:solidFill>
+            <a:srgbClr val="FFC83D"/>
+          </a:solidFill>
+          <a:ln w="12700">
+            <a:solidFill>
+              <a:srgbClr val="FFC83D"/>
+            </a:solidFill>
+            <a:prstDash val="solid"/>
+          </a:ln>
+        </p:spPr>
+      </p:sp>
+    </p:spTree>
+  </p:cSld>
+  <p:clrMapOvr>
+    <a:masterClrMapping/>
+  </p:clrMapOvr>
+</p:sldLayout>
+</file>
+
 <file path=ppt/slideMasters/slideMaster1.xml><?xml version="1.0" encoding="utf-8"?>
 <p:sldMaster xmlns:a="http://schemas.openxmlformats.org/drawingml/2006/main" xmlns:r="http://schemas.openxmlformats.org/officeDocument/2006/relationships" xmlns:p="http://schemas.openxmlformats.org/presentationml/2006/main">
   <p:cSld>
@@ -1800,6 +2177,8 @@
   <p:clrMap bg1="lt1" tx1="dk1" bg2="lt2" tx2="dk2" accent1="accent1" accent2="accent2" accent3="accent3" accent4="accent4" accent5="accent5" accent6="accent6" hlink="hlink" folHlink="folHlink"/>
   <p:sldLayoutIdLst>
     <p:sldLayoutId id="2147483649" r:id="rId1"/>
+    <p:sldLayoutId id="2147483650" r:id="rId2"/>
+    <p:sldLayoutId id="2147483651" r:id="rId3"/>
   </p:sldLayoutIdLst>
   <p:hf sldNum="0" hdr="0" ftr="0" dt="0"/>
   <p:txStyles>
@@ -2058,13 +2437,6 @@
 <file path=ppt/slides/slide1.xml><?xml version="1.0" encoding="utf-8"?>
 <p:sld xmlns:a="http://schemas.openxmlformats.org/drawingml/2006/main" xmlns:r="http://schemas.openxmlformats.org/officeDocument/2006/relationships" xmlns:p="http://schemas.openxmlformats.org/presentationml/2006/main">
   <p:cSld name="Slide 1">
-    <p:bg>
-      <p:bgPr>
-        <a:solidFill>
-          <a:srgbClr val="3B1F5E"/>
-        </a:solidFill>
-      </p:bgPr>
-    </p:bg>
     <p:spTree>
       <p:nvGrpSpPr>
         <p:cNvPr id="1" name=""/>
@@ -2081,113 +2453,7 @@
       </p:grpSpPr>
       <p:sp>
         <p:nvSpPr>
-          <p:cNvPr id="2" name="Shape 0"/>
-          <p:cNvSpPr/>
-          <p:nvPr/>
-        </p:nvSpPr>
-        <p:spPr>
-          <a:xfrm>
-            <a:off x="457200" y="822960"/>
-            <a:ext cx="384048" cy="128016"/>
-          </a:xfrm>
-          <a:prstGeom prst="roundRect">
-            <a:avLst>
-              <a:gd name="adj" fmla="val 42857"/>
-            </a:avLst>
-          </a:prstGeom>
-          <a:solidFill>
-            <a:srgbClr val="B89BE0"/>
-          </a:solidFill>
-          <a:ln w="12700">
-            <a:solidFill>
-              <a:srgbClr val="B89BE0"/>
-            </a:solidFill>
-            <a:prstDash val="solid"/>
-          </a:ln>
-        </p:spPr>
-      </p:sp>
-      <p:sp>
-        <p:nvSpPr>
-          <p:cNvPr id="3" name="Shape 1"/>
-          <p:cNvSpPr/>
-          <p:nvPr/>
-        </p:nvSpPr>
-        <p:spPr>
-          <a:xfrm>
-            <a:off x="548640" y="658368"/>
-            <a:ext cx="384048" cy="128016"/>
-          </a:xfrm>
-          <a:prstGeom prst="roundRect">
-            <a:avLst>
-              <a:gd name="adj" fmla="val 42857"/>
-            </a:avLst>
-          </a:prstGeom>
-          <a:solidFill>
-            <a:srgbClr val="FFFFFF"/>
-          </a:solidFill>
-          <a:ln w="12700">
-            <a:solidFill>
-              <a:srgbClr val="FFFFFF"/>
-            </a:solidFill>
-            <a:prstDash val="solid"/>
-          </a:ln>
-        </p:spPr>
-      </p:sp>
-      <p:sp>
-        <p:nvSpPr>
-          <p:cNvPr id="4" name="Shape 2"/>
-          <p:cNvSpPr/>
-          <p:nvPr/>
-        </p:nvSpPr>
-        <p:spPr>
-          <a:xfrm>
-            <a:off x="640080" y="493776"/>
-            <a:ext cx="384048" cy="128016"/>
-          </a:xfrm>
-          <a:prstGeom prst="roundRect">
-            <a:avLst>
-              <a:gd name="adj" fmla="val 42857"/>
-            </a:avLst>
-          </a:prstGeom>
-          <a:solidFill>
-            <a:srgbClr val="FFFFFF"/>
-          </a:solidFill>
-          <a:ln w="12700">
-            <a:solidFill>
-              <a:srgbClr val="FFFFFF"/>
-            </a:solidFill>
-            <a:prstDash val="solid"/>
-          </a:ln>
-        </p:spPr>
-      </p:sp>
-      <p:sp>
-        <p:nvSpPr>
-          <p:cNvPr id="5" name="Shape 3"/>
-          <p:cNvSpPr/>
-          <p:nvPr/>
-        </p:nvSpPr>
-        <p:spPr>
-          <a:xfrm>
-            <a:off x="1024128" y="859536"/>
-            <a:ext cx="118872" cy="118872"/>
-          </a:xfrm>
-          <a:prstGeom prst="ellipse">
-            <a:avLst/>
-          </a:prstGeom>
-          <a:solidFill>
-            <a:srgbClr val="FFC83D"/>
-          </a:solidFill>
-          <a:ln w="12700">
-            <a:solidFill>
-              <a:srgbClr val="FFC83D"/>
-            </a:solidFill>
-            <a:prstDash val="solid"/>
-          </a:ln>
-        </p:spPr>
-      </p:sp>
-      <p:sp>
-        <p:nvSpPr>
-          <p:cNvPr id="6" name="Text 4"/>
+          <p:cNvPr id="2" name="Text 0"/>
           <p:cNvSpPr txBox="1"/>
           <p:nvPr/>
         </p:nvSpPr>
@@ -2220,7 +2486,7 @@
                 <a:ea typeface="Arial" pitchFamily="34" charset="-122"/>
                 <a:cs typeface="Arial" pitchFamily="34" charset="-120"/>
               </a:rPr>
-              <a:t>Resultado de setembro de 2026</a:t>
+              <a:t>Resultado de agosto de 2026</a:t>
             </a:r>
             <a:endParaRPr lang="en-US" sz="3600" dirty="0"/>
           </a:p>
@@ -2228,7 +2494,7 @@
       </p:sp>
       <p:sp>
         <p:nvSpPr>
-          <p:cNvPr id="7" name="Text 5"/>
+          <p:cNvPr id="3" name="Text 1"/>
           <p:cNvSpPr txBox="1"/>
           <p:nvPr/>
         </p:nvSpPr>
@@ -2259,7 +2525,7 @@
                 <a:ea typeface="Arial" pitchFamily="34" charset="-122"/>
                 <a:cs typeface="Arial" pitchFamily="34" charset="-120"/>
               </a:rPr>
-              <a:t>Ferraz &amp; Lima Advocacia (exemplo fictício) · reunião dos sócios · 2 de outubro de 2026</a:t>
+              <a:t>Ferraz &amp; Lima Advocacia (exemplo fictício) · reunião dos sócios · segunda-feira, 14 de setembro de 2026</a:t>
             </a:r>
             <a:endParaRPr lang="en-US" sz="1600" dirty="0"/>
           </a:p>
@@ -2267,14 +2533,14 @@
       </p:sp>
       <p:sp>
         <p:nvSpPr>
-          <p:cNvPr id="8" name="Text 6"/>
+          <p:cNvPr id="4" name="Text 2"/>
           <p:cNvSpPr txBox="1"/>
           <p:nvPr/>
         </p:nvSpPr>
         <p:spPr>
           <a:xfrm>
             <a:off x="457200" y="3291840"/>
-            <a:ext cx="7772400" cy="640080"/>
+            <a:ext cx="7772400" cy="822960"/>
           </a:xfrm>
           <a:prstGeom prst="rect">
             <a:avLst/>
@@ -2283,7 +2549,7 @@
           <a:ln/>
         </p:spPr>
         <p:txBody>
-          <a:bodyPr wrap="square" lIns="0" tIns="0" rIns="0" bIns="0" rtlCol="0" anchor="ctr"/>
+          <a:bodyPr wrap="square" lIns="0" tIns="0" rIns="0" bIns="0" rtlCol="0" anchor="t"/>
           <a:lstStyle/>
           <a:p>
             <a:pPr indent="0" marL="0">
@@ -2298,156 +2564,11 @@
                 <a:ea typeface="Arial" pitchFamily="34" charset="-122"/>
                 <a:cs typeface="Arial" pitchFamily="34" charset="-120"/>
               </a:rPr>
-              <a:t>Em uma frase: melhor caixa do ano (sobrou R$ 9,2 mil), mas 7 prazos atrasados e R$ 21,6 mil vencidos pedem ação esta semana.</a:t>
+              <a:t>Em uma frase: agosto deu resultado de R$ 5.688 (margem de 21 %), abaixo de julho; mas 7 prazos atrasados e R$ 14.480 vencidos hoje pedem ação esta semana.</a:t>
             </a:r>
             <a:endParaRPr lang="en-US" sz="1400" dirty="0"/>
           </a:p>
         </p:txBody>
-      </p:sp>
-      <p:sp>
-        <p:nvSpPr>
-          <p:cNvPr id="9" name="Text 7"/>
-          <p:cNvSpPr txBox="1"/>
-          <p:nvPr/>
-        </p:nvSpPr>
-        <p:spPr>
-          <a:xfrm>
-            <a:off x="457200" y="4791456"/>
-            <a:ext cx="6858000" cy="201168"/>
-          </a:xfrm>
-          <a:prstGeom prst="rect">
-            <a:avLst/>
-          </a:prstGeom>
-          <a:noFill/>
-          <a:ln/>
-        </p:spPr>
-        <p:txBody>
-          <a:bodyPr wrap="square" lIns="0" tIns="0" rIns="0" bIns="0" rtlCol="0" anchor="ctr"/>
-          <a:lstStyle/>
-          <a:p>
-            <a:pPr indent="0" marL="0">
-              <a:buNone/>
-            </a:pPr>
-            <a:r>
-              <a:rPr lang="en-US" sz="700" dirty="0">
-                <a:solidFill>
-                  <a:srgbClr val="7A5AA8"/>
-                </a:solidFill>
-                <a:latin typeface="Arial" pitchFamily="34" charset="0"/>
-                <a:ea typeface="Arial" pitchFamily="34" charset="-122"/>
-                <a:cs typeface="Arial" pitchFamily="34" charset="-120"/>
-              </a:rPr>
-              <a:t>Kit de Gestão para Advogados · modelo v1.0 · set/2026</a:t>
-            </a:r>
-            <a:endParaRPr lang="en-US" sz="700" dirty="0"/>
-          </a:p>
-        </p:txBody>
-      </p:sp>
-      <p:sp>
-        <p:nvSpPr>
-          <p:cNvPr id="10" name="Shape 8"/>
-          <p:cNvSpPr/>
-          <p:nvPr/>
-        </p:nvSpPr>
-        <p:spPr>
-          <a:xfrm>
-            <a:off x="8229600" y="4818888"/>
-            <a:ext cx="211226" cy="70409"/>
-          </a:xfrm>
-          <a:prstGeom prst="roundRect">
-            <a:avLst>
-              <a:gd name="adj" fmla="val 42857"/>
-            </a:avLst>
-          </a:prstGeom>
-          <a:solidFill>
-            <a:srgbClr val="B89BE0"/>
-          </a:solidFill>
-          <a:ln w="12700">
-            <a:solidFill>
-              <a:srgbClr val="B89BE0"/>
-            </a:solidFill>
-            <a:prstDash val="solid"/>
-          </a:ln>
-        </p:spPr>
-      </p:sp>
-      <p:sp>
-        <p:nvSpPr>
-          <p:cNvPr id="11" name="Shape 9"/>
-          <p:cNvSpPr/>
-          <p:nvPr/>
-        </p:nvSpPr>
-        <p:spPr>
-          <a:xfrm>
-            <a:off x="8279892" y="4728362"/>
-            <a:ext cx="211226" cy="70409"/>
-          </a:xfrm>
-          <a:prstGeom prst="roundRect">
-            <a:avLst>
-              <a:gd name="adj" fmla="val 42857"/>
-            </a:avLst>
-          </a:prstGeom>
-          <a:solidFill>
-            <a:srgbClr val="FFFFFF"/>
-          </a:solidFill>
-          <a:ln w="12700">
-            <a:solidFill>
-              <a:srgbClr val="FFFFFF"/>
-            </a:solidFill>
-            <a:prstDash val="solid"/>
-          </a:ln>
-        </p:spPr>
-      </p:sp>
-      <p:sp>
-        <p:nvSpPr>
-          <p:cNvPr id="12" name="Shape 10"/>
-          <p:cNvSpPr/>
-          <p:nvPr/>
-        </p:nvSpPr>
-        <p:spPr>
-          <a:xfrm>
-            <a:off x="8330184" y="4637837"/>
-            <a:ext cx="211226" cy="70409"/>
-          </a:xfrm>
-          <a:prstGeom prst="roundRect">
-            <a:avLst>
-              <a:gd name="adj" fmla="val 42857"/>
-            </a:avLst>
-          </a:prstGeom>
-          <a:solidFill>
-            <a:srgbClr val="FFFFFF"/>
-          </a:solidFill>
-          <a:ln w="12700">
-            <a:solidFill>
-              <a:srgbClr val="FFFFFF"/>
-            </a:solidFill>
-            <a:prstDash val="solid"/>
-          </a:ln>
-        </p:spPr>
-      </p:sp>
-      <p:sp>
-        <p:nvSpPr>
-          <p:cNvPr id="13" name="Shape 11"/>
-          <p:cNvSpPr/>
-          <p:nvPr/>
-        </p:nvSpPr>
-        <p:spPr>
-          <a:xfrm>
-            <a:off x="8541410" y="4839005"/>
-            <a:ext cx="65380" cy="65380"/>
-          </a:xfrm>
-          <a:prstGeom prst="ellipse">
-            <a:avLst/>
-          </a:prstGeom>
-          <a:solidFill>
-            <a:srgbClr val="FFC83D"/>
-          </a:solidFill>
-          <a:ln w="12700">
-            <a:solidFill>
-              <a:srgbClr val="FFC83D"/>
-            </a:solidFill>
-            <a:prstDash val="solid"/>
-          </a:ln>
-        </p:spPr>
       </p:sp>
     </p:spTree>
   </p:cSld>
@@ -2460,13 +2581,6 @@
 <file path=ppt/slides/slide2.xml><?xml version="1.0" encoding="utf-8"?>
 <p:sld xmlns:a="http://schemas.openxmlformats.org/drawingml/2006/main" xmlns:r="http://schemas.openxmlformats.org/officeDocument/2006/relationships" xmlns:p="http://schemas.openxmlformats.org/presentationml/2006/main">
   <p:cSld name="Slide 2">
-    <p:bg>
-      <p:bgPr>
-        <a:solidFill>
-          <a:srgbClr val="FFFFFF"/>
-        </a:solidFill>
-      </p:bgPr>
-    </p:bg>
     <p:spTree>
       <p:nvGrpSpPr>
         <p:cNvPr id="1" name=""/>
@@ -2555,7 +2669,7 @@
                 <a:ea typeface="Arial" pitchFamily="34" charset="-122"/>
                 <a:cs typeface="Arial" pitchFamily="34" charset="-120"/>
               </a:rPr>
-              <a:t>Fonte: Painel do escritório (17), Caixa (09) e Carteira de clientes e casos (13).</a:t>
+              <a:t>Fonte: Resultado mensal (18) e Caixa do escritório (09), agosto fechado; Carteira (13) e Parcelas (14) na posição de 11/09.</a:t>
             </a:r>
             <a:endParaRPr lang="en-US" sz="1200" dirty="0"/>
           </a:p>
@@ -2623,7 +2737,7 @@
                 <a:ea typeface="Arial" pitchFamily="34" charset="-122"/>
                 <a:cs typeface="Arial" pitchFamily="34" charset="-120"/>
               </a:rPr>
-              <a:t>R$ 29,4 mil</a:t>
+              <a:t>R$ 26.900</a:t>
             </a:r>
             <a:endParaRPr lang="en-US" sz="2600" dirty="0"/>
           </a:p>
@@ -2701,7 +2815,7 @@
                 <a:ea typeface="Arial" pitchFamily="34" charset="-122"/>
                 <a:cs typeface="Arial" pitchFamily="34" charset="-120"/>
               </a:rPr>
-              <a:t>R$ 27,9 mil em agosto (+5%). Honorários por hora e fixos puxaram; nenhum êxito recebido.</a:t>
+              <a:t>R$ 29.460 em julho (−8,7 %). Honorários fixos R$ 15.300 e consultoria e pareceres R$ 11.290; nenhum êxito nem hora em agosto.</a:t>
             </a:r>
             <a:endParaRPr lang="en-US" sz="1050" dirty="0"/>
           </a:p>
@@ -2769,7 +2883,7 @@
                 <a:ea typeface="Arial" pitchFamily="34" charset="-122"/>
                 <a:cs typeface="Arial" pitchFamily="34" charset="-120"/>
               </a:rPr>
-              <a:t>R$ 9,2 mil</a:t>
+              <a:t>R$ 5.688</a:t>
             </a:r>
             <a:endParaRPr lang="en-US" sz="2600" dirty="0"/>
           </a:p>
@@ -2808,7 +2922,7 @@
                 <a:ea typeface="Arial" pitchFamily="34" charset="-122"/>
                 <a:cs typeface="Arial" pitchFamily="34" charset="-120"/>
               </a:rPr>
-              <a:t>Resultado (sobrou)</a:t>
+              <a:t>Resultado (margem 21,1 %)</a:t>
             </a:r>
             <a:endParaRPr lang="en-US" sz="1300" dirty="0"/>
           </a:p>
@@ -2847,7 +2961,7 @@
                 <a:ea typeface="Arial" pitchFamily="34" charset="-122"/>
                 <a:cs typeface="Arial" pitchFamily="34" charset="-120"/>
               </a:rPr>
-              <a:t>depois de R$ 6,4 mil de custo fixo, R$ 12 mil de pró-labore e R$ 1,8 mil de impostos. Agosto: R$ 7,8 mil.</a:t>
+              <a:t>depois de R$ 6.500 de custo fixo, R$ 560 de despesas de casos, R$ 12.000 de pró-labore e R$ 2.152 de impostos provisionados (8 %). Julho: R$ 8.293 (28,2 %).</a:t>
             </a:r>
             <a:endParaRPr lang="en-US" sz="1050" dirty="0"/>
           </a:p>
@@ -2915,7 +3029,7 @@
                 <a:ea typeface="Arial" pitchFamily="34" charset="-122"/>
                 <a:cs typeface="Arial" pitchFamily="34" charset="-120"/>
               </a:rPr>
-              <a:t>R$ 128,3 mil</a:t>
+              <a:t>R$ 111.990</a:t>
             </a:r>
             <a:endParaRPr lang="en-US" sz="2600" dirty="0"/>
           </a:p>
@@ -2993,7 +3107,7 @@
                 <a:ea typeface="Arial" pitchFamily="34" charset="-122"/>
                 <a:cs typeface="Arial" pitchFamily="34" charset="-120"/>
               </a:rPr>
-              <a:t>R$ 21,6 mil já vencidos (16,8%). R$ 36 mil são honorários de êxito, que só entram no fim dos casos.</a:t>
+              <a:t>R$ 14.480 já vencidos em 8 parcelas (inadimplência 5,1 %). R$ 30 mil são êxito puro de 5 casos, que só entra no fim.</a:t>
             </a:r>
             <a:endParaRPr lang="en-US" sz="1050" dirty="0"/>
           </a:p>
@@ -3032,156 +3146,11 @@
                 <a:ea typeface="Arial" pitchFamily="34" charset="-122"/>
                 <a:cs typeface="Arial" pitchFamily="34" charset="-120"/>
               </a:rPr>
-              <a:t>Trinta casos ativos com 18 clientes; 318 horas registradas no mês, 226 faturáveis (71%).</a:t>
+              <a:t>Trinta casos ativos com 18 clientes; 304 horas registradas em agosto, 248 faturáveis (81,6 %).</a:t>
             </a:r>
             <a:endParaRPr lang="en-US" sz="1300" dirty="0"/>
           </a:p>
         </p:txBody>
-      </p:sp>
-      <p:sp>
-        <p:nvSpPr>
-          <p:cNvPr id="17" name="Text 15"/>
-          <p:cNvSpPr txBox="1"/>
-          <p:nvPr/>
-        </p:nvSpPr>
-        <p:spPr>
-          <a:xfrm>
-            <a:off x="457200" y="4791456"/>
-            <a:ext cx="6858000" cy="201168"/>
-          </a:xfrm>
-          <a:prstGeom prst="rect">
-            <a:avLst/>
-          </a:prstGeom>
-          <a:noFill/>
-          <a:ln/>
-        </p:spPr>
-        <p:txBody>
-          <a:bodyPr wrap="square" lIns="0" tIns="0" rIns="0" bIns="0" rtlCol="0" anchor="ctr"/>
-          <a:lstStyle/>
-          <a:p>
-            <a:pPr indent="0" marL="0">
-              <a:buNone/>
-            </a:pPr>
-            <a:r>
-              <a:rPr lang="en-US" sz="700" dirty="0">
-                <a:solidFill>
-                  <a:srgbClr val="B89BE0"/>
-                </a:solidFill>
-                <a:latin typeface="Arial" pitchFamily="34" charset="0"/>
-                <a:ea typeface="Arial" pitchFamily="34" charset="-122"/>
-                <a:cs typeface="Arial" pitchFamily="34" charset="-120"/>
-              </a:rPr>
-              <a:t>Kit de Gestão para Advogados · modelo v1.0 · set/2026</a:t>
-            </a:r>
-            <a:endParaRPr lang="en-US" sz="700" dirty="0"/>
-          </a:p>
-        </p:txBody>
-      </p:sp>
-      <p:sp>
-        <p:nvSpPr>
-          <p:cNvPr id="18" name="Shape 16"/>
-          <p:cNvSpPr/>
-          <p:nvPr/>
-        </p:nvSpPr>
-        <p:spPr>
-          <a:xfrm>
-            <a:off x="8229600" y="4818888"/>
-            <a:ext cx="211226" cy="70409"/>
-          </a:xfrm>
-          <a:prstGeom prst="roundRect">
-            <a:avLst>
-              <a:gd name="adj" fmla="val 42857"/>
-            </a:avLst>
-          </a:prstGeom>
-          <a:solidFill>
-            <a:srgbClr val="7A5AA8"/>
-          </a:solidFill>
-          <a:ln w="12700">
-            <a:solidFill>
-              <a:srgbClr val="7A5AA8"/>
-            </a:solidFill>
-            <a:prstDash val="solid"/>
-          </a:ln>
-        </p:spPr>
-      </p:sp>
-      <p:sp>
-        <p:nvSpPr>
-          <p:cNvPr id="19" name="Shape 17"/>
-          <p:cNvSpPr/>
-          <p:nvPr/>
-        </p:nvSpPr>
-        <p:spPr>
-          <a:xfrm>
-            <a:off x="8279892" y="4728362"/>
-            <a:ext cx="211226" cy="70409"/>
-          </a:xfrm>
-          <a:prstGeom prst="roundRect">
-            <a:avLst>
-              <a:gd name="adj" fmla="val 42857"/>
-            </a:avLst>
-          </a:prstGeom>
-          <a:solidFill>
-            <a:srgbClr val="3B1F5E"/>
-          </a:solidFill>
-          <a:ln w="12700">
-            <a:solidFill>
-              <a:srgbClr val="3B1F5E"/>
-            </a:solidFill>
-            <a:prstDash val="solid"/>
-          </a:ln>
-        </p:spPr>
-      </p:sp>
-      <p:sp>
-        <p:nvSpPr>
-          <p:cNvPr id="20" name="Shape 18"/>
-          <p:cNvSpPr/>
-          <p:nvPr/>
-        </p:nvSpPr>
-        <p:spPr>
-          <a:xfrm>
-            <a:off x="8330184" y="4637837"/>
-            <a:ext cx="211226" cy="70409"/>
-          </a:xfrm>
-          <a:prstGeom prst="roundRect">
-            <a:avLst>
-              <a:gd name="adj" fmla="val 42857"/>
-            </a:avLst>
-          </a:prstGeom>
-          <a:solidFill>
-            <a:srgbClr val="3B1F5E"/>
-          </a:solidFill>
-          <a:ln w="12700">
-            <a:solidFill>
-              <a:srgbClr val="3B1F5E"/>
-            </a:solidFill>
-            <a:prstDash val="solid"/>
-          </a:ln>
-        </p:spPr>
-      </p:sp>
-      <p:sp>
-        <p:nvSpPr>
-          <p:cNvPr id="21" name="Shape 19"/>
-          <p:cNvSpPr/>
-          <p:nvPr/>
-        </p:nvSpPr>
-        <p:spPr>
-          <a:xfrm>
-            <a:off x="8541410" y="4839005"/>
-            <a:ext cx="65380" cy="65380"/>
-          </a:xfrm>
-          <a:prstGeom prst="ellipse">
-            <a:avLst/>
-          </a:prstGeom>
-          <a:solidFill>
-            <a:srgbClr val="FFC83D"/>
-          </a:solidFill>
-          <a:ln w="12700">
-            <a:solidFill>
-              <a:srgbClr val="FFC83D"/>
-            </a:solidFill>
-            <a:prstDash val="solid"/>
-          </a:ln>
-        </p:spPr>
       </p:sp>
     </p:spTree>
   </p:cSld>
@@ -3194,13 +3163,6 @@
 <file path=ppt/slides/slide3.xml><?xml version="1.0" encoding="utf-8"?>
 <p:sld xmlns:a="http://schemas.openxmlformats.org/drawingml/2006/main" xmlns:r="http://schemas.openxmlformats.org/officeDocument/2006/relationships" xmlns:p="http://schemas.openxmlformats.org/presentationml/2006/main">
   <p:cSld name="Slide 3">
-    <p:bg>
-      <p:bgPr>
-        <a:solidFill>
-          <a:srgbClr val="FFFFFF"/>
-        </a:solidFill>
-      </p:bgPr>
-    </p:bg>
     <p:spTree>
       <p:nvGrpSpPr>
         <p:cNvPr id="1" name=""/>
@@ -3289,7 +3251,7 @@
                 <a:ea typeface="Arial" pitchFamily="34" charset="-122"/>
                 <a:cs typeface="Arial" pitchFamily="34" charset="-120"/>
               </a:rPr>
-              <a:t>Agenda de prazos (01), semáforo de 2/10. Atrasado é prazo cujo registro na agenda venceu sem baixa.</a:t>
+              <a:t>Agenda de prazos (01), semáforo de hoje, 14/09. Atrasado é prazo cujo registro na agenda venceu sem baixa.</a:t>
             </a:r>
             <a:endParaRPr lang="en-US" sz="1200" dirty="0"/>
           </a:p>
@@ -3357,7 +3319,7 @@
                 <a:ea typeface="Arial" pitchFamily="34" charset="-122"/>
                 <a:cs typeface="Arial" pitchFamily="34" charset="-120"/>
               </a:rPr>
-              <a:t>13</a:t>
+              <a:t>14</a:t>
             </a:r>
             <a:endParaRPr lang="en-US" sz="2600" dirty="0"/>
           </a:p>
@@ -3396,7 +3358,7 @@
                 <a:ea typeface="Arial" pitchFamily="34" charset="-122"/>
                 <a:cs typeface="Arial" pitchFamily="34" charset="-120"/>
               </a:rPr>
-              <a:t>Prazos nos próximos 7 dias</a:t>
+              <a:t>Prazos de hoje e dos próximos 7 dias</a:t>
             </a:r>
             <a:endParaRPr lang="en-US" sz="1300" dirty="0"/>
           </a:p>
@@ -3640,12 +3602,13 @@
               <a:tblPr/>
               <a:tblGrid>
                 <a:gridCol w="2377440"/>
-                <a:gridCol w="1554480"/>
+                <a:gridCol w="1188720"/>
+                <a:gridCol w="1097280"/>
+                <a:gridCol w="914400"/>
                 <a:gridCol w="1371600"/>
-                <a:gridCol w="1463040"/>
-                <a:gridCol w="1463040"/>
+                <a:gridCol w="1280160"/>
               </a:tblGrid>
-              <a:tr h="347472">
+              <a:tr h="329184">
                 <a:tc>
                   <a:txBody>
                     <a:bodyPr/>
@@ -3731,7 +3694,7 @@
                           <a:ea typeface="Arial" pitchFamily="34" charset="-122"/>
                           <a:cs typeface="Arial" pitchFamily="34" charset="-120"/>
                         </a:rPr>
-                        <a:t>Prazos na semana</a:t>
+                        <a:t>Prazos abertos</a:t>
                       </a:r>
                       <a:endParaRPr lang="en-US" sz="1100" dirty="0">
                         <a:latin typeface="Arial" charset="0"/>
@@ -3867,7 +3830,7 @@
                           <a:ea typeface="Arial" pitchFamily="34" charset="-122"/>
                           <a:cs typeface="Arial" pitchFamily="34" charset="-120"/>
                         </a:rPr>
-                        <a:t>Casos ativos</a:t>
+                        <a:t>Hoje</a:t>
                       </a:r>
                       <a:endParaRPr lang="en-US" sz="1100" dirty="0">
                         <a:latin typeface="Arial" charset="0"/>
@@ -3935,7 +3898,7 @@
                           <a:ea typeface="Arial" pitchFamily="34" charset="-122"/>
                           <a:cs typeface="Arial" pitchFamily="34" charset="-120"/>
                         </a:rPr>
-                        <a:t>Horas no mês</a:t>
+                        <a:t>Em alerta (7 dias)</a:t>
                       </a:r>
                       <a:endParaRPr lang="en-US" sz="1100" dirty="0">
                         <a:latin typeface="Arial" charset="0"/>
@@ -3986,8 +3949,76 @@
                     </a:solidFill>
                   </a:tcPr>
                 </a:tc>
+                <a:tc>
+                  <a:txBody>
+                    <a:bodyPr/>
+                    <a:lstStyle/>
+                    <a:p>
+                      <a:pPr algn="r" indent="0" marL="0">
+                        <a:buNone/>
+                      </a:pPr>
+                      <a:r>
+                        <a:rPr lang="en-US" sz="1100" b="1" dirty="0">
+                          <a:solidFill>
+                            <a:srgbClr val="FFFFFF"/>
+                          </a:solidFill>
+                          <a:latin typeface="Arial" pitchFamily="34" charset="0"/>
+                          <a:ea typeface="Arial" pitchFamily="34" charset="-122"/>
+                          <a:cs typeface="Arial" pitchFamily="34" charset="-120"/>
+                        </a:rPr>
+                        <a:t>Horas em agosto</a:t>
+                      </a:r>
+                      <a:endParaRPr lang="en-US" sz="1100" dirty="0">
+                        <a:latin typeface="Arial" charset="0"/>
+                        <a:ea typeface="Arial" charset="0"/>
+                        <a:cs typeface="Arial" charset="0"/>
+                      </a:endParaRPr>
+                    </a:p>
+                  </a:txBody>
+                  <a:tcPr marL="54864" marR="54864" marT="54864" marB="54864" anchor="ctr">
+                    <a:lnL w="9525" cap="flat" cmpd="sng" algn="ctr">
+                      <a:solidFill>
+                        <a:srgbClr val="DCD2EC"/>
+                      </a:solidFill>
+                      <a:prstDash val="solid"/>
+                      <a:round/>
+                      <a:headEnd type="none" w="med" len="med"/>
+                      <a:tailEnd type="none" w="med" len="med"/>
+                    </a:lnL>
+                    <a:lnR w="9525" cap="flat" cmpd="sng" algn="ctr">
+                      <a:solidFill>
+                        <a:srgbClr val="DCD2EC"/>
+                      </a:solidFill>
+                      <a:prstDash val="solid"/>
+                      <a:round/>
+                      <a:headEnd type="none" w="med" len="med"/>
+                      <a:tailEnd type="none" w="med" len="med"/>
+                    </a:lnR>
+                    <a:lnT w="9525" cap="flat" cmpd="sng" algn="ctr">
+                      <a:solidFill>
+                        <a:srgbClr val="DCD2EC"/>
+                      </a:solidFill>
+                      <a:prstDash val="solid"/>
+                      <a:round/>
+                      <a:headEnd type="none" w="med" len="med"/>
+                      <a:tailEnd type="none" w="med" len="med"/>
+                    </a:lnT>
+                    <a:lnB w="9525" cap="flat" cmpd="sng" algn="ctr">
+                      <a:solidFill>
+                        <a:srgbClr val="DCD2EC"/>
+                      </a:solidFill>
+                      <a:prstDash val="solid"/>
+                      <a:round/>
+                      <a:headEnd type="none" w="med" len="med"/>
+                      <a:tailEnd type="none" w="med" len="med"/>
+                    </a:lnB>
+                    <a:solidFill>
+                      <a:srgbClr val="3B1F5E"/>
+                    </a:solidFill>
+                  </a:tcPr>
+                </a:tc>
               </a:tr>
-              <a:tr h="347472">
+              <a:tr h="329184">
                 <a:tc>
                   <a:txBody>
                     <a:bodyPr/>
@@ -4073,7 +4104,759 @@
                           <a:ea typeface="Arial" pitchFamily="34" charset="-122"/>
                           <a:cs typeface="Arial" pitchFamily="34" charset="-120"/>
                         </a:rPr>
-                        <a:t>7</a:t>
+                        <a:t>15</a:t>
+                      </a:r>
+                      <a:endParaRPr lang="en-US" sz="1100" dirty="0">
+                        <a:latin typeface="Arial" charset="0"/>
+                        <a:ea typeface="Arial" charset="0"/>
+                        <a:cs typeface="Arial" charset="0"/>
+                      </a:endParaRPr>
+                    </a:p>
+                  </a:txBody>
+                  <a:tcPr marL="54864" marR="54864" marT="54864" marB="54864" anchor="ctr">
+                    <a:lnL w="9525" cap="flat" cmpd="sng" algn="ctr">
+                      <a:solidFill>
+                        <a:srgbClr val="DCD2EC"/>
+                      </a:solidFill>
+                      <a:prstDash val="solid"/>
+                      <a:round/>
+                      <a:headEnd type="none" w="med" len="med"/>
+                      <a:tailEnd type="none" w="med" len="med"/>
+                    </a:lnL>
+                    <a:lnR w="9525" cap="flat" cmpd="sng" algn="ctr">
+                      <a:solidFill>
+                        <a:srgbClr val="DCD2EC"/>
+                      </a:solidFill>
+                      <a:prstDash val="solid"/>
+                      <a:round/>
+                      <a:headEnd type="none" w="med" len="med"/>
+                      <a:tailEnd type="none" w="med" len="med"/>
+                    </a:lnR>
+                    <a:lnT w="9525" cap="flat" cmpd="sng" algn="ctr">
+                      <a:solidFill>
+                        <a:srgbClr val="DCD2EC"/>
+                      </a:solidFill>
+                      <a:prstDash val="solid"/>
+                      <a:round/>
+                      <a:headEnd type="none" w="med" len="med"/>
+                      <a:tailEnd type="none" w="med" len="med"/>
+                    </a:lnT>
+                    <a:lnB w="9525" cap="flat" cmpd="sng" algn="ctr">
+                      <a:solidFill>
+                        <a:srgbClr val="DCD2EC"/>
+                      </a:solidFill>
+                      <a:prstDash val="solid"/>
+                      <a:round/>
+                      <a:headEnd type="none" w="med" len="med"/>
+                      <a:tailEnd type="none" w="med" len="med"/>
+                    </a:lnB>
+                    <a:solidFill>
+                      <a:srgbClr val="F3EEFB"/>
+                    </a:solidFill>
+                  </a:tcPr>
+                </a:tc>
+                <a:tc>
+                  <a:txBody>
+                    <a:bodyPr/>
+                    <a:lstStyle/>
+                    <a:p>
+                      <a:pPr algn="r" indent="0" marL="0">
+                        <a:buNone/>
+                      </a:pPr>
+                      <a:r>
+                        <a:rPr lang="en-US" sz="1100" dirty="0">
+                          <a:solidFill>
+                            <a:srgbClr val="1F1235"/>
+                          </a:solidFill>
+                          <a:latin typeface="Arial" pitchFamily="34" charset="0"/>
+                          <a:ea typeface="Arial" pitchFamily="34" charset="-122"/>
+                          <a:cs typeface="Arial" pitchFamily="34" charset="-120"/>
+                        </a:rPr>
+                        <a:t>3</a:t>
+                      </a:r>
+                      <a:endParaRPr lang="en-US" sz="1100" dirty="0">
+                        <a:latin typeface="Arial" charset="0"/>
+                        <a:ea typeface="Arial" charset="0"/>
+                        <a:cs typeface="Arial" charset="0"/>
+                      </a:endParaRPr>
+                    </a:p>
+                  </a:txBody>
+                  <a:tcPr marL="54864" marR="54864" marT="54864" marB="54864" anchor="ctr">
+                    <a:lnL w="9525" cap="flat" cmpd="sng" algn="ctr">
+                      <a:solidFill>
+                        <a:srgbClr val="DCD2EC"/>
+                      </a:solidFill>
+                      <a:prstDash val="solid"/>
+                      <a:round/>
+                      <a:headEnd type="none" w="med" len="med"/>
+                      <a:tailEnd type="none" w="med" len="med"/>
+                    </a:lnL>
+                    <a:lnR w="9525" cap="flat" cmpd="sng" algn="ctr">
+                      <a:solidFill>
+                        <a:srgbClr val="DCD2EC"/>
+                      </a:solidFill>
+                      <a:prstDash val="solid"/>
+                      <a:round/>
+                      <a:headEnd type="none" w="med" len="med"/>
+                      <a:tailEnd type="none" w="med" len="med"/>
+                    </a:lnR>
+                    <a:lnT w="9525" cap="flat" cmpd="sng" algn="ctr">
+                      <a:solidFill>
+                        <a:srgbClr val="DCD2EC"/>
+                      </a:solidFill>
+                      <a:prstDash val="solid"/>
+                      <a:round/>
+                      <a:headEnd type="none" w="med" len="med"/>
+                      <a:tailEnd type="none" w="med" len="med"/>
+                    </a:lnT>
+                    <a:lnB w="9525" cap="flat" cmpd="sng" algn="ctr">
+                      <a:solidFill>
+                        <a:srgbClr val="DCD2EC"/>
+                      </a:solidFill>
+                      <a:prstDash val="solid"/>
+                      <a:round/>
+                      <a:headEnd type="none" w="med" len="med"/>
+                      <a:tailEnd type="none" w="med" len="med"/>
+                    </a:lnB>
+                    <a:solidFill>
+                      <a:srgbClr val="F3EEFB"/>
+                    </a:solidFill>
+                  </a:tcPr>
+                </a:tc>
+                <a:tc>
+                  <a:txBody>
+                    <a:bodyPr/>
+                    <a:lstStyle/>
+                    <a:p>
+                      <a:pPr algn="r" indent="0" marL="0">
+                        <a:buNone/>
+                      </a:pPr>
+                      <a:r>
+                        <a:rPr lang="en-US" sz="1100" dirty="0">
+                          <a:solidFill>
+                            <a:srgbClr val="1F1235"/>
+                          </a:solidFill>
+                          <a:latin typeface="Arial" pitchFamily="34" charset="0"/>
+                          <a:ea typeface="Arial" pitchFamily="34" charset="-122"/>
+                          <a:cs typeface="Arial" pitchFamily="34" charset="-120"/>
+                        </a:rPr>
+                        <a:t>2</a:t>
+                      </a:r>
+                      <a:endParaRPr lang="en-US" sz="1100" dirty="0">
+                        <a:latin typeface="Arial" charset="0"/>
+                        <a:ea typeface="Arial" charset="0"/>
+                        <a:cs typeface="Arial" charset="0"/>
+                      </a:endParaRPr>
+                    </a:p>
+                  </a:txBody>
+                  <a:tcPr marL="54864" marR="54864" marT="54864" marB="54864" anchor="ctr">
+                    <a:lnL w="9525" cap="flat" cmpd="sng" algn="ctr">
+                      <a:solidFill>
+                        <a:srgbClr val="DCD2EC"/>
+                      </a:solidFill>
+                      <a:prstDash val="solid"/>
+                      <a:round/>
+                      <a:headEnd type="none" w="med" len="med"/>
+                      <a:tailEnd type="none" w="med" len="med"/>
+                    </a:lnL>
+                    <a:lnR w="9525" cap="flat" cmpd="sng" algn="ctr">
+                      <a:solidFill>
+                        <a:srgbClr val="DCD2EC"/>
+                      </a:solidFill>
+                      <a:prstDash val="solid"/>
+                      <a:round/>
+                      <a:headEnd type="none" w="med" len="med"/>
+                      <a:tailEnd type="none" w="med" len="med"/>
+                    </a:lnR>
+                    <a:lnT w="9525" cap="flat" cmpd="sng" algn="ctr">
+                      <a:solidFill>
+                        <a:srgbClr val="DCD2EC"/>
+                      </a:solidFill>
+                      <a:prstDash val="solid"/>
+                      <a:round/>
+                      <a:headEnd type="none" w="med" len="med"/>
+                      <a:tailEnd type="none" w="med" len="med"/>
+                    </a:lnT>
+                    <a:lnB w="9525" cap="flat" cmpd="sng" algn="ctr">
+                      <a:solidFill>
+                        <a:srgbClr val="DCD2EC"/>
+                      </a:solidFill>
+                      <a:prstDash val="solid"/>
+                      <a:round/>
+                      <a:headEnd type="none" w="med" len="med"/>
+                      <a:tailEnd type="none" w="med" len="med"/>
+                    </a:lnB>
+                    <a:solidFill>
+                      <a:srgbClr val="F3EEFB"/>
+                    </a:solidFill>
+                  </a:tcPr>
+                </a:tc>
+                <a:tc>
+                  <a:txBody>
+                    <a:bodyPr/>
+                    <a:lstStyle/>
+                    <a:p>
+                      <a:pPr algn="r" indent="0" marL="0">
+                        <a:buNone/>
+                      </a:pPr>
+                      <a:r>
+                        <a:rPr lang="en-US" sz="1100" dirty="0">
+                          <a:solidFill>
+                            <a:srgbClr val="1F1235"/>
+                          </a:solidFill>
+                          <a:latin typeface="Arial" pitchFamily="34" charset="0"/>
+                          <a:ea typeface="Arial" pitchFamily="34" charset="-122"/>
+                          <a:cs typeface="Arial" pitchFamily="34" charset="-120"/>
+                        </a:rPr>
+                        <a:t>4</a:t>
+                      </a:r>
+                      <a:endParaRPr lang="en-US" sz="1100" dirty="0">
+                        <a:latin typeface="Arial" charset="0"/>
+                        <a:ea typeface="Arial" charset="0"/>
+                        <a:cs typeface="Arial" charset="0"/>
+                      </a:endParaRPr>
+                    </a:p>
+                  </a:txBody>
+                  <a:tcPr marL="54864" marR="54864" marT="54864" marB="54864" anchor="ctr">
+                    <a:lnL w="9525" cap="flat" cmpd="sng" algn="ctr">
+                      <a:solidFill>
+                        <a:srgbClr val="DCD2EC"/>
+                      </a:solidFill>
+                      <a:prstDash val="solid"/>
+                      <a:round/>
+                      <a:headEnd type="none" w="med" len="med"/>
+                      <a:tailEnd type="none" w="med" len="med"/>
+                    </a:lnL>
+                    <a:lnR w="9525" cap="flat" cmpd="sng" algn="ctr">
+                      <a:solidFill>
+                        <a:srgbClr val="DCD2EC"/>
+                      </a:solidFill>
+                      <a:prstDash val="solid"/>
+                      <a:round/>
+                      <a:headEnd type="none" w="med" len="med"/>
+                      <a:tailEnd type="none" w="med" len="med"/>
+                    </a:lnR>
+                    <a:lnT w="9525" cap="flat" cmpd="sng" algn="ctr">
+                      <a:solidFill>
+                        <a:srgbClr val="DCD2EC"/>
+                      </a:solidFill>
+                      <a:prstDash val="solid"/>
+                      <a:round/>
+                      <a:headEnd type="none" w="med" len="med"/>
+                      <a:tailEnd type="none" w="med" len="med"/>
+                    </a:lnT>
+                    <a:lnB w="9525" cap="flat" cmpd="sng" algn="ctr">
+                      <a:solidFill>
+                        <a:srgbClr val="DCD2EC"/>
+                      </a:solidFill>
+                      <a:prstDash val="solid"/>
+                      <a:round/>
+                      <a:headEnd type="none" w="med" len="med"/>
+                      <a:tailEnd type="none" w="med" len="med"/>
+                    </a:lnB>
+                    <a:solidFill>
+                      <a:srgbClr val="F3EEFB"/>
+                    </a:solidFill>
+                  </a:tcPr>
+                </a:tc>
+                <a:tc>
+                  <a:txBody>
+                    <a:bodyPr/>
+                    <a:lstStyle/>
+                    <a:p>
+                      <a:pPr algn="r" indent="0" marL="0">
+                        <a:buNone/>
+                      </a:pPr>
+                      <a:r>
+                        <a:rPr lang="en-US" sz="1100" dirty="0">
+                          <a:solidFill>
+                            <a:srgbClr val="1F1235"/>
+                          </a:solidFill>
+                          <a:latin typeface="Arial" pitchFamily="34" charset="0"/>
+                          <a:ea typeface="Arial" pitchFamily="34" charset="-122"/>
+                          <a:cs typeface="Arial" pitchFamily="34" charset="-120"/>
+                        </a:rPr>
+                        <a:t>111,5</a:t>
+                      </a:r>
+                      <a:endParaRPr lang="en-US" sz="1100" dirty="0">
+                        <a:latin typeface="Arial" charset="0"/>
+                        <a:ea typeface="Arial" charset="0"/>
+                        <a:cs typeface="Arial" charset="0"/>
+                      </a:endParaRPr>
+                    </a:p>
+                  </a:txBody>
+                  <a:tcPr marL="54864" marR="54864" marT="54864" marB="54864" anchor="ctr">
+                    <a:lnL w="9525" cap="flat" cmpd="sng" algn="ctr">
+                      <a:solidFill>
+                        <a:srgbClr val="DCD2EC"/>
+                      </a:solidFill>
+                      <a:prstDash val="solid"/>
+                      <a:round/>
+                      <a:headEnd type="none" w="med" len="med"/>
+                      <a:tailEnd type="none" w="med" len="med"/>
+                    </a:lnL>
+                    <a:lnR w="9525" cap="flat" cmpd="sng" algn="ctr">
+                      <a:solidFill>
+                        <a:srgbClr val="DCD2EC"/>
+                      </a:solidFill>
+                      <a:prstDash val="solid"/>
+                      <a:round/>
+                      <a:headEnd type="none" w="med" len="med"/>
+                      <a:tailEnd type="none" w="med" len="med"/>
+                    </a:lnR>
+                    <a:lnT w="9525" cap="flat" cmpd="sng" algn="ctr">
+                      <a:solidFill>
+                        <a:srgbClr val="DCD2EC"/>
+                      </a:solidFill>
+                      <a:prstDash val="solid"/>
+                      <a:round/>
+                      <a:headEnd type="none" w="med" len="med"/>
+                      <a:tailEnd type="none" w="med" len="med"/>
+                    </a:lnT>
+                    <a:lnB w="9525" cap="flat" cmpd="sng" algn="ctr">
+                      <a:solidFill>
+                        <a:srgbClr val="DCD2EC"/>
+                      </a:solidFill>
+                      <a:prstDash val="solid"/>
+                      <a:round/>
+                      <a:headEnd type="none" w="med" len="med"/>
+                      <a:tailEnd type="none" w="med" len="med"/>
+                    </a:lnB>
+                    <a:solidFill>
+                      <a:srgbClr val="F3EEFB"/>
+                    </a:solidFill>
+                  </a:tcPr>
+                </a:tc>
+              </a:tr>
+              <a:tr h="329184">
+                <a:tc>
+                  <a:txBody>
+                    <a:bodyPr/>
+                    <a:lstStyle/>
+                    <a:p>
+                      <a:pPr algn="l" indent="0" marL="0">
+                        <a:buNone/>
+                      </a:pPr>
+                      <a:r>
+                        <a:rPr lang="en-US" sz="1100" dirty="0">
+                          <a:solidFill>
+                            <a:srgbClr val="1F1235"/>
+                          </a:solidFill>
+                          <a:latin typeface="Arial" pitchFamily="34" charset="0"/>
+                          <a:ea typeface="Arial" pitchFamily="34" charset="-122"/>
+                          <a:cs typeface="Arial" pitchFamily="34" charset="-120"/>
+                        </a:rPr>
+                        <a:t>Rafael Lima</a:t>
+                      </a:r>
+                      <a:endParaRPr lang="en-US" sz="1100" dirty="0">
+                        <a:latin typeface="Arial" charset="0"/>
+                        <a:ea typeface="Arial" charset="0"/>
+                        <a:cs typeface="Arial" charset="0"/>
+                      </a:endParaRPr>
+                    </a:p>
+                  </a:txBody>
+                  <a:tcPr marL="54864" marR="54864" marT="54864" marB="54864" anchor="ctr">
+                    <a:lnL w="9525" cap="flat" cmpd="sng" algn="ctr">
+                      <a:solidFill>
+                        <a:srgbClr val="DCD2EC"/>
+                      </a:solidFill>
+                      <a:prstDash val="solid"/>
+                      <a:round/>
+                      <a:headEnd type="none" w="med" len="med"/>
+                      <a:tailEnd type="none" w="med" len="med"/>
+                    </a:lnL>
+                    <a:lnR w="9525" cap="flat" cmpd="sng" algn="ctr">
+                      <a:solidFill>
+                        <a:srgbClr val="DCD2EC"/>
+                      </a:solidFill>
+                      <a:prstDash val="solid"/>
+                      <a:round/>
+                      <a:headEnd type="none" w="med" len="med"/>
+                      <a:tailEnd type="none" w="med" len="med"/>
+                    </a:lnR>
+                    <a:lnT w="9525" cap="flat" cmpd="sng" algn="ctr">
+                      <a:solidFill>
+                        <a:srgbClr val="DCD2EC"/>
+                      </a:solidFill>
+                      <a:prstDash val="solid"/>
+                      <a:round/>
+                      <a:headEnd type="none" w="med" len="med"/>
+                      <a:tailEnd type="none" w="med" len="med"/>
+                    </a:lnT>
+                    <a:lnB w="9525" cap="flat" cmpd="sng" algn="ctr">
+                      <a:solidFill>
+                        <a:srgbClr val="DCD2EC"/>
+                      </a:solidFill>
+                      <a:prstDash val="solid"/>
+                      <a:round/>
+                      <a:headEnd type="none" w="med" len="med"/>
+                      <a:tailEnd type="none" w="med" len="med"/>
+                    </a:lnB>
+                    <a:solidFill>
+                      <a:srgbClr val="FFFFFF"/>
+                    </a:solidFill>
+                  </a:tcPr>
+                </a:tc>
+                <a:tc>
+                  <a:txBody>
+                    <a:bodyPr/>
+                    <a:lstStyle/>
+                    <a:p>
+                      <a:pPr algn="r" indent="0" marL="0">
+                        <a:buNone/>
+                      </a:pPr>
+                      <a:r>
+                        <a:rPr lang="en-US" sz="1100" dirty="0">
+                          <a:solidFill>
+                            <a:srgbClr val="1F1235"/>
+                          </a:solidFill>
+                          <a:latin typeface="Arial" pitchFamily="34" charset="0"/>
+                          <a:ea typeface="Arial" pitchFamily="34" charset="-122"/>
+                          <a:cs typeface="Arial" pitchFamily="34" charset="-120"/>
+                        </a:rPr>
+                        <a:t>16</a:t>
+                      </a:r>
+                      <a:endParaRPr lang="en-US" sz="1100" dirty="0">
+                        <a:latin typeface="Arial" charset="0"/>
+                        <a:ea typeface="Arial" charset="0"/>
+                        <a:cs typeface="Arial" charset="0"/>
+                      </a:endParaRPr>
+                    </a:p>
+                  </a:txBody>
+                  <a:tcPr marL="54864" marR="54864" marT="54864" marB="54864" anchor="ctr">
+                    <a:lnL w="9525" cap="flat" cmpd="sng" algn="ctr">
+                      <a:solidFill>
+                        <a:srgbClr val="DCD2EC"/>
+                      </a:solidFill>
+                      <a:prstDash val="solid"/>
+                      <a:round/>
+                      <a:headEnd type="none" w="med" len="med"/>
+                      <a:tailEnd type="none" w="med" len="med"/>
+                    </a:lnL>
+                    <a:lnR w="9525" cap="flat" cmpd="sng" algn="ctr">
+                      <a:solidFill>
+                        <a:srgbClr val="DCD2EC"/>
+                      </a:solidFill>
+                      <a:prstDash val="solid"/>
+                      <a:round/>
+                      <a:headEnd type="none" w="med" len="med"/>
+                      <a:tailEnd type="none" w="med" len="med"/>
+                    </a:lnR>
+                    <a:lnT w="9525" cap="flat" cmpd="sng" algn="ctr">
+                      <a:solidFill>
+                        <a:srgbClr val="DCD2EC"/>
+                      </a:solidFill>
+                      <a:prstDash val="solid"/>
+                      <a:round/>
+                      <a:headEnd type="none" w="med" len="med"/>
+                      <a:tailEnd type="none" w="med" len="med"/>
+                    </a:lnT>
+                    <a:lnB w="9525" cap="flat" cmpd="sng" algn="ctr">
+                      <a:solidFill>
+                        <a:srgbClr val="DCD2EC"/>
+                      </a:solidFill>
+                      <a:prstDash val="solid"/>
+                      <a:round/>
+                      <a:headEnd type="none" w="med" len="med"/>
+                      <a:tailEnd type="none" w="med" len="med"/>
+                    </a:lnB>
+                    <a:solidFill>
+                      <a:srgbClr val="FFFFFF"/>
+                    </a:solidFill>
+                  </a:tcPr>
+                </a:tc>
+                <a:tc>
+                  <a:txBody>
+                    <a:bodyPr/>
+                    <a:lstStyle/>
+                    <a:p>
+                      <a:pPr algn="r" indent="0" marL="0">
+                        <a:buNone/>
+                      </a:pPr>
+                      <a:r>
+                        <a:rPr lang="en-US" sz="1100" dirty="0">
+                          <a:solidFill>
+                            <a:srgbClr val="1F1235"/>
+                          </a:solidFill>
+                          <a:latin typeface="Arial" pitchFamily="34" charset="0"/>
+                          <a:ea typeface="Arial" pitchFamily="34" charset="-122"/>
+                          <a:cs typeface="Arial" pitchFamily="34" charset="-120"/>
+                        </a:rPr>
+                        <a:t>3</a:t>
+                      </a:r>
+                      <a:endParaRPr lang="en-US" sz="1100" dirty="0">
+                        <a:latin typeface="Arial" charset="0"/>
+                        <a:ea typeface="Arial" charset="0"/>
+                        <a:cs typeface="Arial" charset="0"/>
+                      </a:endParaRPr>
+                    </a:p>
+                  </a:txBody>
+                  <a:tcPr marL="54864" marR="54864" marT="54864" marB="54864" anchor="ctr">
+                    <a:lnL w="9525" cap="flat" cmpd="sng" algn="ctr">
+                      <a:solidFill>
+                        <a:srgbClr val="DCD2EC"/>
+                      </a:solidFill>
+                      <a:prstDash val="solid"/>
+                      <a:round/>
+                      <a:headEnd type="none" w="med" len="med"/>
+                      <a:tailEnd type="none" w="med" len="med"/>
+                    </a:lnL>
+                    <a:lnR w="9525" cap="flat" cmpd="sng" algn="ctr">
+                      <a:solidFill>
+                        <a:srgbClr val="DCD2EC"/>
+                      </a:solidFill>
+                      <a:prstDash val="solid"/>
+                      <a:round/>
+                      <a:headEnd type="none" w="med" len="med"/>
+                      <a:tailEnd type="none" w="med" len="med"/>
+                    </a:lnR>
+                    <a:lnT w="9525" cap="flat" cmpd="sng" algn="ctr">
+                      <a:solidFill>
+                        <a:srgbClr val="DCD2EC"/>
+                      </a:solidFill>
+                      <a:prstDash val="solid"/>
+                      <a:round/>
+                      <a:headEnd type="none" w="med" len="med"/>
+                      <a:tailEnd type="none" w="med" len="med"/>
+                    </a:lnT>
+                    <a:lnB w="9525" cap="flat" cmpd="sng" algn="ctr">
+                      <a:solidFill>
+                        <a:srgbClr val="DCD2EC"/>
+                      </a:solidFill>
+                      <a:prstDash val="solid"/>
+                      <a:round/>
+                      <a:headEnd type="none" w="med" len="med"/>
+                      <a:tailEnd type="none" w="med" len="med"/>
+                    </a:lnB>
+                    <a:solidFill>
+                      <a:srgbClr val="FFFFFF"/>
+                    </a:solidFill>
+                  </a:tcPr>
+                </a:tc>
+                <a:tc>
+                  <a:txBody>
+                    <a:bodyPr/>
+                    <a:lstStyle/>
+                    <a:p>
+                      <a:pPr algn="r" indent="0" marL="0">
+                        <a:buNone/>
+                      </a:pPr>
+                      <a:r>
+                        <a:rPr lang="en-US" sz="1100" dirty="0">
+                          <a:solidFill>
+                            <a:srgbClr val="1F1235"/>
+                          </a:solidFill>
+                          <a:latin typeface="Arial" pitchFamily="34" charset="0"/>
+                          <a:ea typeface="Arial" pitchFamily="34" charset="-122"/>
+                          <a:cs typeface="Arial" pitchFamily="34" charset="-120"/>
+                        </a:rPr>
+                        <a:t>1</a:t>
+                      </a:r>
+                      <a:endParaRPr lang="en-US" sz="1100" dirty="0">
+                        <a:latin typeface="Arial" charset="0"/>
+                        <a:ea typeface="Arial" charset="0"/>
+                        <a:cs typeface="Arial" charset="0"/>
+                      </a:endParaRPr>
+                    </a:p>
+                  </a:txBody>
+                  <a:tcPr marL="54864" marR="54864" marT="54864" marB="54864" anchor="ctr">
+                    <a:lnL w="9525" cap="flat" cmpd="sng" algn="ctr">
+                      <a:solidFill>
+                        <a:srgbClr val="DCD2EC"/>
+                      </a:solidFill>
+                      <a:prstDash val="solid"/>
+                      <a:round/>
+                      <a:headEnd type="none" w="med" len="med"/>
+                      <a:tailEnd type="none" w="med" len="med"/>
+                    </a:lnL>
+                    <a:lnR w="9525" cap="flat" cmpd="sng" algn="ctr">
+                      <a:solidFill>
+                        <a:srgbClr val="DCD2EC"/>
+                      </a:solidFill>
+                      <a:prstDash val="solid"/>
+                      <a:round/>
+                      <a:headEnd type="none" w="med" len="med"/>
+                      <a:tailEnd type="none" w="med" len="med"/>
+                    </a:lnR>
+                    <a:lnT w="9525" cap="flat" cmpd="sng" algn="ctr">
+                      <a:solidFill>
+                        <a:srgbClr val="DCD2EC"/>
+                      </a:solidFill>
+                      <a:prstDash val="solid"/>
+                      <a:round/>
+                      <a:headEnd type="none" w="med" len="med"/>
+                      <a:tailEnd type="none" w="med" len="med"/>
+                    </a:lnT>
+                    <a:lnB w="9525" cap="flat" cmpd="sng" algn="ctr">
+                      <a:solidFill>
+                        <a:srgbClr val="DCD2EC"/>
+                      </a:solidFill>
+                      <a:prstDash val="solid"/>
+                      <a:round/>
+                      <a:headEnd type="none" w="med" len="med"/>
+                      <a:tailEnd type="none" w="med" len="med"/>
+                    </a:lnB>
+                    <a:solidFill>
+                      <a:srgbClr val="FFFFFF"/>
+                    </a:solidFill>
+                  </a:tcPr>
+                </a:tc>
+                <a:tc>
+                  <a:txBody>
+                    <a:bodyPr/>
+                    <a:lstStyle/>
+                    <a:p>
+                      <a:pPr algn="r" indent="0" marL="0">
+                        <a:buNone/>
+                      </a:pPr>
+                      <a:r>
+                        <a:rPr lang="en-US" sz="1100" dirty="0">
+                          <a:solidFill>
+                            <a:srgbClr val="1F1235"/>
+                          </a:solidFill>
+                          <a:latin typeface="Arial" pitchFamily="34" charset="0"/>
+                          <a:ea typeface="Arial" pitchFamily="34" charset="-122"/>
+                          <a:cs typeface="Arial" pitchFamily="34" charset="-120"/>
+                        </a:rPr>
+                        <a:t>5</a:t>
+                      </a:r>
+                      <a:endParaRPr lang="en-US" sz="1100" dirty="0">
+                        <a:latin typeface="Arial" charset="0"/>
+                        <a:ea typeface="Arial" charset="0"/>
+                        <a:cs typeface="Arial" charset="0"/>
+                      </a:endParaRPr>
+                    </a:p>
+                  </a:txBody>
+                  <a:tcPr marL="54864" marR="54864" marT="54864" marB="54864" anchor="ctr">
+                    <a:lnL w="9525" cap="flat" cmpd="sng" algn="ctr">
+                      <a:solidFill>
+                        <a:srgbClr val="DCD2EC"/>
+                      </a:solidFill>
+                      <a:prstDash val="solid"/>
+                      <a:round/>
+                      <a:headEnd type="none" w="med" len="med"/>
+                      <a:tailEnd type="none" w="med" len="med"/>
+                    </a:lnL>
+                    <a:lnR w="9525" cap="flat" cmpd="sng" algn="ctr">
+                      <a:solidFill>
+                        <a:srgbClr val="DCD2EC"/>
+                      </a:solidFill>
+                      <a:prstDash val="solid"/>
+                      <a:round/>
+                      <a:headEnd type="none" w="med" len="med"/>
+                      <a:tailEnd type="none" w="med" len="med"/>
+                    </a:lnR>
+                    <a:lnT w="9525" cap="flat" cmpd="sng" algn="ctr">
+                      <a:solidFill>
+                        <a:srgbClr val="DCD2EC"/>
+                      </a:solidFill>
+                      <a:prstDash val="solid"/>
+                      <a:round/>
+                      <a:headEnd type="none" w="med" len="med"/>
+                      <a:tailEnd type="none" w="med" len="med"/>
+                    </a:lnT>
+                    <a:lnB w="9525" cap="flat" cmpd="sng" algn="ctr">
+                      <a:solidFill>
+                        <a:srgbClr val="DCD2EC"/>
+                      </a:solidFill>
+                      <a:prstDash val="solid"/>
+                      <a:round/>
+                      <a:headEnd type="none" w="med" len="med"/>
+                      <a:tailEnd type="none" w="med" len="med"/>
+                    </a:lnB>
+                    <a:solidFill>
+                      <a:srgbClr val="FFFFFF"/>
+                    </a:solidFill>
+                  </a:tcPr>
+                </a:tc>
+                <a:tc>
+                  <a:txBody>
+                    <a:bodyPr/>
+                    <a:lstStyle/>
+                    <a:p>
+                      <a:pPr algn="r" indent="0" marL="0">
+                        <a:buNone/>
+                      </a:pPr>
+                      <a:r>
+                        <a:rPr lang="en-US" sz="1100" dirty="0">
+                          <a:solidFill>
+                            <a:srgbClr val="1F1235"/>
+                          </a:solidFill>
+                          <a:latin typeface="Arial" pitchFamily="34" charset="0"/>
+                          <a:ea typeface="Arial" pitchFamily="34" charset="-122"/>
+                          <a:cs typeface="Arial" pitchFamily="34" charset="-120"/>
+                        </a:rPr>
+                        <a:t>112,0</a:t>
+                      </a:r>
+                      <a:endParaRPr lang="en-US" sz="1100" dirty="0">
+                        <a:latin typeface="Arial" charset="0"/>
+                        <a:ea typeface="Arial" charset="0"/>
+                        <a:cs typeface="Arial" charset="0"/>
+                      </a:endParaRPr>
+                    </a:p>
+                  </a:txBody>
+                  <a:tcPr marL="54864" marR="54864" marT="54864" marB="54864" anchor="ctr">
+                    <a:lnL w="9525" cap="flat" cmpd="sng" algn="ctr">
+                      <a:solidFill>
+                        <a:srgbClr val="DCD2EC"/>
+                      </a:solidFill>
+                      <a:prstDash val="solid"/>
+                      <a:round/>
+                      <a:headEnd type="none" w="med" len="med"/>
+                      <a:tailEnd type="none" w="med" len="med"/>
+                    </a:lnL>
+                    <a:lnR w="9525" cap="flat" cmpd="sng" algn="ctr">
+                      <a:solidFill>
+                        <a:srgbClr val="DCD2EC"/>
+                      </a:solidFill>
+                      <a:prstDash val="solid"/>
+                      <a:round/>
+                      <a:headEnd type="none" w="med" len="med"/>
+                      <a:tailEnd type="none" w="med" len="med"/>
+                    </a:lnR>
+                    <a:lnT w="9525" cap="flat" cmpd="sng" algn="ctr">
+                      <a:solidFill>
+                        <a:srgbClr val="DCD2EC"/>
+                      </a:solidFill>
+                      <a:prstDash val="solid"/>
+                      <a:round/>
+                      <a:headEnd type="none" w="med" len="med"/>
+                      <a:tailEnd type="none" w="med" len="med"/>
+                    </a:lnT>
+                    <a:lnB w="9525" cap="flat" cmpd="sng" algn="ctr">
+                      <a:solidFill>
+                        <a:srgbClr val="DCD2EC"/>
+                      </a:solidFill>
+                      <a:prstDash val="solid"/>
+                      <a:round/>
+                      <a:headEnd type="none" w="med" len="med"/>
+                      <a:tailEnd type="none" w="med" len="med"/>
+                    </a:lnB>
+                    <a:solidFill>
+                      <a:srgbClr val="FFFFFF"/>
+                    </a:solidFill>
+                  </a:tcPr>
+                </a:tc>
+              </a:tr>
+              <a:tr h="329184">
+                <a:tc>
+                  <a:txBody>
+                    <a:bodyPr/>
+                    <a:lstStyle/>
+                    <a:p>
+                      <a:pPr algn="l" indent="0" marL="0">
+                        <a:buNone/>
+                      </a:pPr>
+                      <a:r>
+                        <a:rPr lang="en-US" sz="1100" dirty="0">
+                          <a:solidFill>
+                            <a:srgbClr val="1F1235"/>
+                          </a:solidFill>
+                          <a:latin typeface="Arial" pitchFamily="34" charset="0"/>
+                          <a:ea typeface="Arial" pitchFamily="34" charset="-122"/>
+                          <a:cs typeface="Arial" pitchFamily="34" charset="-120"/>
+                        </a:rPr>
+                        <a:t>Júlia Prado (estagiária)</a:t>
                       </a:r>
                       <a:endParaRPr lang="en-US" sz="1100" dirty="0">
                         <a:latin typeface="Arial" charset="0"/>
@@ -4209,7 +4992,7 @@
                           <a:ea typeface="Arial" pitchFamily="34" charset="-122"/>
                           <a:cs typeface="Arial" pitchFamily="34" charset="-120"/>
                         </a:rPr>
-                        <a:t>19</a:t>
+                        <a:t>1</a:t>
                       </a:r>
                       <a:endParaRPr lang="en-US" sz="1100" dirty="0">
                         <a:latin typeface="Arial" charset="0"/>
@@ -4277,7 +5060,7 @@
                           <a:ea typeface="Arial" pitchFamily="34" charset="-122"/>
                           <a:cs typeface="Arial" pitchFamily="34" charset="-120"/>
                         </a:rPr>
-                        <a:t>128</a:t>
+                        <a:t>0</a:t>
                       </a:r>
                       <a:endParaRPr lang="en-US" sz="1100" dirty="0">
                         <a:latin typeface="Arial" charset="0"/>
@@ -4325,144 +5108,6 @@
                     </a:lnB>
                     <a:solidFill>
                       <a:srgbClr val="F3EEFB"/>
-                    </a:solidFill>
-                  </a:tcPr>
-                </a:tc>
-              </a:tr>
-              <a:tr h="347472">
-                <a:tc>
-                  <a:txBody>
-                    <a:bodyPr/>
-                    <a:lstStyle/>
-                    <a:p>
-                      <a:pPr algn="l" indent="0" marL="0">
-                        <a:buNone/>
-                      </a:pPr>
-                      <a:r>
-                        <a:rPr lang="en-US" sz="1100" dirty="0">
-                          <a:solidFill>
-                            <a:srgbClr val="1F1235"/>
-                          </a:solidFill>
-                          <a:latin typeface="Arial" pitchFamily="34" charset="0"/>
-                          <a:ea typeface="Arial" pitchFamily="34" charset="-122"/>
-                          <a:cs typeface="Arial" pitchFamily="34" charset="-120"/>
-                        </a:rPr>
-                        <a:t>Rafael Lima</a:t>
-                      </a:r>
-                      <a:endParaRPr lang="en-US" sz="1100" dirty="0">
-                        <a:latin typeface="Arial" charset="0"/>
-                        <a:ea typeface="Arial" charset="0"/>
-                        <a:cs typeface="Arial" charset="0"/>
-                      </a:endParaRPr>
-                    </a:p>
-                  </a:txBody>
-                  <a:tcPr marL="54864" marR="54864" marT="54864" marB="54864" anchor="ctr">
-                    <a:lnL w="9525" cap="flat" cmpd="sng" algn="ctr">
-                      <a:solidFill>
-                        <a:srgbClr val="DCD2EC"/>
-                      </a:solidFill>
-                      <a:prstDash val="solid"/>
-                      <a:round/>
-                      <a:headEnd type="none" w="med" len="med"/>
-                      <a:tailEnd type="none" w="med" len="med"/>
-                    </a:lnL>
-                    <a:lnR w="9525" cap="flat" cmpd="sng" algn="ctr">
-                      <a:solidFill>
-                        <a:srgbClr val="DCD2EC"/>
-                      </a:solidFill>
-                      <a:prstDash val="solid"/>
-                      <a:round/>
-                      <a:headEnd type="none" w="med" len="med"/>
-                      <a:tailEnd type="none" w="med" len="med"/>
-                    </a:lnR>
-                    <a:lnT w="9525" cap="flat" cmpd="sng" algn="ctr">
-                      <a:solidFill>
-                        <a:srgbClr val="DCD2EC"/>
-                      </a:solidFill>
-                      <a:prstDash val="solid"/>
-                      <a:round/>
-                      <a:headEnd type="none" w="med" len="med"/>
-                      <a:tailEnd type="none" w="med" len="med"/>
-                    </a:lnT>
-                    <a:lnB w="9525" cap="flat" cmpd="sng" algn="ctr">
-                      <a:solidFill>
-                        <a:srgbClr val="DCD2EC"/>
-                      </a:solidFill>
-                      <a:prstDash val="solid"/>
-                      <a:round/>
-                      <a:headEnd type="none" w="med" len="med"/>
-                      <a:tailEnd type="none" w="med" len="med"/>
-                    </a:lnB>
-                    <a:solidFill>
-                      <a:srgbClr val="FFFFFF"/>
-                    </a:solidFill>
-                  </a:tcPr>
-                </a:tc>
-                <a:tc>
-                  <a:txBody>
-                    <a:bodyPr/>
-                    <a:lstStyle/>
-                    <a:p>
-                      <a:pPr algn="r" indent="0" marL="0">
-                        <a:buNone/>
-                      </a:pPr>
-                      <a:r>
-                        <a:rPr lang="en-US" sz="1100" dirty="0">
-                          <a:solidFill>
-                            <a:srgbClr val="1F1235"/>
-                          </a:solidFill>
-                          <a:latin typeface="Arial" pitchFamily="34" charset="0"/>
-                          <a:ea typeface="Arial" pitchFamily="34" charset="-122"/>
-                          <a:cs typeface="Arial" pitchFamily="34" charset="-120"/>
-                        </a:rPr>
-                        <a:t>6</a:t>
-                      </a:r>
-                      <a:endParaRPr lang="en-US" sz="1100" dirty="0">
-                        <a:latin typeface="Arial" charset="0"/>
-                        <a:ea typeface="Arial" charset="0"/>
-                        <a:cs typeface="Arial" charset="0"/>
-                      </a:endParaRPr>
-                    </a:p>
-                  </a:txBody>
-                  <a:tcPr marL="54864" marR="54864" marT="54864" marB="54864" anchor="ctr">
-                    <a:lnL w="9525" cap="flat" cmpd="sng" algn="ctr">
-                      <a:solidFill>
-                        <a:srgbClr val="DCD2EC"/>
-                      </a:solidFill>
-                      <a:prstDash val="solid"/>
-                      <a:round/>
-                      <a:headEnd type="none" w="med" len="med"/>
-                      <a:tailEnd type="none" w="med" len="med"/>
-                    </a:lnL>
-                    <a:lnR w="9525" cap="flat" cmpd="sng" algn="ctr">
-                      <a:solidFill>
-                        <a:srgbClr val="DCD2EC"/>
-                      </a:solidFill>
-                      <a:prstDash val="solid"/>
-                      <a:round/>
-                      <a:headEnd type="none" w="med" len="med"/>
-                      <a:tailEnd type="none" w="med" len="med"/>
-                    </a:lnR>
-                    <a:lnT w="9525" cap="flat" cmpd="sng" algn="ctr">
-                      <a:solidFill>
-                        <a:srgbClr val="DCD2EC"/>
-                      </a:solidFill>
-                      <a:prstDash val="solid"/>
-                      <a:round/>
-                      <a:headEnd type="none" w="med" len="med"/>
-                      <a:tailEnd type="none" w="med" len="med"/>
-                    </a:lnT>
-                    <a:lnB w="9525" cap="flat" cmpd="sng" algn="ctr">
-                      <a:solidFill>
-                        <a:srgbClr val="DCD2EC"/>
-                      </a:solidFill>
-                      <a:prstDash val="solid"/>
-                      <a:round/>
-                      <a:headEnd type="none" w="med" len="med"/>
-                      <a:tailEnd type="none" w="med" len="med"/>
-                    </a:lnB>
-                    <a:solidFill>
-                      <a:srgbClr val="FFFFFF"/>
                     </a:solidFill>
                   </a:tcPr>
                 </a:tc>
@@ -4530,7 +5175,7 @@
                       <a:tailEnd type="none" w="med" len="med"/>
                     </a:lnB>
                     <a:solidFill>
-                      <a:srgbClr val="FFFFFF"/>
+                      <a:srgbClr val="F3EEFB"/>
                     </a:solidFill>
                   </a:tcPr>
                 </a:tc>
@@ -4551,7 +5196,7 @@
                           <a:ea typeface="Arial" pitchFamily="34" charset="-122"/>
                           <a:cs typeface="Arial" pitchFamily="34" charset="-120"/>
                         </a:rPr>
-                        <a:t>11</a:t>
+                        <a:t>80,5</a:t>
                       </a:r>
                       <a:endParaRPr lang="en-US" sz="1100" dirty="0">
                         <a:latin typeface="Arial" charset="0"/>
@@ -4598,80 +5243,12 @@
                       <a:tailEnd type="none" w="med" len="med"/>
                     </a:lnB>
                     <a:solidFill>
-                      <a:srgbClr val="FFFFFF"/>
-                    </a:solidFill>
-                  </a:tcPr>
-                </a:tc>
-                <a:tc>
-                  <a:txBody>
-                    <a:bodyPr/>
-                    <a:lstStyle/>
-                    <a:p>
-                      <a:pPr algn="r" indent="0" marL="0">
-                        <a:buNone/>
-                      </a:pPr>
-                      <a:r>
-                        <a:rPr lang="en-US" sz="1100" dirty="0">
-                          <a:solidFill>
-                            <a:srgbClr val="1F1235"/>
-                          </a:solidFill>
-                          <a:latin typeface="Arial" pitchFamily="34" charset="0"/>
-                          <a:ea typeface="Arial" pitchFamily="34" charset="-122"/>
-                          <a:cs typeface="Arial" pitchFamily="34" charset="-120"/>
-                        </a:rPr>
-                        <a:t>118</a:t>
-                      </a:r>
-                      <a:endParaRPr lang="en-US" sz="1100" dirty="0">
-                        <a:latin typeface="Arial" charset="0"/>
-                        <a:ea typeface="Arial" charset="0"/>
-                        <a:cs typeface="Arial" charset="0"/>
-                      </a:endParaRPr>
-                    </a:p>
-                  </a:txBody>
-                  <a:tcPr marL="54864" marR="54864" marT="54864" marB="54864" anchor="ctr">
-                    <a:lnL w="9525" cap="flat" cmpd="sng" algn="ctr">
-                      <a:solidFill>
-                        <a:srgbClr val="DCD2EC"/>
-                      </a:solidFill>
-                      <a:prstDash val="solid"/>
-                      <a:round/>
-                      <a:headEnd type="none" w="med" len="med"/>
-                      <a:tailEnd type="none" w="med" len="med"/>
-                    </a:lnL>
-                    <a:lnR w="9525" cap="flat" cmpd="sng" algn="ctr">
-                      <a:solidFill>
-                        <a:srgbClr val="DCD2EC"/>
-                      </a:solidFill>
-                      <a:prstDash val="solid"/>
-                      <a:round/>
-                      <a:headEnd type="none" w="med" len="med"/>
-                      <a:tailEnd type="none" w="med" len="med"/>
-                    </a:lnR>
-                    <a:lnT w="9525" cap="flat" cmpd="sng" algn="ctr">
-                      <a:solidFill>
-                        <a:srgbClr val="DCD2EC"/>
-                      </a:solidFill>
-                      <a:prstDash val="solid"/>
-                      <a:round/>
-                      <a:headEnd type="none" w="med" len="med"/>
-                      <a:tailEnd type="none" w="med" len="med"/>
-                    </a:lnT>
-                    <a:lnB w="9525" cap="flat" cmpd="sng" algn="ctr">
-                      <a:solidFill>
-                        <a:srgbClr val="DCD2EC"/>
-                      </a:solidFill>
-                      <a:prstDash val="solid"/>
-                      <a:round/>
-                      <a:headEnd type="none" w="med" len="med"/>
-                      <a:tailEnd type="none" w="med" len="med"/>
-                    </a:lnB>
-                    <a:solidFill>
-                      <a:srgbClr val="FFFFFF"/>
+                      <a:srgbClr val="F3EEFB"/>
                     </a:solidFill>
                   </a:tcPr>
                 </a:tc>
               </a:tr>
-              <a:tr h="347472">
+              <a:tr h="329184">
                 <a:tc>
                   <a:txBody>
                     <a:bodyPr/>
@@ -4736,7 +5313,7 @@
                       <a:tailEnd type="none" w="med" len="med"/>
                     </a:lnB>
                     <a:solidFill>
-                      <a:srgbClr val="F3EEFB"/>
+                      <a:srgbClr val="FFFFFF"/>
                     </a:solidFill>
                   </a:tcPr>
                 </a:tc>
@@ -4757,7 +5334,7 @@
                           <a:ea typeface="Arial" pitchFamily="34" charset="-122"/>
                           <a:cs typeface="Arial" pitchFamily="34" charset="-120"/>
                         </a:rPr>
-                        <a:t>13</a:t>
+                        <a:t>36</a:t>
                       </a:r>
                       <a:endParaRPr lang="en-US" sz="1100" dirty="0">
                         <a:latin typeface="Arial" charset="0"/>
@@ -4804,7 +5381,7 @@
                       <a:tailEnd type="none" w="med" len="med"/>
                     </a:lnB>
                     <a:solidFill>
-                      <a:srgbClr val="F3EEFB"/>
+                      <a:srgbClr val="FFFFFF"/>
                     </a:solidFill>
                   </a:tcPr>
                 </a:tc>
@@ -4872,7 +5449,7 @@
                       <a:tailEnd type="none" w="med" len="med"/>
                     </a:lnB>
                     <a:solidFill>
-                      <a:srgbClr val="F3EEFB"/>
+                      <a:srgbClr val="FFFFFF"/>
                     </a:solidFill>
                   </a:tcPr>
                 </a:tc>
@@ -4893,7 +5470,7 @@
                           <a:ea typeface="Arial" pitchFamily="34" charset="-122"/>
                           <a:cs typeface="Arial" pitchFamily="34" charset="-120"/>
                         </a:rPr>
-                        <a:t>30</a:t>
+                        <a:t>3</a:t>
                       </a:r>
                       <a:endParaRPr lang="en-US" sz="1100" dirty="0">
                         <a:latin typeface="Arial" charset="0"/>
@@ -4940,7 +5517,7 @@
                       <a:tailEnd type="none" w="med" len="med"/>
                     </a:lnB>
                     <a:solidFill>
-                      <a:srgbClr val="F3EEFB"/>
+                      <a:srgbClr val="FFFFFF"/>
                     </a:solidFill>
                   </a:tcPr>
                 </a:tc>
@@ -4961,7 +5538,7 @@
                           <a:ea typeface="Arial" pitchFamily="34" charset="-122"/>
                           <a:cs typeface="Arial" pitchFamily="34" charset="-120"/>
                         </a:rPr>
-                        <a:t>318</a:t>
+                        <a:t>11</a:t>
                       </a:r>
                       <a:endParaRPr lang="en-US" sz="1100" dirty="0">
                         <a:latin typeface="Arial" charset="0"/>
@@ -5008,7 +5585,75 @@
                       <a:tailEnd type="none" w="med" len="med"/>
                     </a:lnB>
                     <a:solidFill>
-                      <a:srgbClr val="F3EEFB"/>
+                      <a:srgbClr val="FFFFFF"/>
+                    </a:solidFill>
+                  </a:tcPr>
+                </a:tc>
+                <a:tc>
+                  <a:txBody>
+                    <a:bodyPr/>
+                    <a:lstStyle/>
+                    <a:p>
+                      <a:pPr algn="r" indent="0" marL="0">
+                        <a:buNone/>
+                      </a:pPr>
+                      <a:r>
+                        <a:rPr lang="en-US" sz="1100" b="1" dirty="0">
+                          <a:solidFill>
+                            <a:srgbClr val="1F1235"/>
+                          </a:solidFill>
+                          <a:latin typeface="Arial" pitchFamily="34" charset="0"/>
+                          <a:ea typeface="Arial" pitchFamily="34" charset="-122"/>
+                          <a:cs typeface="Arial" pitchFamily="34" charset="-120"/>
+                        </a:rPr>
+                        <a:t>304,0</a:t>
+                      </a:r>
+                      <a:endParaRPr lang="en-US" sz="1100" dirty="0">
+                        <a:latin typeface="Arial" charset="0"/>
+                        <a:ea typeface="Arial" charset="0"/>
+                        <a:cs typeface="Arial" charset="0"/>
+                      </a:endParaRPr>
+                    </a:p>
+                  </a:txBody>
+                  <a:tcPr marL="54864" marR="54864" marT="54864" marB="54864" anchor="ctr">
+                    <a:lnL w="9525" cap="flat" cmpd="sng" algn="ctr">
+                      <a:solidFill>
+                        <a:srgbClr val="DCD2EC"/>
+                      </a:solidFill>
+                      <a:prstDash val="solid"/>
+                      <a:round/>
+                      <a:headEnd type="none" w="med" len="med"/>
+                      <a:tailEnd type="none" w="med" len="med"/>
+                    </a:lnL>
+                    <a:lnR w="9525" cap="flat" cmpd="sng" algn="ctr">
+                      <a:solidFill>
+                        <a:srgbClr val="DCD2EC"/>
+                      </a:solidFill>
+                      <a:prstDash val="solid"/>
+                      <a:round/>
+                      <a:headEnd type="none" w="med" len="med"/>
+                      <a:tailEnd type="none" w="med" len="med"/>
+                    </a:lnR>
+                    <a:lnT w="9525" cap="flat" cmpd="sng" algn="ctr">
+                      <a:solidFill>
+                        <a:srgbClr val="DCD2EC"/>
+                      </a:solidFill>
+                      <a:prstDash val="solid"/>
+                      <a:round/>
+                      <a:headEnd type="none" w="med" len="med"/>
+                      <a:tailEnd type="none" w="med" len="med"/>
+                    </a:lnT>
+                    <a:lnB w="9525" cap="flat" cmpd="sng" algn="ctr">
+                      <a:solidFill>
+                        <a:srgbClr val="DCD2EC"/>
+                      </a:solidFill>
+                      <a:prstDash val="solid"/>
+                      <a:round/>
+                      <a:headEnd type="none" w="med" len="med"/>
+                      <a:tailEnd type="none" w="med" len="med"/>
+                    </a:lnB>
+                    <a:solidFill>
+                      <a:srgbClr val="FFFFFF"/>
                     </a:solidFill>
                   </a:tcPr>
                 </a:tc>
@@ -5025,8 +5670,8 @@
         </p:nvSpPr>
         <p:spPr>
           <a:xfrm>
-            <a:off x="457200" y="4160520"/>
-            <a:ext cx="8229600" cy="411480"/>
+            <a:off x="457200" y="4553712"/>
+            <a:ext cx="7680960" cy="457200"/>
           </a:xfrm>
           <a:prstGeom prst="rect">
             <a:avLst/>
@@ -5035,14 +5680,14 @@
           <a:ln/>
         </p:spPr>
         <p:txBody>
-          <a:bodyPr wrap="square" lIns="0" tIns="0" rIns="0" bIns="0" rtlCol="0" anchor="ctr"/>
+          <a:bodyPr wrap="square" lIns="0" tIns="0" rIns="0" bIns="0" rtlCol="0" anchor="t"/>
           <a:lstStyle/>
           <a:p>
             <a:pPr indent="0" marL="0">
               <a:buNone/>
             </a:pPr>
             <a:r>
-              <a:rPr lang="en-US" sz="1100" dirty="0">
+              <a:rPr lang="en-US" sz="1000" dirty="0">
                 <a:solidFill>
                   <a:srgbClr val="5A4A78"/>
                 </a:solidFill>
@@ -5050,156 +5695,11 @@
                 <a:ea typeface="Arial" pitchFamily="34" charset="-122"/>
                 <a:cs typeface="Arial" pitchFamily="34" charset="-120"/>
               </a:rPr>
-              <a:t>Das 318 horas, 72 são da estagiária. Casos ativos por fase: 6 iniciais, 1 em instrução, 4 em sentença, 5 em recurso, 2 em execução, 8 em acordo e 4 consultivos.</a:t>
+              <a:t>Casos ativos por fase (02): 7 consultivos, 8 iniciais, 4 em instrução, 3 em sentença, 3 em recurso, 3 em execução e 2 em acordo. Quatro parados há mais de 30 dias.</a:t>
             </a:r>
-            <a:endParaRPr lang="en-US" sz="1100" dirty="0"/>
+            <a:endParaRPr lang="en-US" sz="1000" dirty="0"/>
           </a:p>
         </p:txBody>
-      </p:sp>
-      <p:sp>
-        <p:nvSpPr>
-          <p:cNvPr id="15" name="Text 12"/>
-          <p:cNvSpPr txBox="1"/>
-          <p:nvPr/>
-        </p:nvSpPr>
-        <p:spPr>
-          <a:xfrm>
-            <a:off x="457200" y="4791456"/>
-            <a:ext cx="6858000" cy="201168"/>
-          </a:xfrm>
-          <a:prstGeom prst="rect">
-            <a:avLst/>
-          </a:prstGeom>
-          <a:noFill/>
-          <a:ln/>
-        </p:spPr>
-        <p:txBody>
-          <a:bodyPr wrap="square" lIns="0" tIns="0" rIns="0" bIns="0" rtlCol="0" anchor="ctr"/>
-          <a:lstStyle/>
-          <a:p>
-            <a:pPr indent="0" marL="0">
-              <a:buNone/>
-            </a:pPr>
-            <a:r>
-              <a:rPr lang="en-US" sz="700" dirty="0">
-                <a:solidFill>
-                  <a:srgbClr val="B89BE0"/>
-                </a:solidFill>
-                <a:latin typeface="Arial" pitchFamily="34" charset="0"/>
-                <a:ea typeface="Arial" pitchFamily="34" charset="-122"/>
-                <a:cs typeface="Arial" pitchFamily="34" charset="-120"/>
-              </a:rPr>
-              <a:t>Kit de Gestão para Advogados · modelo v1.0 · set/2026</a:t>
-            </a:r>
-            <a:endParaRPr lang="en-US" sz="700" dirty="0"/>
-          </a:p>
-        </p:txBody>
-      </p:sp>
-      <p:sp>
-        <p:nvSpPr>
-          <p:cNvPr id="16" name="Shape 13"/>
-          <p:cNvSpPr/>
-          <p:nvPr/>
-        </p:nvSpPr>
-        <p:spPr>
-          <a:xfrm>
-            <a:off x="8229600" y="4818888"/>
-            <a:ext cx="211226" cy="70409"/>
-          </a:xfrm>
-          <a:prstGeom prst="roundRect">
-            <a:avLst>
-              <a:gd name="adj" fmla="val 42857"/>
-            </a:avLst>
-          </a:prstGeom>
-          <a:solidFill>
-            <a:srgbClr val="7A5AA8"/>
-          </a:solidFill>
-          <a:ln w="12700">
-            <a:solidFill>
-              <a:srgbClr val="7A5AA8"/>
-            </a:solidFill>
-            <a:prstDash val="solid"/>
-          </a:ln>
-        </p:spPr>
-      </p:sp>
-      <p:sp>
-        <p:nvSpPr>
-          <p:cNvPr id="17" name="Shape 14"/>
-          <p:cNvSpPr/>
-          <p:nvPr/>
-        </p:nvSpPr>
-        <p:spPr>
-          <a:xfrm>
-            <a:off x="8279892" y="4728362"/>
-            <a:ext cx="211226" cy="70409"/>
-          </a:xfrm>
-          <a:prstGeom prst="roundRect">
-            <a:avLst>
-              <a:gd name="adj" fmla="val 42857"/>
-            </a:avLst>
-          </a:prstGeom>
-          <a:solidFill>
-            <a:srgbClr val="3B1F5E"/>
-          </a:solidFill>
-          <a:ln w="12700">
-            <a:solidFill>
-              <a:srgbClr val="3B1F5E"/>
-            </a:solidFill>
-            <a:prstDash val="solid"/>
-          </a:ln>
-        </p:spPr>
-      </p:sp>
-      <p:sp>
-        <p:nvSpPr>
-          <p:cNvPr id="18" name="Shape 15"/>
-          <p:cNvSpPr/>
-          <p:nvPr/>
-        </p:nvSpPr>
-        <p:spPr>
-          <a:xfrm>
-            <a:off x="8330184" y="4637837"/>
-            <a:ext cx="211226" cy="70409"/>
-          </a:xfrm>
-          <a:prstGeom prst="roundRect">
-            <a:avLst>
-              <a:gd name="adj" fmla="val 42857"/>
-            </a:avLst>
-          </a:prstGeom>
-          <a:solidFill>
-            <a:srgbClr val="3B1F5E"/>
-          </a:solidFill>
-          <a:ln w="12700">
-            <a:solidFill>
-              <a:srgbClr val="3B1F5E"/>
-            </a:solidFill>
-            <a:prstDash val="solid"/>
-          </a:ln>
-        </p:spPr>
-      </p:sp>
-      <p:sp>
-        <p:nvSpPr>
-          <p:cNvPr id="19" name="Shape 16"/>
-          <p:cNvSpPr/>
-          <p:nvPr/>
-        </p:nvSpPr>
-        <p:spPr>
-          <a:xfrm>
-            <a:off x="8541410" y="4839005"/>
-            <a:ext cx="65380" cy="65380"/>
-          </a:xfrm>
-          <a:prstGeom prst="ellipse">
-            <a:avLst/>
-          </a:prstGeom>
-          <a:solidFill>
-            <a:srgbClr val="FFC83D"/>
-          </a:solidFill>
-          <a:ln w="12700">
-            <a:solidFill>
-              <a:srgbClr val="FFC83D"/>
-            </a:solidFill>
-            <a:prstDash val="solid"/>
-          </a:ln>
-        </p:spPr>
       </p:sp>
     </p:spTree>
   </p:cSld>
@@ -5212,13 +5712,6 @@
 <file path=ppt/slides/slide4.xml><?xml version="1.0" encoding="utf-8"?>
 <p:sld xmlns:a="http://schemas.openxmlformats.org/drawingml/2006/main" xmlns:r="http://schemas.openxmlformats.org/officeDocument/2006/relationships" xmlns:p="http://schemas.openxmlformats.org/presentationml/2006/main">
   <p:cSld name="Slide 4">
-    <p:bg>
-      <p:bgPr>
-        <a:solidFill>
-          <a:srgbClr val="FFFFFF"/>
-        </a:solidFill>
-      </p:bgPr>
-    </p:bg>
     <p:spTree>
       <p:nvGrpSpPr>
         <p:cNvPr id="1" name=""/>
@@ -5268,7 +5761,7 @@
                 <a:ea typeface="Arial" pitchFamily="34" charset="-122"/>
                 <a:cs typeface="Arial" pitchFamily="34" charset="-120"/>
               </a:rPr>
-              <a:t>Horas × faturado por sócio</a:t>
+              <a:t>Horas de agosto contra a meta e o custo-hora</a:t>
             </a:r>
             <a:endParaRPr lang="en-US" sz="2400" dirty="0"/>
           </a:p>
@@ -5307,7 +5800,7 @@
                 <a:ea typeface="Arial" pitchFamily="34" charset="-122"/>
                 <a:cs typeface="Arial" pitchFamily="34" charset="-120"/>
               </a:rPr>
-              <a:t>Receita do mês por hora faturável, comparada ao custo-hora do escritório (planilha 05).</a:t>
+              <a:t>Horas por caso e por pessoa (16) e Custo-hora do escritório (05).</a:t>
             </a:r>
             <a:endParaRPr lang="en-US" sz="1200" dirty="0"/>
           </a:p>
@@ -5321,7 +5814,7 @@
         </p:nvGraphicFramePr>
         <p:xfrm>
           <a:off x="457200" y="1463040"/>
-          <a:ext cx="3931920" cy="3017520"/>
+          <a:ext cx="4023360" cy="3017520"/>
         </p:xfrm>
         <a:graphic xmlns:a="http://schemas.openxmlformats.org/drawingml/2006/main">
           <a:graphicData uri="http://schemas.openxmlformats.org/drawingml/2006/chart">
@@ -5344,7 +5837,7 @@
           </p:nvPr>
         </p:nvGraphicFramePr>
         <p:xfrm>
-          <a:off x="4572000" y="1508760"/>
+          <a:off x="4663440" y="1508760"/>
           <a:ext cx="4114800" cy="914400"/>
         </p:xfrm>
         <a:graphic>
@@ -5352,11 +5845,11 @@
             <a:tbl>
               <a:tblPr/>
               <a:tblGrid>
-                <a:gridCol w="1371600"/>
+                <a:gridCol w="1325880"/>
+                <a:gridCol w="640080"/>
+                <a:gridCol w="777240"/>
                 <a:gridCol w="594360"/>
                 <a:gridCol w="777240"/>
-                <a:gridCol w="777240"/>
-                <a:gridCol w="594360"/>
               </a:tblGrid>
               <a:tr h="365760">
                 <a:tc>
@@ -5580,7 +6073,7 @@
                           <a:ea typeface="Arial" pitchFamily="34" charset="-122"/>
                           <a:cs typeface="Arial" pitchFamily="34" charset="-120"/>
                         </a:rPr>
-                        <a:t>Entrou</a:t>
+                        <a:t>% fat.</a:t>
                       </a:r>
                       <a:endParaRPr lang="en-US" sz="950" dirty="0">
                         <a:latin typeface="Arial" charset="0"/>
@@ -5648,7 +6141,7 @@
                           <a:ea typeface="Arial" pitchFamily="34" charset="-122"/>
                           <a:cs typeface="Arial" pitchFamily="34" charset="-120"/>
                         </a:rPr>
-                        <a:t>R$/h</a:t>
+                        <a:t>Custo-hora</a:t>
                       </a:r>
                       <a:endParaRPr lang="en-US" sz="950" dirty="0">
                         <a:latin typeface="Arial" charset="0"/>
@@ -5786,7 +6279,7 @@
                           <a:ea typeface="Arial" pitchFamily="34" charset="-122"/>
                           <a:cs typeface="Arial" pitchFamily="34" charset="-120"/>
                         </a:rPr>
-                        <a:t>128</a:t>
+                        <a:t>111,5</a:t>
                       </a:r>
                       <a:endParaRPr lang="en-US" sz="950" dirty="0">
                         <a:latin typeface="Arial" charset="0"/>
@@ -5854,7 +6347,7 @@
                           <a:ea typeface="Arial" pitchFamily="34" charset="-122"/>
                           <a:cs typeface="Arial" pitchFamily="34" charset="-120"/>
                         </a:rPr>
-                        <a:t>96</a:t>
+                        <a:t>101,5</a:t>
                       </a:r>
                       <a:endParaRPr lang="en-US" sz="950" dirty="0">
                         <a:latin typeface="Arial" charset="0"/>
@@ -5922,7 +6415,7 @@
                           <a:ea typeface="Arial" pitchFamily="34" charset="-122"/>
                           <a:cs typeface="Arial" pitchFamily="34" charset="-120"/>
                         </a:rPr>
-                        <a:t>19.100</a:t>
+                        <a:t>91 %</a:t>
                       </a:r>
                       <a:endParaRPr lang="en-US" sz="950" dirty="0">
                         <a:latin typeface="Arial" charset="0"/>
@@ -5990,7 +6483,7 @@
                           <a:ea typeface="Arial" pitchFamily="34" charset="-122"/>
                           <a:cs typeface="Arial" pitchFamily="34" charset="-120"/>
                         </a:rPr>
-                        <a:t>199</a:t>
+                        <a:t>R$ 72,76</a:t>
                       </a:r>
                       <a:endParaRPr lang="en-US" sz="950" dirty="0">
                         <a:latin typeface="Arial" charset="0"/>
@@ -6128,7 +6621,7 @@
                           <a:ea typeface="Arial" pitchFamily="34" charset="-122"/>
                           <a:cs typeface="Arial" pitchFamily="34" charset="-120"/>
                         </a:rPr>
-                        <a:t>118</a:t>
+                        <a:t>112,0</a:t>
                       </a:r>
                       <a:endParaRPr lang="en-US" sz="950" dirty="0">
                         <a:latin typeface="Arial" charset="0"/>
@@ -6196,7 +6689,7 @@
                           <a:ea typeface="Arial" pitchFamily="34" charset="-122"/>
                           <a:cs typeface="Arial" pitchFamily="34" charset="-120"/>
                         </a:rPr>
-                        <a:t>88</a:t>
+                        <a:t>88,0</a:t>
                       </a:r>
                       <a:endParaRPr lang="en-US" sz="950" dirty="0">
                         <a:latin typeface="Arial" charset="0"/>
@@ -6264,7 +6757,7 @@
                           <a:ea typeface="Arial" pitchFamily="34" charset="-122"/>
                           <a:cs typeface="Arial" pitchFamily="34" charset="-120"/>
                         </a:rPr>
-                        <a:t>10.300</a:t>
+                        <a:t>79 %</a:t>
                       </a:r>
                       <a:endParaRPr lang="en-US" sz="950" dirty="0">
                         <a:latin typeface="Arial" charset="0"/>
@@ -6332,7 +6825,7 @@
                           <a:ea typeface="Arial" pitchFamily="34" charset="-122"/>
                           <a:cs typeface="Arial" pitchFamily="34" charset="-120"/>
                         </a:rPr>
-                        <a:t>117</a:t>
+                        <a:t>R$ 72,76</a:t>
                       </a:r>
                       <a:endParaRPr lang="en-US" sz="950" dirty="0">
                         <a:latin typeface="Arial" charset="0"/>
@@ -6470,7 +6963,7 @@
                           <a:ea typeface="Arial" pitchFamily="34" charset="-122"/>
                           <a:cs typeface="Arial" pitchFamily="34" charset="-120"/>
                         </a:rPr>
-                        <a:t>72</a:t>
+                        <a:t>80,5</a:t>
                       </a:r>
                       <a:endParaRPr lang="en-US" sz="950" dirty="0">
                         <a:latin typeface="Arial" charset="0"/>
@@ -6538,7 +7031,7 @@
                           <a:ea typeface="Arial" pitchFamily="34" charset="-122"/>
                           <a:cs typeface="Arial" pitchFamily="34" charset="-120"/>
                         </a:rPr>
-                        <a:t>42</a:t>
+                        <a:t>58,5</a:t>
                       </a:r>
                       <a:endParaRPr lang="en-US" sz="950" dirty="0">
                         <a:latin typeface="Arial" charset="0"/>
@@ -6606,7 +7099,7 @@
                           <a:ea typeface="Arial" pitchFamily="34" charset="-122"/>
                           <a:cs typeface="Arial" pitchFamily="34" charset="-120"/>
                         </a:rPr>
-                        <a:t>—</a:t>
+                        <a:t>73 %</a:t>
                       </a:r>
                       <a:endParaRPr lang="en-US" sz="950" dirty="0">
                         <a:latin typeface="Arial" charset="0"/>
@@ -6674,7 +7167,7 @@
                           <a:ea typeface="Arial" pitchFamily="34" charset="-122"/>
                           <a:cs typeface="Arial" pitchFamily="34" charset="-120"/>
                         </a:rPr>
-                        <a:t>—</a:t>
+                        <a:t>R$ 41,55</a:t>
                       </a:r>
                       <a:endParaRPr lang="en-US" sz="950" dirty="0">
                         <a:latin typeface="Arial" charset="0"/>
@@ -6744,7 +7237,7 @@
                           <a:ea typeface="Arial" pitchFamily="34" charset="-122"/>
                           <a:cs typeface="Arial" pitchFamily="34" charset="-120"/>
                         </a:rPr>
-                        <a:t>Total</a:t>
+                        <a:t>Escritório</a:t>
                       </a:r>
                       <a:endParaRPr lang="en-US" sz="950" dirty="0">
                         <a:latin typeface="Arial" charset="0"/>
@@ -6812,7 +7305,7 @@
                           <a:ea typeface="Arial" pitchFamily="34" charset="-122"/>
                           <a:cs typeface="Arial" pitchFamily="34" charset="-120"/>
                         </a:rPr>
-                        <a:t>318</a:t>
+                        <a:t>304,0</a:t>
                       </a:r>
                       <a:endParaRPr lang="en-US" sz="950" dirty="0">
                         <a:latin typeface="Arial" charset="0"/>
@@ -6880,7 +7373,7 @@
                           <a:ea typeface="Arial" pitchFamily="34" charset="-122"/>
                           <a:cs typeface="Arial" pitchFamily="34" charset="-120"/>
                         </a:rPr>
-                        <a:t>226</a:t>
+                        <a:t>248,0</a:t>
                       </a:r>
                       <a:endParaRPr lang="en-US" sz="950" dirty="0">
                         <a:latin typeface="Arial" charset="0"/>
@@ -6948,7 +7441,7 @@
                           <a:ea typeface="Arial" pitchFamily="34" charset="-122"/>
                           <a:cs typeface="Arial" pitchFamily="34" charset="-120"/>
                         </a:rPr>
-                        <a:t>29.400</a:t>
+                        <a:t>82 %</a:t>
                       </a:r>
                       <a:endParaRPr lang="en-US" sz="950" dirty="0">
                         <a:latin typeface="Arial" charset="0"/>
@@ -7016,7 +7509,7 @@
                           <a:ea typeface="Arial" pitchFamily="34" charset="-122"/>
                           <a:cs typeface="Arial" pitchFamily="34" charset="-120"/>
                         </a:rPr>
-                        <a:t>130</a:t>
+                        <a:t>R$ 66,07</a:t>
                       </a:r>
                       <a:endParaRPr lang="en-US" sz="950" dirty="0">
                         <a:latin typeface="Arial" charset="0"/>
@@ -7080,8 +7573,8 @@
         </p:nvSpPr>
         <p:spPr>
           <a:xfrm>
-            <a:off x="4572000" y="3291840"/>
-            <a:ext cx="4114800" cy="1280160"/>
+            <a:off x="4663440" y="3291840"/>
+            <a:ext cx="4023360" cy="1371600"/>
           </a:xfrm>
           <a:prstGeom prst="rect">
             <a:avLst/>
@@ -7100,7 +7593,7 @@
               <a:buNone/>
             </a:pPr>
             <a:r>
-              <a:rPr lang="en-US" sz="1050" b="1" dirty="0">
+              <a:rPr lang="en-US" sz="1000" b="1" dirty="0">
                 <a:solidFill>
                   <a:srgbClr val="3B1F5E"/>
                 </a:solidFill>
@@ -7110,7 +7603,7 @@
               </a:rPr>
               <a:t>Leitura</a:t>
             </a:r>
-            <a:endParaRPr lang="en-US" sz="1050" dirty="0"/>
+            <a:endParaRPr lang="en-US" sz="1000" dirty="0"/>
           </a:p>
           <a:p>
             <a:pPr marL="342900" indent="-342900">
@@ -7121,7 +7614,7 @@
               <a:buChar char="•"/>
             </a:pPr>
             <a:r>
-              <a:rPr lang="en-US" sz="1050" dirty="0">
+              <a:rPr lang="en-US" sz="1000" dirty="0">
                 <a:solidFill>
                   <a:srgbClr val="1F1235"/>
                 </a:solidFill>
@@ -7129,9 +7622,9 @@
                 <a:ea typeface="Arial" pitchFamily="34" charset="-122"/>
                 <a:cs typeface="Arial" pitchFamily="34" charset="-120"/>
               </a:rPr>
-              <a:t>12 casos ativos já passaram das horas estimadas (8 da Marina, 4 do Rafael): candidatos a revisão de honorário ou aditivo.</a:t>
+              <a:t>Custo-hora do escritório R$ 66,07 (R$ 18.500 ÷ 280 h faturáveis) e hora mínima a cobrar R$ 110 (planilha 05).</a:t>
             </a:r>
-            <a:endParaRPr lang="en-US" sz="1050" dirty="0"/>
+            <a:endParaRPr lang="en-US" sz="1000" dirty="0"/>
           </a:p>
           <a:p>
             <a:pPr marL="342900" indent="-342900">
@@ -7142,7 +7635,7 @@
               <a:buChar char="•"/>
             </a:pPr>
             <a:r>
-              <a:rPr lang="en-US" sz="1050" dirty="0">
+              <a:rPr lang="en-US" sz="1000" dirty="0">
                 <a:solidFill>
                   <a:srgbClr val="1F1235"/>
                 </a:solidFill>
@@ -7150,156 +7643,11 @@
                 <a:ea typeface="Arial" pitchFamily="34" charset="-122"/>
                 <a:cs typeface="Arial" pitchFamily="34" charset="-120"/>
               </a:rPr>
-              <a:t>Custo-hora dos sócios de R$ 73, calculado na planilha 05 (custo direto + rateio dos fixos ÷ horas faturáveis).</a:t>
+              <a:t>Dois casos ativos já passaram das horas estimadas (16): Bistrô 42, 50 h para 45, êxito sem nada recebido; Escola Aurora, 100 h para 90.</a:t>
             </a:r>
-            <a:endParaRPr lang="en-US" sz="1050" dirty="0"/>
+            <a:endParaRPr lang="en-US" sz="1000" dirty="0"/>
           </a:p>
         </p:txBody>
-      </p:sp>
-      <p:sp>
-        <p:nvSpPr>
-          <p:cNvPr id="7" name="Text 3"/>
-          <p:cNvSpPr txBox="1"/>
-          <p:nvPr/>
-        </p:nvSpPr>
-        <p:spPr>
-          <a:xfrm>
-            <a:off x="457200" y="4791456"/>
-            <a:ext cx="6858000" cy="201168"/>
-          </a:xfrm>
-          <a:prstGeom prst="rect">
-            <a:avLst/>
-          </a:prstGeom>
-          <a:noFill/>
-          <a:ln/>
-        </p:spPr>
-        <p:txBody>
-          <a:bodyPr wrap="square" lIns="0" tIns="0" rIns="0" bIns="0" rtlCol="0" anchor="ctr"/>
-          <a:lstStyle/>
-          <a:p>
-            <a:pPr indent="0" marL="0">
-              <a:buNone/>
-            </a:pPr>
-            <a:r>
-              <a:rPr lang="en-US" sz="700" dirty="0">
-                <a:solidFill>
-                  <a:srgbClr val="B89BE0"/>
-                </a:solidFill>
-                <a:latin typeface="Arial" pitchFamily="34" charset="0"/>
-                <a:ea typeface="Arial" pitchFamily="34" charset="-122"/>
-                <a:cs typeface="Arial" pitchFamily="34" charset="-120"/>
-              </a:rPr>
-              <a:t>Kit de Gestão para Advogados · modelo v1.0 · set/2026</a:t>
-            </a:r>
-            <a:endParaRPr lang="en-US" sz="700" dirty="0"/>
-          </a:p>
-        </p:txBody>
-      </p:sp>
-      <p:sp>
-        <p:nvSpPr>
-          <p:cNvPr id="8" name="Shape 4"/>
-          <p:cNvSpPr/>
-          <p:nvPr/>
-        </p:nvSpPr>
-        <p:spPr>
-          <a:xfrm>
-            <a:off x="8229600" y="4818888"/>
-            <a:ext cx="211226" cy="70409"/>
-          </a:xfrm>
-          <a:prstGeom prst="roundRect">
-            <a:avLst>
-              <a:gd name="adj" fmla="val 42857"/>
-            </a:avLst>
-          </a:prstGeom>
-          <a:solidFill>
-            <a:srgbClr val="7A5AA8"/>
-          </a:solidFill>
-          <a:ln w="12700">
-            <a:solidFill>
-              <a:srgbClr val="7A5AA8"/>
-            </a:solidFill>
-            <a:prstDash val="solid"/>
-          </a:ln>
-        </p:spPr>
-      </p:sp>
-      <p:sp>
-        <p:nvSpPr>
-          <p:cNvPr id="9" name="Shape 5"/>
-          <p:cNvSpPr/>
-          <p:nvPr/>
-        </p:nvSpPr>
-        <p:spPr>
-          <a:xfrm>
-            <a:off x="8279892" y="4728362"/>
-            <a:ext cx="211226" cy="70409"/>
-          </a:xfrm>
-          <a:prstGeom prst="roundRect">
-            <a:avLst>
-              <a:gd name="adj" fmla="val 42857"/>
-            </a:avLst>
-          </a:prstGeom>
-          <a:solidFill>
-            <a:srgbClr val="3B1F5E"/>
-          </a:solidFill>
-          <a:ln w="12700">
-            <a:solidFill>
-              <a:srgbClr val="3B1F5E"/>
-            </a:solidFill>
-            <a:prstDash val="solid"/>
-          </a:ln>
-        </p:spPr>
-      </p:sp>
-      <p:sp>
-        <p:nvSpPr>
-          <p:cNvPr id="10" name="Shape 6"/>
-          <p:cNvSpPr/>
-          <p:nvPr/>
-        </p:nvSpPr>
-        <p:spPr>
-          <a:xfrm>
-            <a:off x="8330184" y="4637837"/>
-            <a:ext cx="211226" cy="70409"/>
-          </a:xfrm>
-          <a:prstGeom prst="roundRect">
-            <a:avLst>
-              <a:gd name="adj" fmla="val 42857"/>
-            </a:avLst>
-          </a:prstGeom>
-          <a:solidFill>
-            <a:srgbClr val="3B1F5E"/>
-          </a:solidFill>
-          <a:ln w="12700">
-            <a:solidFill>
-              <a:srgbClr val="3B1F5E"/>
-            </a:solidFill>
-            <a:prstDash val="solid"/>
-          </a:ln>
-        </p:spPr>
-      </p:sp>
-      <p:sp>
-        <p:nvSpPr>
-          <p:cNvPr id="11" name="Shape 7"/>
-          <p:cNvSpPr/>
-          <p:nvPr/>
-        </p:nvSpPr>
-        <p:spPr>
-          <a:xfrm>
-            <a:off x="8541410" y="4839005"/>
-            <a:ext cx="65380" cy="65380"/>
-          </a:xfrm>
-          <a:prstGeom prst="ellipse">
-            <a:avLst/>
-          </a:prstGeom>
-          <a:solidFill>
-            <a:srgbClr val="FFC83D"/>
-          </a:solidFill>
-          <a:ln w="12700">
-            <a:solidFill>
-              <a:srgbClr val="FFC83D"/>
-            </a:solidFill>
-            <a:prstDash val="solid"/>
-          </a:ln>
-        </p:spPr>
       </p:sp>
     </p:spTree>
   </p:cSld>
@@ -7312,13 +7660,6 @@
 <file path=ppt/slides/slide5.xml><?xml version="1.0" encoding="utf-8"?>
 <p:sld xmlns:a="http://schemas.openxmlformats.org/drawingml/2006/main" xmlns:r="http://schemas.openxmlformats.org/officeDocument/2006/relationships" xmlns:p="http://schemas.openxmlformats.org/presentationml/2006/main">
   <p:cSld name="Slide 5">
-    <p:bg>
-      <p:bgPr>
-        <a:solidFill>
-          <a:srgbClr val="FFFFFF"/>
-        </a:solidFill>
-      </p:bgPr>
-    </p:bg>
     <p:spTree>
       <p:nvGrpSpPr>
         <p:cNvPr id="1" name=""/>
@@ -7407,7 +7748,7 @@
                 <a:ea typeface="Arial" pitchFamily="34" charset="-122"/>
                 <a:cs typeface="Arial" pitchFamily="34" charset="-120"/>
               </a:rPr>
-              <a:t>Caixa do escritório (09), aba Painel. Saiu inclui custo fixo, pró-labore e impostos do mês.</a:t>
+              <a:t>Caixa do escritório (09), aba Painel. Saiu inclui custo fixo, pró-labore, guia de impostos e despesas de casos.</a:t>
             </a:r>
             <a:endParaRPr lang="en-US" sz="1200" dirty="0"/>
           </a:p>
@@ -7438,7 +7779,7 @@
         <p:spPr>
           <a:xfrm>
             <a:off x="5669280" y="1508760"/>
-            <a:ext cx="3108960" cy="3017520"/>
+            <a:ext cx="3108960" cy="3108960"/>
           </a:xfrm>
           <a:prstGeom prst="rect">
             <a:avLst/>
@@ -7457,7 +7798,7 @@
               <a:buNone/>
             </a:pPr>
             <a:r>
-              <a:rPr lang="en-US" sz="1050" b="1" dirty="0">
+              <a:rPr lang="en-US" sz="1000" b="1" dirty="0">
                 <a:solidFill>
                   <a:srgbClr val="3B1F5E"/>
                 </a:solidFill>
@@ -7465,9 +7806,9 @@
                 <a:ea typeface="Arial" pitchFamily="34" charset="-122"/>
                 <a:cs typeface="Arial" pitchFamily="34" charset="-120"/>
               </a:rPr>
-              <a:t>Setembro</a:t>
+              <a:t>Agosto</a:t>
             </a:r>
-            <a:endParaRPr lang="en-US" sz="1050" dirty="0"/>
+            <a:endParaRPr lang="en-US" sz="1000" dirty="0"/>
           </a:p>
           <a:p>
             <a:pPr marL="342900" indent="-342900">
@@ -7478,7 +7819,7 @@
               <a:buChar char="•"/>
             </a:pPr>
             <a:r>
-              <a:rPr lang="en-US" sz="1050" dirty="0">
+              <a:rPr lang="en-US" sz="1000" dirty="0">
                 <a:solidFill>
                   <a:srgbClr val="1F1235"/>
                 </a:solidFill>
@@ -7486,9 +7827,9 @@
                 <a:ea typeface="Arial" pitchFamily="34" charset="-122"/>
                 <a:cs typeface="Arial" pitchFamily="34" charset="-120"/>
               </a:rPr>
-              <a:t>Entrou R$ 29.400, saiu R$ 20.179, sobrou R$ 9.221 (agosto: R$ 7.836; julho: R$ 3.912).</a:t>
+              <a:t>Entrou R$ 26.900, saiu R$ 21.897, sobrou R$ 5.003 (julho: R$ 562, com a distribuição do 2º trimestre; junho: R$ 4.335).</a:t>
             </a:r>
-            <a:endParaRPr lang="en-US" sz="1050" dirty="0"/>
+            <a:endParaRPr lang="en-US" sz="1000" dirty="0"/>
           </a:p>
           <a:p>
             <a:pPr indent="0" marL="0">
@@ -7498,7 +7839,7 @@
               <a:buNone/>
             </a:pPr>
             <a:r>
-              <a:rPr lang="en-US" sz="1050" b="1" dirty="0">
+              <a:rPr lang="en-US" sz="1000" b="1" dirty="0">
                 <a:solidFill>
                   <a:srgbClr val="3B1F5E"/>
                 </a:solidFill>
@@ -7506,9 +7847,9 @@
                 <a:ea typeface="Arial" pitchFamily="34" charset="-122"/>
                 <a:cs typeface="Arial" pitchFamily="34" charset="-120"/>
               </a:rPr>
-              <a:t>Saídas do mês</a:t>
+              <a:t>Saídas de agosto</a:t>
             </a:r>
-            <a:endParaRPr lang="en-US" sz="1050" dirty="0"/>
+            <a:endParaRPr lang="en-US" sz="1000" dirty="0"/>
           </a:p>
           <a:p>
             <a:pPr marL="342900" indent="-342900">
@@ -7519,7 +7860,7 @@
               <a:buChar char="•"/>
             </a:pPr>
             <a:r>
-              <a:rPr lang="en-US" sz="1050" dirty="0">
+              <a:rPr lang="en-US" sz="1000" dirty="0">
                 <a:solidFill>
                   <a:srgbClr val="1F1235"/>
                 </a:solidFill>
@@ -7527,9 +7868,9 @@
                 <a:ea typeface="Arial" pitchFamily="34" charset="-122"/>
                 <a:cs typeface="Arial" pitchFamily="34" charset="-120"/>
               </a:rPr>
-              <a:t>Custo fixo R$ 6.415 · pró-labore R$ 12.000 · impostos R$ 1.764 (6% da receita, alíquota efetiva combinada com o contador).</a:t>
+              <a:t>Custo fixo R$ 6.500 · pró-labore R$ 12.000 · guia de impostos R$ 2.357 (8 % das entradas de julho) · custas e deslocamento R$ 560 · despesa pessoal a acertar R$ 480.</a:t>
             </a:r>
-            <a:endParaRPr lang="en-US" sz="1050" dirty="0"/>
+            <a:endParaRPr lang="en-US" sz="1000" dirty="0"/>
           </a:p>
           <a:p>
             <a:pPr indent="0" marL="0">
@@ -7539,7 +7880,7 @@
               <a:buNone/>
             </a:pPr>
             <a:r>
-              <a:rPr lang="en-US" sz="1050" b="1" dirty="0">
+              <a:rPr lang="en-US" sz="1000" b="1" dirty="0">
                 <a:solidFill>
                   <a:srgbClr val="3B1F5E"/>
                 </a:solidFill>
@@ -7549,7 +7890,7 @@
               </a:rPr>
               <a:t>No ano</a:t>
             </a:r>
-            <a:endParaRPr lang="en-US" sz="1050" dirty="0"/>
+            <a:endParaRPr lang="en-US" sz="1000" dirty="0"/>
           </a:p>
           <a:p>
             <a:pPr marL="342900" indent="-342900">
@@ -7560,7 +7901,7 @@
               <a:buChar char="•"/>
             </a:pPr>
             <a:r>
-              <a:rPr lang="en-US" sz="1050" dirty="0">
+              <a:rPr lang="en-US" sz="1000" dirty="0">
                 <a:solidFill>
                   <a:srgbClr val="1F1235"/>
                 </a:solidFill>
@@ -7568,156 +7909,11 @@
                 <a:ea typeface="Arial" pitchFamily="34" charset="-122"/>
                 <a:cs typeface="Arial" pitchFamily="34" charset="-120"/>
               </a:rPr>
-              <a:t>Sobrou R$ 40,7 mil de janeiro a setembro. Reserva alvo (3 meses de custo fixo com pró-labore): R$ 55,2 mil.</a:t>
+              <a:t>Sobrou R$ 21.783 de janeiro a agosto; saldo em caixa R$ 43.683. Reserva alvo (3 meses de custo fixo com pró-labore): R$ 55.500; guardado: R$ 12.000.</a:t>
             </a:r>
-            <a:endParaRPr lang="en-US" sz="1050" dirty="0"/>
+            <a:endParaRPr lang="en-US" sz="1000" dirty="0"/>
           </a:p>
         </p:txBody>
-      </p:sp>
-      <p:sp>
-        <p:nvSpPr>
-          <p:cNvPr id="6" name="Text 3"/>
-          <p:cNvSpPr txBox="1"/>
-          <p:nvPr/>
-        </p:nvSpPr>
-        <p:spPr>
-          <a:xfrm>
-            <a:off x="457200" y="4791456"/>
-            <a:ext cx="6858000" cy="201168"/>
-          </a:xfrm>
-          <a:prstGeom prst="rect">
-            <a:avLst/>
-          </a:prstGeom>
-          <a:noFill/>
-          <a:ln/>
-        </p:spPr>
-        <p:txBody>
-          <a:bodyPr wrap="square" lIns="0" tIns="0" rIns="0" bIns="0" rtlCol="0" anchor="ctr"/>
-          <a:lstStyle/>
-          <a:p>
-            <a:pPr indent="0" marL="0">
-              <a:buNone/>
-            </a:pPr>
-            <a:r>
-              <a:rPr lang="en-US" sz="700" dirty="0">
-                <a:solidFill>
-                  <a:srgbClr val="B89BE0"/>
-                </a:solidFill>
-                <a:latin typeface="Arial" pitchFamily="34" charset="0"/>
-                <a:ea typeface="Arial" pitchFamily="34" charset="-122"/>
-                <a:cs typeface="Arial" pitchFamily="34" charset="-120"/>
-              </a:rPr>
-              <a:t>Kit de Gestão para Advogados · modelo v1.0 · set/2026</a:t>
-            </a:r>
-            <a:endParaRPr lang="en-US" sz="700" dirty="0"/>
-          </a:p>
-        </p:txBody>
-      </p:sp>
-      <p:sp>
-        <p:nvSpPr>
-          <p:cNvPr id="7" name="Shape 4"/>
-          <p:cNvSpPr/>
-          <p:nvPr/>
-        </p:nvSpPr>
-        <p:spPr>
-          <a:xfrm>
-            <a:off x="8229600" y="4818888"/>
-            <a:ext cx="211226" cy="70409"/>
-          </a:xfrm>
-          <a:prstGeom prst="roundRect">
-            <a:avLst>
-              <a:gd name="adj" fmla="val 42857"/>
-            </a:avLst>
-          </a:prstGeom>
-          <a:solidFill>
-            <a:srgbClr val="7A5AA8"/>
-          </a:solidFill>
-          <a:ln w="12700">
-            <a:solidFill>
-              <a:srgbClr val="7A5AA8"/>
-            </a:solidFill>
-            <a:prstDash val="solid"/>
-          </a:ln>
-        </p:spPr>
-      </p:sp>
-      <p:sp>
-        <p:nvSpPr>
-          <p:cNvPr id="8" name="Shape 5"/>
-          <p:cNvSpPr/>
-          <p:nvPr/>
-        </p:nvSpPr>
-        <p:spPr>
-          <a:xfrm>
-            <a:off x="8279892" y="4728362"/>
-            <a:ext cx="211226" cy="70409"/>
-          </a:xfrm>
-          <a:prstGeom prst="roundRect">
-            <a:avLst>
-              <a:gd name="adj" fmla="val 42857"/>
-            </a:avLst>
-          </a:prstGeom>
-          <a:solidFill>
-            <a:srgbClr val="3B1F5E"/>
-          </a:solidFill>
-          <a:ln w="12700">
-            <a:solidFill>
-              <a:srgbClr val="3B1F5E"/>
-            </a:solidFill>
-            <a:prstDash val="solid"/>
-          </a:ln>
-        </p:spPr>
-      </p:sp>
-      <p:sp>
-        <p:nvSpPr>
-          <p:cNvPr id="9" name="Shape 6"/>
-          <p:cNvSpPr/>
-          <p:nvPr/>
-        </p:nvSpPr>
-        <p:spPr>
-          <a:xfrm>
-            <a:off x="8330184" y="4637837"/>
-            <a:ext cx="211226" cy="70409"/>
-          </a:xfrm>
-          <a:prstGeom prst="roundRect">
-            <a:avLst>
-              <a:gd name="adj" fmla="val 42857"/>
-            </a:avLst>
-          </a:prstGeom>
-          <a:solidFill>
-            <a:srgbClr val="3B1F5E"/>
-          </a:solidFill>
-          <a:ln w="12700">
-            <a:solidFill>
-              <a:srgbClr val="3B1F5E"/>
-            </a:solidFill>
-            <a:prstDash val="solid"/>
-          </a:ln>
-        </p:spPr>
-      </p:sp>
-      <p:sp>
-        <p:nvSpPr>
-          <p:cNvPr id="10" name="Shape 7"/>
-          <p:cNvSpPr/>
-          <p:nvPr/>
-        </p:nvSpPr>
-        <p:spPr>
-          <a:xfrm>
-            <a:off x="8541410" y="4839005"/>
-            <a:ext cx="65380" cy="65380"/>
-          </a:xfrm>
-          <a:prstGeom prst="ellipse">
-            <a:avLst/>
-          </a:prstGeom>
-          <a:solidFill>
-            <a:srgbClr val="FFC83D"/>
-          </a:solidFill>
-          <a:ln w="12700">
-            <a:solidFill>
-              <a:srgbClr val="FFC83D"/>
-            </a:solidFill>
-            <a:prstDash val="solid"/>
-          </a:ln>
-        </p:spPr>
       </p:sp>
     </p:spTree>
   </p:cSld>
@@ -7730,13 +7926,6 @@
 <file path=ppt/slides/slide6.xml><?xml version="1.0" encoding="utf-8"?>
 <p:sld xmlns:a="http://schemas.openxmlformats.org/drawingml/2006/main" xmlns:r="http://schemas.openxmlformats.org/officeDocument/2006/relationships" xmlns:p="http://schemas.openxmlformats.org/presentationml/2006/main">
   <p:cSld name="Slide 6">
-    <p:bg>
-      <p:bgPr>
-        <a:solidFill>
-          <a:srgbClr val="FFFFFF"/>
-        </a:solidFill>
-      </p:bgPr>
-    </p:bg>
     <p:spTree>
       <p:nvGrpSpPr>
         <p:cNvPr id="1" name=""/>
@@ -7825,7 +8014,7 @@
                 <a:ea typeface="Arial" pitchFamily="34" charset="-122"/>
                 <a:cs typeface="Arial" pitchFamily="34" charset="-120"/>
               </a:rPr>
-              <a:t>Carteira de clientes e casos (13) e Parcelas e inadimplência (14), posição de 2/10.</a:t>
+              <a:t>Carteira de clientes e casos (13) e Parcelas e inadimplência (14), posição de sexta, 11/09.</a:t>
             </a:r>
             <a:endParaRPr lang="en-US" sz="1200" dirty="0"/>
           </a:p>
@@ -7893,7 +8082,7 @@
                 <a:ea typeface="Arial" pitchFamily="34" charset="-122"/>
                 <a:cs typeface="Arial" pitchFamily="34" charset="-120"/>
               </a:rPr>
-              <a:t>R$ 128,3 mil</a:t>
+              <a:t>R$ 111.990</a:t>
             </a:r>
             <a:endParaRPr lang="en-US" sz="2600" dirty="0"/>
           </a:p>
@@ -7971,7 +8160,7 @@
                 <a:ea typeface="Arial" pitchFamily="34" charset="-122"/>
                 <a:cs typeface="Arial" pitchFamily="34" charset="-120"/>
               </a:rPr>
-              <a:t>contratado menos recebido, nos 38 casos</a:t>
+              <a:t>contratado menos recebido, nos 30 casos ativos</a:t>
             </a:r>
             <a:endParaRPr lang="en-US" sz="1050" dirty="0"/>
           </a:p>
@@ -8039,7 +8228,7 @@
                 <a:ea typeface="Arial" pitchFamily="34" charset="-122"/>
                 <a:cs typeface="Arial" pitchFamily="34" charset="-120"/>
               </a:rPr>
-              <a:t>R$ 21,6 mil</a:t>
+              <a:t>R$ 14.480</a:t>
             </a:r>
             <a:endParaRPr lang="en-US" sz="2600" dirty="0"/>
           </a:p>
@@ -8078,7 +8267,7 @@
                 <a:ea typeface="Arial" pitchFamily="34" charset="-122"/>
                 <a:cs typeface="Arial" pitchFamily="34" charset="-120"/>
               </a:rPr>
-              <a:t>Vencido (16,8%)</a:t>
+              <a:t>Vencido (5,1 %)</a:t>
             </a:r>
             <a:endParaRPr lang="en-US" sz="1300" dirty="0"/>
           </a:p>
@@ -8117,7 +8306,7 @@
                 <a:ea typeface="Arial" pitchFamily="34" charset="-122"/>
                 <a:cs typeface="Arial" pitchFamily="34" charset="-120"/>
               </a:rPr>
-              <a:t>R$ 20,9 mil em agosto; R$ 23,6 mil em julho</a:t>
+              <a:t>8 parcelas; R$ 12.500 (4,5 %) no fim de agosto; R$ 8.900 (3,6 %) em julho</a:t>
             </a:r>
             <a:endParaRPr lang="en-US" sz="1050" dirty="0"/>
           </a:p>
@@ -8185,7 +8374,7 @@
                 <a:ea typeface="Arial" pitchFamily="34" charset="-122"/>
                 <a:cs typeface="Arial" pitchFamily="34" charset="-120"/>
               </a:rPr>
-              <a:t>R$ 36,0 mil</a:t>
+              <a:t>R$ 30.000</a:t>
             </a:r>
             <a:endParaRPr lang="en-US" sz="2600" dirty="0"/>
           </a:p>
@@ -8263,7 +8452,7 @@
                 <a:ea typeface="Arial" pitchFamily="34" charset="-122"/>
                 <a:cs typeface="Arial" pitchFamily="34" charset="-120"/>
               </a:rPr>
-              <a:t>4 casos; só entra no fim, não conta como atraso</a:t>
+              <a:t>5 casos de êxito puro; só entra no fim, não conta como atraso</a:t>
             </a:r>
             <a:endParaRPr lang="en-US" sz="1050" dirty="0"/>
           </a:p>
@@ -8278,7 +8467,7 @@
         <p:spPr>
           <a:xfrm>
             <a:off x="457200" y="3337560"/>
-            <a:ext cx="8229600" cy="1280160"/>
+            <a:ext cx="8229600" cy="1325880"/>
           </a:xfrm>
           <a:prstGeom prst="rect">
             <a:avLst/>
@@ -8297,7 +8486,7 @@
               <a:buNone/>
             </a:pPr>
             <a:r>
-              <a:rPr lang="en-US" sz="1100" b="1" dirty="0">
+              <a:rPr lang="en-US" sz="1050" b="1" dirty="0">
                 <a:solidFill>
                   <a:srgbClr val="3B1F5E"/>
                 </a:solidFill>
@@ -8305,9 +8494,9 @@
                 <a:ea typeface="Arial" pitchFamily="34" charset="-122"/>
                 <a:cs typeface="Arial" pitchFamily="34" charset="-120"/>
               </a:rPr>
-              <a:t>Por sócio</a:t>
+              <a:t>Cobrar primeiro (14)</a:t>
             </a:r>
-            <a:endParaRPr lang="en-US" sz="1100" dirty="0"/>
+            <a:endParaRPr lang="en-US" sz="1050" dirty="0"/>
           </a:p>
           <a:p>
             <a:pPr marL="342900" indent="-342900">
@@ -8318,7 +8507,7 @@
               <a:buChar char="•"/>
             </a:pPr>
             <a:r>
-              <a:rPr lang="en-US" sz="1100" dirty="0">
+              <a:rPr lang="en-US" sz="1050" dirty="0">
                 <a:solidFill>
                   <a:srgbClr val="1F1235"/>
                 </a:solidFill>
@@ -8326,9 +8515,9 @@
                 <a:ea typeface="Arial" pitchFamily="34" charset="-122"/>
                 <a:cs typeface="Arial" pitchFamily="34" charset="-120"/>
               </a:rPr>
-              <a:t>Marina: R$ 102,8 mil a receber (R$ 26,1 mil de êxito). Rafael: R$ 25,5 mil (R$ 9,9 mil de êxito). Sem êxito: R$ 92,3 mil em 15 casos com parcelas datadas.</a:t>
+              <a:t>Seis parcelas com mais de 30 dias: Bistrô 42 (2 × R$ 2.100, 150 e 180 dias), Fernanda Castro (R$ 1.400, caso encerrado), Oficina Mecânica Central (R$ 1.500), Patrícia Gomes (R$ 2.100) e Agência Prisma (R$ 1.800).</a:t>
             </a:r>
-            <a:endParaRPr lang="en-US" sz="1100" dirty="0"/>
+            <a:endParaRPr lang="en-US" sz="1050" dirty="0"/>
           </a:p>
           <a:p>
             <a:pPr indent="0" marL="0">
@@ -8338,7 +8527,7 @@
               <a:buNone/>
             </a:pPr>
             <a:r>
-              <a:rPr lang="en-US" sz="1100" b="1" dirty="0">
+              <a:rPr lang="en-US" sz="1050" b="1" dirty="0">
                 <a:solidFill>
                   <a:srgbClr val="3B1F5E"/>
                 </a:solidFill>
@@ -8346,9 +8535,9 @@
                 <a:ea typeface="Arial" pitchFamily="34" charset="-122"/>
                 <a:cs typeface="Arial" pitchFamily="34" charset="-120"/>
               </a:rPr>
-              <a:t>Cobrança</a:t>
+              <a:t>Régua da planilha 14</a:t>
             </a:r>
-            <a:endParaRPr lang="en-US" sz="1100" dirty="0"/>
+            <a:endParaRPr lang="en-US" sz="1050" dirty="0"/>
           </a:p>
           <a:p>
             <a:pPr marL="342900" indent="-342900">
@@ -8359,7 +8548,7 @@
               <a:buChar char="•"/>
             </a:pPr>
             <a:r>
-              <a:rPr lang="en-US" sz="1100" dirty="0">
+              <a:rPr lang="en-US" sz="1050" dirty="0">
                 <a:solidFill>
                   <a:srgbClr val="1F1235"/>
                 </a:solidFill>
@@ -8367,156 +8556,11 @@
                 <a:ea typeface="Arial" pitchFamily="34" charset="-122"/>
                 <a:cs typeface="Arial" pitchFamily="34" charset="-120"/>
               </a:rPr>
-              <a:t>Régua da planilha 14: lembrete no vencimento, mensagem em 7 dias, ligação em 15, reunião em 30. Os modelos de mensagem do kit evitam o constrangimento.</a:t>
+              <a:t>1 dia: lembrete gentil · 7 dias: mensagem do responsável pelo caso · 15 dias: e-mail com demonstrativo e proposta de renegociação · 30 dias: ligação ou reunião e plano por escrito. Os modelos do bônus 22 seguem a régua.</a:t>
             </a:r>
-            <a:endParaRPr lang="en-US" sz="1100" dirty="0"/>
+            <a:endParaRPr lang="en-US" sz="1050" dirty="0"/>
           </a:p>
         </p:txBody>
-      </p:sp>
-      <p:sp>
-        <p:nvSpPr>
-          <p:cNvPr id="17" name="Text 15"/>
-          <p:cNvSpPr txBox="1"/>
-          <p:nvPr/>
-        </p:nvSpPr>
-        <p:spPr>
-          <a:xfrm>
-            <a:off x="457200" y="4791456"/>
-            <a:ext cx="6858000" cy="201168"/>
-          </a:xfrm>
-          <a:prstGeom prst="rect">
-            <a:avLst/>
-          </a:prstGeom>
-          <a:noFill/>
-          <a:ln/>
-        </p:spPr>
-        <p:txBody>
-          <a:bodyPr wrap="square" lIns="0" tIns="0" rIns="0" bIns="0" rtlCol="0" anchor="ctr"/>
-          <a:lstStyle/>
-          <a:p>
-            <a:pPr indent="0" marL="0">
-              <a:buNone/>
-            </a:pPr>
-            <a:r>
-              <a:rPr lang="en-US" sz="700" dirty="0">
-                <a:solidFill>
-                  <a:srgbClr val="B89BE0"/>
-                </a:solidFill>
-                <a:latin typeface="Arial" pitchFamily="34" charset="0"/>
-                <a:ea typeface="Arial" pitchFamily="34" charset="-122"/>
-                <a:cs typeface="Arial" pitchFamily="34" charset="-120"/>
-              </a:rPr>
-              <a:t>Kit de Gestão para Advogados · modelo v1.0 · set/2026</a:t>
-            </a:r>
-            <a:endParaRPr lang="en-US" sz="700" dirty="0"/>
-          </a:p>
-        </p:txBody>
-      </p:sp>
-      <p:sp>
-        <p:nvSpPr>
-          <p:cNvPr id="18" name="Shape 16"/>
-          <p:cNvSpPr/>
-          <p:nvPr/>
-        </p:nvSpPr>
-        <p:spPr>
-          <a:xfrm>
-            <a:off x="8229600" y="4818888"/>
-            <a:ext cx="211226" cy="70409"/>
-          </a:xfrm>
-          <a:prstGeom prst="roundRect">
-            <a:avLst>
-              <a:gd name="adj" fmla="val 42857"/>
-            </a:avLst>
-          </a:prstGeom>
-          <a:solidFill>
-            <a:srgbClr val="7A5AA8"/>
-          </a:solidFill>
-          <a:ln w="12700">
-            <a:solidFill>
-              <a:srgbClr val="7A5AA8"/>
-            </a:solidFill>
-            <a:prstDash val="solid"/>
-          </a:ln>
-        </p:spPr>
-      </p:sp>
-      <p:sp>
-        <p:nvSpPr>
-          <p:cNvPr id="19" name="Shape 17"/>
-          <p:cNvSpPr/>
-          <p:nvPr/>
-        </p:nvSpPr>
-        <p:spPr>
-          <a:xfrm>
-            <a:off x="8279892" y="4728362"/>
-            <a:ext cx="211226" cy="70409"/>
-          </a:xfrm>
-          <a:prstGeom prst="roundRect">
-            <a:avLst>
-              <a:gd name="adj" fmla="val 42857"/>
-            </a:avLst>
-          </a:prstGeom>
-          <a:solidFill>
-            <a:srgbClr val="3B1F5E"/>
-          </a:solidFill>
-          <a:ln w="12700">
-            <a:solidFill>
-              <a:srgbClr val="3B1F5E"/>
-            </a:solidFill>
-            <a:prstDash val="solid"/>
-          </a:ln>
-        </p:spPr>
-      </p:sp>
-      <p:sp>
-        <p:nvSpPr>
-          <p:cNvPr id="20" name="Shape 18"/>
-          <p:cNvSpPr/>
-          <p:nvPr/>
-        </p:nvSpPr>
-        <p:spPr>
-          <a:xfrm>
-            <a:off x="8330184" y="4637837"/>
-            <a:ext cx="211226" cy="70409"/>
-          </a:xfrm>
-          <a:prstGeom prst="roundRect">
-            <a:avLst>
-              <a:gd name="adj" fmla="val 42857"/>
-            </a:avLst>
-          </a:prstGeom>
-          <a:solidFill>
-            <a:srgbClr val="3B1F5E"/>
-          </a:solidFill>
-          <a:ln w="12700">
-            <a:solidFill>
-              <a:srgbClr val="3B1F5E"/>
-            </a:solidFill>
-            <a:prstDash val="solid"/>
-          </a:ln>
-        </p:spPr>
-      </p:sp>
-      <p:sp>
-        <p:nvSpPr>
-          <p:cNvPr id="21" name="Shape 19"/>
-          <p:cNvSpPr/>
-          <p:nvPr/>
-        </p:nvSpPr>
-        <p:spPr>
-          <a:xfrm>
-            <a:off x="8541410" y="4839005"/>
-            <a:ext cx="65380" cy="65380"/>
-          </a:xfrm>
-          <a:prstGeom prst="ellipse">
-            <a:avLst/>
-          </a:prstGeom>
-          <a:solidFill>
-            <a:srgbClr val="FFC83D"/>
-          </a:solidFill>
-          <a:ln w="12700">
-            <a:solidFill>
-              <a:srgbClr val="FFC83D"/>
-            </a:solidFill>
-            <a:prstDash val="solid"/>
-          </a:ln>
-        </p:spPr>
       </p:sp>
     </p:spTree>
   </p:cSld>
@@ -8529,13 +8573,6 @@
 <file path=ppt/slides/slide7.xml><?xml version="1.0" encoding="utf-8"?>
 <p:sld xmlns:a="http://schemas.openxmlformats.org/drawingml/2006/main" xmlns:r="http://schemas.openxmlformats.org/officeDocument/2006/relationships" xmlns:p="http://schemas.openxmlformats.org/presentationml/2006/main">
   <p:cSld name="Slide 7">
-    <p:bg>
-      <p:bgPr>
-        <a:solidFill>
-          <a:srgbClr val="3B1F5E"/>
-        </a:solidFill>
-      </p:bgPr>
-    </p:bg>
     <p:spTree>
       <p:nvGrpSpPr>
         <p:cNvPr id="1" name=""/>
@@ -8600,7 +8637,7 @@
         <p:spPr>
           <a:xfrm>
             <a:off x="457200" y="1554480"/>
-            <a:ext cx="8229600" cy="2743200"/>
+            <a:ext cx="7772400" cy="2651760"/>
           </a:xfrm>
           <a:prstGeom prst="rect">
             <a:avLst/>
@@ -8614,13 +8651,13 @@
           <a:p>
             <a:pPr marL="342900" indent="-342900">
               <a:spcAft>
-                <a:spcPts val="1000"/>
+                <a:spcPts val="800"/>
               </a:spcAft>
               <a:buSzPct val="100000"/>
               <a:buChar char="•"/>
             </a:pPr>
             <a:r>
-              <a:rPr lang="en-US" sz="1600" dirty="0">
+              <a:rPr lang="en-US" sz="1500" dirty="0">
                 <a:solidFill>
                   <a:srgbClr val="FFFFFF"/>
                 </a:solidFill>
@@ -8628,20 +8665,20 @@
                 <a:ea typeface="Arial" pitchFamily="34" charset="-122"/>
                 <a:cs typeface="Arial" pitchFamily="34" charset="-120"/>
               </a:rPr>
-              <a:t>Separar R$ 4.000 do resultado de setembro para a reserva do escritório, todo mês, até chegar a três meses de custo fixo (R$ 55,2 mil).</a:t>
+              <a:t>Separar R$ 3.000 por mês para a reserva do escritório, a partir de setembro, até chegar a três meses de custo fixo (R$ 55.500; hoje R$ 12.000, meta em dezembro de 2027 pela planilha 12).</a:t>
             </a:r>
-            <a:endParaRPr lang="en-US" sz="1600" dirty="0"/>
+            <a:endParaRPr lang="en-US" sz="1500" dirty="0"/>
           </a:p>
           <a:p>
             <a:pPr marL="342900" indent="-342900">
               <a:spcAft>
-                <a:spcPts val="1000"/>
+                <a:spcPts val="800"/>
               </a:spcAft>
               <a:buSzPct val="100000"/>
               <a:buChar char="•"/>
             </a:pPr>
             <a:r>
-              <a:rPr lang="en-US" sz="1600" dirty="0">
+              <a:rPr lang="en-US" sz="1500" dirty="0">
                 <a:solidFill>
                   <a:srgbClr val="FFFFFF"/>
                 </a:solidFill>
@@ -8649,20 +8686,20 @@
                 <a:ea typeface="Arial" pitchFamily="34" charset="-122"/>
                 <a:cs typeface="Arial" pitchFamily="34" charset="-120"/>
               </a:rPr>
-              <a:t>Casos novos só em modalidade fixa, por hora ou mista: a parte fixa precisa cobrir as horas estimadas. Hoje R$ 36 mil estão parados em quatro casos de êxito.</a:t>
+              <a:t>Casos novos só em modalidade fixa, por hora ou mista: a parte fixa precisa cobrir as horas estimadas. Hoje R$ 30 mil estão parados em cinco casos de êxito puro.</a:t>
             </a:r>
-            <a:endParaRPr lang="en-US" sz="1600" dirty="0"/>
+            <a:endParaRPr lang="en-US" sz="1500" dirty="0"/>
           </a:p>
           <a:p>
             <a:pPr marL="342900" indent="-342900">
               <a:spcAft>
-                <a:spcPts val="1000"/>
+                <a:spcPts val="800"/>
               </a:spcAft>
               <a:buSzPct val="100000"/>
               <a:buChar char="•"/>
             </a:pPr>
             <a:r>
-              <a:rPr lang="en-US" sz="1600" dirty="0">
+              <a:rPr lang="en-US" sz="1500" dirty="0">
                 <a:solidFill>
                   <a:srgbClr val="FFFFFF"/>
                 </a:solidFill>
@@ -8670,9 +8707,9 @@
                 <a:ea typeface="Arial" pitchFamily="34" charset="-122"/>
                 <a:cs typeface="Arial" pitchFamily="34" charset="-120"/>
               </a:rPr>
-              <a:t>Contratar mais 20 horas por mês da estagiária (R$ 700) para prazos e cobrança, ou redistribuir os 12 casos acima das horas estimadas? Decidir hoje.</a:t>
+              <a:t>Contratar mais 20 horas por mês da estagiária (R$ 467, na proporção da bolsa atual de R$ 1.400 por 60 h faturáveis) para juntadas e cobrança, ou redistribuir os prazos entre os sócios? Decidir hoje.</a:t>
             </a:r>
-            <a:endParaRPr lang="en-US" sz="1600" dirty="0"/>
+            <a:endParaRPr lang="en-US" sz="1500" dirty="0"/>
           </a:p>
         </p:txBody>
       </p:sp>
@@ -8684,152 +8721,7 @@
         </p:nvSpPr>
         <p:spPr>
           <a:xfrm>
-            <a:off x="457200" y="4791456"/>
-            <a:ext cx="6858000" cy="201168"/>
-          </a:xfrm>
-          <a:prstGeom prst="rect">
-            <a:avLst/>
-          </a:prstGeom>
-          <a:noFill/>
-          <a:ln/>
-        </p:spPr>
-        <p:txBody>
-          <a:bodyPr wrap="square" lIns="0" tIns="0" rIns="0" bIns="0" rtlCol="0" anchor="ctr"/>
-          <a:lstStyle/>
-          <a:p>
-            <a:pPr indent="0" marL="0">
-              <a:buNone/>
-            </a:pPr>
-            <a:r>
-              <a:rPr lang="en-US" sz="700" dirty="0">
-                <a:solidFill>
-                  <a:srgbClr val="7A5AA8"/>
-                </a:solidFill>
-                <a:latin typeface="Arial" pitchFamily="34" charset="0"/>
-                <a:ea typeface="Arial" pitchFamily="34" charset="-122"/>
-                <a:cs typeface="Arial" pitchFamily="34" charset="-120"/>
-              </a:rPr>
-              <a:t>Kit de Gestão para Advogados · modelo v1.0 · set/2026</a:t>
-            </a:r>
-            <a:endParaRPr lang="en-US" sz="700" dirty="0"/>
-          </a:p>
-        </p:txBody>
-      </p:sp>
-      <p:sp>
-        <p:nvSpPr>
-          <p:cNvPr id="5" name="Shape 3"/>
-          <p:cNvSpPr/>
-          <p:nvPr/>
-        </p:nvSpPr>
-        <p:spPr>
-          <a:xfrm>
-            <a:off x="8229600" y="4818888"/>
-            <a:ext cx="211226" cy="70409"/>
-          </a:xfrm>
-          <a:prstGeom prst="roundRect">
-            <a:avLst>
-              <a:gd name="adj" fmla="val 42857"/>
-            </a:avLst>
-          </a:prstGeom>
-          <a:solidFill>
-            <a:srgbClr val="B89BE0"/>
-          </a:solidFill>
-          <a:ln w="12700">
-            <a:solidFill>
-              <a:srgbClr val="B89BE0"/>
-            </a:solidFill>
-            <a:prstDash val="solid"/>
-          </a:ln>
-        </p:spPr>
-      </p:sp>
-      <p:sp>
-        <p:nvSpPr>
-          <p:cNvPr id="6" name="Shape 4"/>
-          <p:cNvSpPr/>
-          <p:nvPr/>
-        </p:nvSpPr>
-        <p:spPr>
-          <a:xfrm>
-            <a:off x="8279892" y="4728362"/>
-            <a:ext cx="211226" cy="70409"/>
-          </a:xfrm>
-          <a:prstGeom prst="roundRect">
-            <a:avLst>
-              <a:gd name="adj" fmla="val 42857"/>
-            </a:avLst>
-          </a:prstGeom>
-          <a:solidFill>
-            <a:srgbClr val="FFFFFF"/>
-          </a:solidFill>
-          <a:ln w="12700">
-            <a:solidFill>
-              <a:srgbClr val="FFFFFF"/>
-            </a:solidFill>
-            <a:prstDash val="solid"/>
-          </a:ln>
-        </p:spPr>
-      </p:sp>
-      <p:sp>
-        <p:nvSpPr>
-          <p:cNvPr id="7" name="Shape 5"/>
-          <p:cNvSpPr/>
-          <p:nvPr/>
-        </p:nvSpPr>
-        <p:spPr>
-          <a:xfrm>
-            <a:off x="8330184" y="4637837"/>
-            <a:ext cx="211226" cy="70409"/>
-          </a:xfrm>
-          <a:prstGeom prst="roundRect">
-            <a:avLst>
-              <a:gd name="adj" fmla="val 42857"/>
-            </a:avLst>
-          </a:prstGeom>
-          <a:solidFill>
-            <a:srgbClr val="FFFFFF"/>
-          </a:solidFill>
-          <a:ln w="12700">
-            <a:solidFill>
-              <a:srgbClr val="FFFFFF"/>
-            </a:solidFill>
-            <a:prstDash val="solid"/>
-          </a:ln>
-        </p:spPr>
-      </p:sp>
-      <p:sp>
-        <p:nvSpPr>
-          <p:cNvPr id="8" name="Shape 6"/>
-          <p:cNvSpPr/>
-          <p:nvPr/>
-        </p:nvSpPr>
-        <p:spPr>
-          <a:xfrm>
-            <a:off x="8541410" y="4839005"/>
-            <a:ext cx="65380" cy="65380"/>
-          </a:xfrm>
-          <a:prstGeom prst="ellipse">
-            <a:avLst/>
-          </a:prstGeom>
-          <a:solidFill>
-            <a:srgbClr val="FFC83D"/>
-          </a:solidFill>
-          <a:ln w="12700">
-            <a:solidFill>
-              <a:srgbClr val="FFC83D"/>
-            </a:solidFill>
-            <a:prstDash val="solid"/>
-          </a:ln>
-        </p:spPr>
-      </p:sp>
-      <p:sp>
-        <p:nvSpPr>
-          <p:cNvPr id="9" name="Text 7"/>
-          <p:cNvSpPr txBox="1"/>
-          <p:nvPr/>
-        </p:nvSpPr>
-        <p:spPr>
-          <a:xfrm>
-            <a:off x="457200" y="4160520"/>
+            <a:off x="457200" y="4297680"/>
             <a:ext cx="8229600" cy="365760"/>
           </a:xfrm>
           <a:prstGeom prst="rect">
@@ -8871,13 +8763,6 @@
 <file path=ppt/slides/slide8.xml><?xml version="1.0" encoding="utf-8"?>
 <p:sld xmlns:a="http://schemas.openxmlformats.org/drawingml/2006/main" xmlns:r="http://schemas.openxmlformats.org/officeDocument/2006/relationships" xmlns:p="http://schemas.openxmlformats.org/presentationml/2006/main">
   <p:cSld name="Slide 8">
-    <p:bg>
-      <p:bgPr>
-        <a:solidFill>
-          <a:srgbClr val="FFFFFF"/>
-        </a:solidFill>
-      </p:bgPr>
-    </p:bg>
     <p:spTree>
       <p:nvGrpSpPr>
         <p:cNvPr id="1" name=""/>
@@ -8995,9 +8880,9 @@
             <a:tbl>
               <a:tblPr/>
               <a:tblGrid>
-                <a:gridCol w="5120640"/>
-                <a:gridCol w="1920240"/>
-                <a:gridCol w="1188720"/>
+                <a:gridCol w="4937760"/>
+                <a:gridCol w="2194560"/>
+                <a:gridCol w="1097280"/>
               </a:tblGrid>
               <a:tr h="347472">
                 <a:tc>
@@ -9009,7 +8894,7 @@
                         <a:buNone/>
                       </a:pPr>
                       <a:r>
-                        <a:rPr lang="en-US" sz="1050" b="1" dirty="0">
+                        <a:rPr lang="en-US" sz="1000" b="1" dirty="0">
                           <a:solidFill>
                             <a:srgbClr val="FFFFFF"/>
                           </a:solidFill>
@@ -9019,7 +8904,7 @@
                         </a:rPr>
                         <a:t>O que</a:t>
                       </a:r>
-                      <a:endParaRPr lang="en-US" sz="1050" dirty="0">
+                      <a:endParaRPr lang="en-US" sz="1000" dirty="0">
                         <a:latin typeface="Arial" charset="0"/>
                         <a:ea typeface="Arial" charset="0"/>
                         <a:cs typeface="Arial" charset="0"/>
@@ -9077,7 +8962,7 @@
                         <a:buNone/>
                       </a:pPr>
                       <a:r>
-                        <a:rPr lang="en-US" sz="1050" b="1" dirty="0">
+                        <a:rPr lang="en-US" sz="1000" b="1" dirty="0">
                           <a:solidFill>
                             <a:srgbClr val="FFFFFF"/>
                           </a:solidFill>
@@ -9087,7 +8972,7 @@
                         </a:rPr>
                         <a:t>Quem</a:t>
                       </a:r>
-                      <a:endParaRPr lang="en-US" sz="1050" dirty="0">
+                      <a:endParaRPr lang="en-US" sz="1000" dirty="0">
                         <a:latin typeface="Arial" charset="0"/>
                         <a:ea typeface="Arial" charset="0"/>
                         <a:cs typeface="Arial" charset="0"/>
@@ -9145,7 +9030,7 @@
                         <a:buNone/>
                       </a:pPr>
                       <a:r>
-                        <a:rPr lang="en-US" sz="1050" b="1" dirty="0">
+                        <a:rPr lang="en-US" sz="1000" b="1" dirty="0">
                           <a:solidFill>
                             <a:srgbClr val="FFFFFF"/>
                           </a:solidFill>
@@ -9155,7 +9040,7 @@
                         </a:rPr>
                         <a:t>Prazo</a:t>
                       </a:r>
-                      <a:endParaRPr lang="en-US" sz="1050" dirty="0">
+                      <a:endParaRPr lang="en-US" sz="1000" dirty="0">
                         <a:latin typeface="Arial" charset="0"/>
                         <a:ea typeface="Arial" charset="0"/>
                         <a:cs typeface="Arial" charset="0"/>
@@ -9215,7 +9100,7 @@
                         <a:buNone/>
                       </a:pPr>
                       <a:r>
-                        <a:rPr lang="en-US" sz="1050" dirty="0">
+                        <a:rPr lang="en-US" sz="1000" dirty="0">
                           <a:solidFill>
                             <a:srgbClr val="1F1235"/>
                           </a:solidFill>
@@ -9225,7 +9110,7 @@
                         </a:rPr>
                         <a:t>Zerar os 7 prazos atrasados e registrar a baixa na Agenda de prazos (01)</a:t>
                       </a:r>
-                      <a:endParaRPr lang="en-US" sz="1050" dirty="0">
+                      <a:endParaRPr lang="en-US" sz="1000" dirty="0">
                         <a:latin typeface="Arial" charset="0"/>
                         <a:ea typeface="Arial" charset="0"/>
                         <a:cs typeface="Arial" charset="0"/>
@@ -9283,7 +9168,7 @@
                         <a:buNone/>
                       </a:pPr>
                       <a:r>
-                        <a:rPr lang="en-US" sz="1050" dirty="0">
+                        <a:rPr lang="en-US" sz="1000" dirty="0">
                           <a:solidFill>
                             <a:srgbClr val="1F1235"/>
                           </a:solidFill>
@@ -9291,9 +9176,9 @@
                           <a:ea typeface="Arial" pitchFamily="34" charset="-122"/>
                           <a:cs typeface="Arial" pitchFamily="34" charset="-120"/>
                         </a:rPr>
-                        <a:t>Marina (5) e Rafael (2)</a:t>
+                        <a:t>Marina (3), Rafael (3) e Júlia (1)</a:t>
                       </a:r>
-                      <a:endParaRPr lang="en-US" sz="1050" dirty="0">
+                      <a:endParaRPr lang="en-US" sz="1000" dirty="0">
                         <a:latin typeface="Arial" charset="0"/>
                         <a:ea typeface="Arial" charset="0"/>
                         <a:cs typeface="Arial" charset="0"/>
@@ -9351,7 +9236,7 @@
                         <a:buNone/>
                       </a:pPr>
                       <a:r>
-                        <a:rPr lang="en-US" sz="1050" dirty="0">
+                        <a:rPr lang="en-US" sz="1000" dirty="0">
                           <a:solidFill>
                             <a:srgbClr val="1F1235"/>
                           </a:solidFill>
@@ -9359,9 +9244,9 @@
                           <a:ea typeface="Arial" pitchFamily="34" charset="-122"/>
                           <a:cs typeface="Arial" pitchFamily="34" charset="-120"/>
                         </a:rPr>
-                        <a:t>9/10/2026</a:t>
+                        <a:t>18/09/2026</a:t>
                       </a:r>
-                      <a:endParaRPr lang="en-US" sz="1050" dirty="0">
+                      <a:endParaRPr lang="en-US" sz="1000" dirty="0">
                         <a:latin typeface="Arial" charset="0"/>
                         <a:ea typeface="Arial" charset="0"/>
                         <a:cs typeface="Arial" charset="0"/>
@@ -9421,7 +9306,7 @@
                         <a:buNone/>
                       </a:pPr>
                       <a:r>
-                        <a:rPr lang="en-US" sz="1050" dirty="0">
+                        <a:rPr lang="en-US" sz="1000" dirty="0">
                           <a:solidFill>
                             <a:srgbClr val="1F1235"/>
                           </a:solidFill>
@@ -9429,9 +9314,9 @@
                           <a:ea typeface="Arial" pitchFamily="34" charset="-122"/>
                           <a:cs typeface="Arial" pitchFamily="34" charset="-120"/>
                         </a:rPr>
-                        <a:t>Enviar lembrete de cobrança a todas as parcelas vencidas (modelos do kit)</a:t>
+                        <a:t>Enviar a mensagem da régua para as 8 parcelas vencidas (modelos 04 a 07 do bônus 22)</a:t>
                       </a:r>
-                      <a:endParaRPr lang="en-US" sz="1050" dirty="0">
+                      <a:endParaRPr lang="en-US" sz="1000" dirty="0">
                         <a:latin typeface="Arial" charset="0"/>
                         <a:ea typeface="Arial" charset="0"/>
                         <a:cs typeface="Arial" charset="0"/>
@@ -9489,7 +9374,7 @@
                         <a:buNone/>
                       </a:pPr>
                       <a:r>
-                        <a:rPr lang="en-US" sz="1050" dirty="0">
+                        <a:rPr lang="en-US" sz="1000" dirty="0">
                           <a:solidFill>
                             <a:srgbClr val="1F1235"/>
                           </a:solidFill>
@@ -9499,7 +9384,7 @@
                         </a:rPr>
                         <a:t>Júlia Prado</a:t>
                       </a:r>
-                      <a:endParaRPr lang="en-US" sz="1050" dirty="0">
+                      <a:endParaRPr lang="en-US" sz="1000" dirty="0">
                         <a:latin typeface="Arial" charset="0"/>
                         <a:ea typeface="Arial" charset="0"/>
                         <a:cs typeface="Arial" charset="0"/>
@@ -9557,7 +9442,7 @@
                         <a:buNone/>
                       </a:pPr>
                       <a:r>
-                        <a:rPr lang="en-US" sz="1050" dirty="0">
+                        <a:rPr lang="en-US" sz="1000" dirty="0">
                           <a:solidFill>
                             <a:srgbClr val="1F1235"/>
                           </a:solidFill>
@@ -9565,9 +9450,9 @@
                           <a:ea typeface="Arial" pitchFamily="34" charset="-122"/>
                           <a:cs typeface="Arial" pitchFamily="34" charset="-120"/>
                         </a:rPr>
-                        <a:t>9/10/2026</a:t>
+                        <a:t>16/09/2026</a:t>
                       </a:r>
-                      <a:endParaRPr lang="en-US" sz="1050" dirty="0">
+                      <a:endParaRPr lang="en-US" sz="1000" dirty="0">
                         <a:latin typeface="Arial" charset="0"/>
                         <a:ea typeface="Arial" charset="0"/>
                         <a:cs typeface="Arial" charset="0"/>
@@ -9627,7 +9512,7 @@
                         <a:buNone/>
                       </a:pPr>
                       <a:r>
-                        <a:rPr lang="en-US" sz="1050" dirty="0">
+                        <a:rPr lang="en-US" sz="1000" dirty="0">
                           <a:solidFill>
                             <a:srgbClr val="1F1235"/>
                           </a:solidFill>
@@ -9635,9 +9520,9 @@
                           <a:ea typeface="Arial" pitchFamily="34" charset="-122"/>
                           <a:cs typeface="Arial" pitchFamily="34" charset="-120"/>
                         </a:rPr>
-                        <a:t>Ligar para os clientes com parcela vencida há mais de 30 dias</a:t>
+                        <a:t>Ligar para os clientes com parcela vencida há mais de 30 dias e registrar o plano por escrito</a:t>
                       </a:r>
-                      <a:endParaRPr lang="en-US" sz="1050" dirty="0">
+                      <a:endParaRPr lang="en-US" sz="1000" dirty="0">
                         <a:latin typeface="Arial" charset="0"/>
                         <a:ea typeface="Arial" charset="0"/>
                         <a:cs typeface="Arial" charset="0"/>
@@ -9695,7 +9580,7 @@
                         <a:buNone/>
                       </a:pPr>
                       <a:r>
-                        <a:rPr lang="en-US" sz="1050" dirty="0">
+                        <a:rPr lang="en-US" sz="1000" dirty="0">
                           <a:solidFill>
                             <a:srgbClr val="1F1235"/>
                           </a:solidFill>
@@ -9705,7 +9590,7 @@
                         </a:rPr>
                         <a:t>Marina e Rafael</a:t>
                       </a:r>
-                      <a:endParaRPr lang="en-US" sz="1050" dirty="0">
+                      <a:endParaRPr lang="en-US" sz="1000" dirty="0">
                         <a:latin typeface="Arial" charset="0"/>
                         <a:ea typeface="Arial" charset="0"/>
                         <a:cs typeface="Arial" charset="0"/>
@@ -9763,7 +9648,7 @@
                         <a:buNone/>
                       </a:pPr>
                       <a:r>
-                        <a:rPr lang="en-US" sz="1050" dirty="0">
+                        <a:rPr lang="en-US" sz="1000" dirty="0">
                           <a:solidFill>
                             <a:srgbClr val="1F1235"/>
                           </a:solidFill>
@@ -9771,9 +9656,9 @@
                           <a:ea typeface="Arial" pitchFamily="34" charset="-122"/>
                           <a:cs typeface="Arial" pitchFamily="34" charset="-120"/>
                         </a:rPr>
-                        <a:t>16/10/2026</a:t>
+                        <a:t>25/09/2026</a:t>
                       </a:r>
-                      <a:endParaRPr lang="en-US" sz="1050" dirty="0">
+                      <a:endParaRPr lang="en-US" sz="1000" dirty="0">
                         <a:latin typeface="Arial" charset="0"/>
                         <a:ea typeface="Arial" charset="0"/>
                         <a:cs typeface="Arial" charset="0"/>
@@ -9833,7 +9718,7 @@
                         <a:buNone/>
                       </a:pPr>
                       <a:r>
-                        <a:rPr lang="en-US" sz="1050" dirty="0">
+                        <a:rPr lang="en-US" sz="1000" dirty="0">
                           <a:solidFill>
                             <a:srgbClr val="1F1235"/>
                           </a:solidFill>
@@ -9841,9 +9726,9 @@
                           <a:ea typeface="Arial" pitchFamily="34" charset="-122"/>
                           <a:cs typeface="Arial" pitchFamily="34" charset="-120"/>
                         </a:rPr>
-                        <a:t>Revisar honorário dos 12 casos acima das horas estimadas (planilhas 16 e 06)</a:t>
+                        <a:t>Revisar o honorário dos 2 casos acima das horas estimadas (planilhas 16 e 06)</a:t>
                       </a:r>
-                      <a:endParaRPr lang="en-US" sz="1050" dirty="0">
+                      <a:endParaRPr lang="en-US" sz="1000" dirty="0">
                         <a:latin typeface="Arial" charset="0"/>
                         <a:ea typeface="Arial" charset="0"/>
                         <a:cs typeface="Arial" charset="0"/>
@@ -9901,7 +9786,7 @@
                         <a:buNone/>
                       </a:pPr>
                       <a:r>
-                        <a:rPr lang="en-US" sz="1050" dirty="0">
+                        <a:rPr lang="en-US" sz="1000" dirty="0">
                           <a:solidFill>
                             <a:srgbClr val="1F1235"/>
                           </a:solidFill>
@@ -9909,9 +9794,9 @@
                           <a:ea typeface="Arial" pitchFamily="34" charset="-122"/>
                           <a:cs typeface="Arial" pitchFamily="34" charset="-120"/>
                         </a:rPr>
-                        <a:t>Marina Ferraz</a:t>
+                        <a:t>Rafael (Bistrô 42) e Marina (Escola Aurora)</a:t>
                       </a:r>
-                      <a:endParaRPr lang="en-US" sz="1050" dirty="0">
+                      <a:endParaRPr lang="en-US" sz="1000" dirty="0">
                         <a:latin typeface="Arial" charset="0"/>
                         <a:ea typeface="Arial" charset="0"/>
                         <a:cs typeface="Arial" charset="0"/>
@@ -9969,7 +9854,7 @@
                         <a:buNone/>
                       </a:pPr>
                       <a:r>
-                        <a:rPr lang="en-US" sz="1050" dirty="0">
+                        <a:rPr lang="en-US" sz="1000" dirty="0">
                           <a:solidFill>
                             <a:srgbClr val="1F1235"/>
                           </a:solidFill>
@@ -9977,9 +9862,9 @@
                           <a:ea typeface="Arial" pitchFamily="34" charset="-122"/>
                           <a:cs typeface="Arial" pitchFamily="34" charset="-120"/>
                         </a:rPr>
-                        <a:t>23/10/2026</a:t>
+                        <a:t>30/09/2026</a:t>
                       </a:r>
-                      <a:endParaRPr lang="en-US" sz="1050" dirty="0">
+                      <a:endParaRPr lang="en-US" sz="1000" dirty="0">
                         <a:latin typeface="Arial" charset="0"/>
                         <a:ea typeface="Arial" charset="0"/>
                         <a:cs typeface="Arial" charset="0"/>
@@ -10039,7 +9924,7 @@
                         <a:buNone/>
                       </a:pPr>
                       <a:r>
-                        <a:rPr lang="en-US" sz="1050" dirty="0">
+                        <a:rPr lang="en-US" sz="1000" dirty="0">
                           <a:solidFill>
                             <a:srgbClr val="1F1235"/>
                           </a:solidFill>
@@ -10047,9 +9932,9 @@
                           <a:ea typeface="Arial" pitchFamily="34" charset="-122"/>
                           <a:cs typeface="Arial" pitchFamily="34" charset="-120"/>
                         </a:rPr>
-                        <a:t>Transferir R$ 4.000 para a reserva e registrar na planilha 12</a:t>
+                        <a:t>Transferir R$ 3.000 para a reserva e registrar na planilha 12</a:t>
                       </a:r>
-                      <a:endParaRPr lang="en-US" sz="1050" dirty="0">
+                      <a:endParaRPr lang="en-US" sz="1000" dirty="0">
                         <a:latin typeface="Arial" charset="0"/>
                         <a:ea typeface="Arial" charset="0"/>
                         <a:cs typeface="Arial" charset="0"/>
@@ -10107,7 +9992,7 @@
                         <a:buNone/>
                       </a:pPr>
                       <a:r>
-                        <a:rPr lang="en-US" sz="1050" dirty="0">
+                        <a:rPr lang="en-US" sz="1000" dirty="0">
                           <a:solidFill>
                             <a:srgbClr val="1F1235"/>
                           </a:solidFill>
@@ -10117,7 +10002,7 @@
                         </a:rPr>
                         <a:t>Rafael Lima</a:t>
                       </a:r>
-                      <a:endParaRPr lang="en-US" sz="1050" dirty="0">
+                      <a:endParaRPr lang="en-US" sz="1000" dirty="0">
                         <a:latin typeface="Arial" charset="0"/>
                         <a:ea typeface="Arial" charset="0"/>
                         <a:cs typeface="Arial" charset="0"/>
@@ -10175,7 +10060,7 @@
                         <a:buNone/>
                       </a:pPr>
                       <a:r>
-                        <a:rPr lang="en-US" sz="1050" dirty="0">
+                        <a:rPr lang="en-US" sz="1000" dirty="0">
                           <a:solidFill>
                             <a:srgbClr val="1F1235"/>
                           </a:solidFill>
@@ -10183,9 +10068,9 @@
                           <a:ea typeface="Arial" pitchFamily="34" charset="-122"/>
                           <a:cs typeface="Arial" pitchFamily="34" charset="-120"/>
                         </a:rPr>
-                        <a:t>28/10/2026</a:t>
+                        <a:t>28/09/2026</a:t>
                       </a:r>
-                      <a:endParaRPr lang="en-US" sz="1050" dirty="0">
+                      <a:endParaRPr lang="en-US" sz="1000" dirty="0">
                         <a:latin typeface="Arial" charset="0"/>
                         <a:ea typeface="Arial" charset="0"/>
                         <a:cs typeface="Arial" charset="0"/>
@@ -10245,7 +10130,7 @@
                         <a:buNone/>
                       </a:pPr>
                       <a:r>
-                        <a:rPr lang="en-US" sz="1050" dirty="0">
+                        <a:rPr lang="en-US" sz="1000" dirty="0">
                           <a:solidFill>
                             <a:srgbClr val="1F1235"/>
                           </a:solidFill>
@@ -10253,9 +10138,9 @@
                           <a:ea typeface="Arial" pitchFamily="34" charset="-122"/>
                           <a:cs typeface="Arial" pitchFamily="34" charset="-120"/>
                         </a:rPr>
-                        <a:t>Fechar o painel de outubro e enviar o resumo ao contador (planilha 20)</a:t>
+                        <a:t>Fechar setembro e enviar o resumo ao contador (planilhas 18 e 20)</a:t>
                       </a:r>
-                      <a:endParaRPr lang="en-US" sz="1050" dirty="0">
+                      <a:endParaRPr lang="en-US" sz="1000" dirty="0">
                         <a:latin typeface="Arial" charset="0"/>
                         <a:ea typeface="Arial" charset="0"/>
                         <a:cs typeface="Arial" charset="0"/>
@@ -10313,7 +10198,7 @@
                         <a:buNone/>
                       </a:pPr>
                       <a:r>
-                        <a:rPr lang="en-US" sz="1050" dirty="0">
+                        <a:rPr lang="en-US" sz="1000" dirty="0">
                           <a:solidFill>
                             <a:srgbClr val="1F1235"/>
                           </a:solidFill>
@@ -10323,7 +10208,7 @@
                         </a:rPr>
                         <a:t>Rafael Lima</a:t>
                       </a:r>
-                      <a:endParaRPr lang="en-US" sz="1050" dirty="0">
+                      <a:endParaRPr lang="en-US" sz="1000" dirty="0">
                         <a:latin typeface="Arial" charset="0"/>
                         <a:ea typeface="Arial" charset="0"/>
                         <a:cs typeface="Arial" charset="0"/>
@@ -10381,7 +10266,7 @@
                         <a:buNone/>
                       </a:pPr>
                       <a:r>
-                        <a:rPr lang="en-US" sz="1050" dirty="0">
+                        <a:rPr lang="en-US" sz="1000" dirty="0">
                           <a:solidFill>
                             <a:srgbClr val="1F1235"/>
                           </a:solidFill>
@@ -10389,9 +10274,9 @@
                           <a:ea typeface="Arial" pitchFamily="34" charset="-122"/>
                           <a:cs typeface="Arial" pitchFamily="34" charset="-120"/>
                         </a:rPr>
-                        <a:t>5/11/2026</a:t>
+                        <a:t>05/10/2026</a:t>
                       </a:r>
-                      <a:endParaRPr lang="en-US" sz="1050" dirty="0">
+                      <a:endParaRPr lang="en-US" sz="1000" dirty="0">
                         <a:latin typeface="Arial" charset="0"/>
                         <a:ea typeface="Arial" charset="0"/>
                         <a:cs typeface="Arial" charset="0"/>
@@ -10453,7 +10338,7 @@
         </p:nvSpPr>
         <p:spPr>
           <a:xfrm>
-            <a:off x="457200" y="4251960"/>
+            <a:off x="457200" y="4343400"/>
             <a:ext cx="8229600" cy="320040"/>
           </a:xfrm>
           <a:prstGeom prst="rect">
@@ -10478,156 +10363,11 @@
                 <a:ea typeface="Arial" pitchFamily="34" charset="-122"/>
                 <a:cs typeface="Arial" pitchFamily="34" charset="-120"/>
               </a:rPr>
-              <a:t>Próxima reunião de resultado: 6 de novembro de 2026, com o fechamento de outubro.</a:t>
+              <a:t>Próxima reunião de resultado: 5 de outubro de 2026, com o fechamento de setembro.</a:t>
             </a:r>
             <a:endParaRPr lang="en-US" sz="1100" dirty="0"/>
           </a:p>
         </p:txBody>
-      </p:sp>
-      <p:sp>
-        <p:nvSpPr>
-          <p:cNvPr id="6" name="Text 3"/>
-          <p:cNvSpPr txBox="1"/>
-          <p:nvPr/>
-        </p:nvSpPr>
-        <p:spPr>
-          <a:xfrm>
-            <a:off x="457200" y="4791456"/>
-            <a:ext cx="6858000" cy="201168"/>
-          </a:xfrm>
-          <a:prstGeom prst="rect">
-            <a:avLst/>
-          </a:prstGeom>
-          <a:noFill/>
-          <a:ln/>
-        </p:spPr>
-        <p:txBody>
-          <a:bodyPr wrap="square" lIns="0" tIns="0" rIns="0" bIns="0" rtlCol="0" anchor="ctr"/>
-          <a:lstStyle/>
-          <a:p>
-            <a:pPr indent="0" marL="0">
-              <a:buNone/>
-            </a:pPr>
-            <a:r>
-              <a:rPr lang="en-US" sz="700" dirty="0">
-                <a:solidFill>
-                  <a:srgbClr val="B89BE0"/>
-                </a:solidFill>
-                <a:latin typeface="Arial" pitchFamily="34" charset="0"/>
-                <a:ea typeface="Arial" pitchFamily="34" charset="-122"/>
-                <a:cs typeface="Arial" pitchFamily="34" charset="-120"/>
-              </a:rPr>
-              <a:t>Kit de Gestão para Advogados · modelo v1.0 · set/2026</a:t>
-            </a:r>
-            <a:endParaRPr lang="en-US" sz="700" dirty="0"/>
-          </a:p>
-        </p:txBody>
-      </p:sp>
-      <p:sp>
-        <p:nvSpPr>
-          <p:cNvPr id="7" name="Shape 4"/>
-          <p:cNvSpPr/>
-          <p:nvPr/>
-        </p:nvSpPr>
-        <p:spPr>
-          <a:xfrm>
-            <a:off x="8229600" y="4818888"/>
-            <a:ext cx="211226" cy="70409"/>
-          </a:xfrm>
-          <a:prstGeom prst="roundRect">
-            <a:avLst>
-              <a:gd name="adj" fmla="val 42857"/>
-            </a:avLst>
-          </a:prstGeom>
-          <a:solidFill>
-            <a:srgbClr val="7A5AA8"/>
-          </a:solidFill>
-          <a:ln w="12700">
-            <a:solidFill>
-              <a:srgbClr val="7A5AA8"/>
-            </a:solidFill>
-            <a:prstDash val="solid"/>
-          </a:ln>
-        </p:spPr>
-      </p:sp>
-      <p:sp>
-        <p:nvSpPr>
-          <p:cNvPr id="8" name="Shape 5"/>
-          <p:cNvSpPr/>
-          <p:nvPr/>
-        </p:nvSpPr>
-        <p:spPr>
-          <a:xfrm>
-            <a:off x="8279892" y="4728362"/>
-            <a:ext cx="211226" cy="70409"/>
-          </a:xfrm>
-          <a:prstGeom prst="roundRect">
-            <a:avLst>
-              <a:gd name="adj" fmla="val 42857"/>
-            </a:avLst>
-          </a:prstGeom>
-          <a:solidFill>
-            <a:srgbClr val="3B1F5E"/>
-          </a:solidFill>
-          <a:ln w="12700">
-            <a:solidFill>
-              <a:srgbClr val="3B1F5E"/>
-            </a:solidFill>
-            <a:prstDash val="solid"/>
-          </a:ln>
-        </p:spPr>
-      </p:sp>
-      <p:sp>
-        <p:nvSpPr>
-          <p:cNvPr id="9" name="Shape 6"/>
-          <p:cNvSpPr/>
-          <p:nvPr/>
-        </p:nvSpPr>
-        <p:spPr>
-          <a:xfrm>
-            <a:off x="8330184" y="4637837"/>
-            <a:ext cx="211226" cy="70409"/>
-          </a:xfrm>
-          <a:prstGeom prst="roundRect">
-            <a:avLst>
-              <a:gd name="adj" fmla="val 42857"/>
-            </a:avLst>
-          </a:prstGeom>
-          <a:solidFill>
-            <a:srgbClr val="3B1F5E"/>
-          </a:solidFill>
-          <a:ln w="12700">
-            <a:solidFill>
-              <a:srgbClr val="3B1F5E"/>
-            </a:solidFill>
-            <a:prstDash val="solid"/>
-          </a:ln>
-        </p:spPr>
-      </p:sp>
-      <p:sp>
-        <p:nvSpPr>
-          <p:cNvPr id="10" name="Shape 7"/>
-          <p:cNvSpPr/>
-          <p:nvPr/>
-        </p:nvSpPr>
-        <p:spPr>
-          <a:xfrm>
-            <a:off x="8541410" y="4839005"/>
-            <a:ext cx="65380" cy="65380"/>
-          </a:xfrm>
-          <a:prstGeom prst="ellipse">
-            <a:avLst/>
-          </a:prstGeom>
-          <a:solidFill>
-            <a:srgbClr val="FFC83D"/>
-          </a:solidFill>
-          <a:ln w="12700">
-            <a:solidFill>
-              <a:srgbClr val="FFC83D"/>
-            </a:solidFill>
-            <a:prstDash val="solid"/>
-          </a:ln>
-        </p:spPr>
       </p:sp>
     </p:spTree>
   </p:cSld>

</xml_diff>